<commit_message>
feat: embed genuine live demo screenshots into slide 6 (SQLi), slide 12 (XSS), and slide 17 (CSRF) for perfect visual evidence
</commit_message>
<xml_diff>
--- a/Slide_OWASP_Top3_Nhom_WNC_G01.pptx
+++ b/Slide_OWASP_Top3_Nhom_WNC_G01.pptx
@@ -4387,7 +4387,7 @@
               </a:defRPr>
             </a:pPr>
             <a:r>
-              <a:t>2.4. Stored XSS: Đối Chứng Thực Nghiệm &amp; Live Demo Trực Tiếp</a:t>
+              <a:t>2.4. Stored XSS: Minh Chứng Thực Nghiệm Trực Quan Trên Web UI</a:t>
             </a:r>
           </a:p>
         </p:txBody>
@@ -4427,16 +4427,40 @@
           </a:p>
         </p:txBody>
       </p:sp>
-      <p:sp>
-        <p:nvSpPr>
-          <p:cNvPr id="6" name="Rounded Rectangle 5"/>
+      <p:pic>
+        <p:nvPicPr>
+          <p:cNvPr id="6" name="Picture 5" descr="crop_xss_ui.png"/>
+          <p:cNvPicPr>
+            <a:picLocks noChangeAspect="1"/>
+          </p:cNvPicPr>
+          <p:nvPr/>
+        </p:nvPicPr>
+        <p:blipFill>
+          <a:blip r:embed="rId2"/>
+          <a:stretch>
+            <a:fillRect/>
+          </a:stretch>
+        </p:blipFill>
+        <p:spPr>
+          <a:xfrm>
+            <a:off x="1645920" y="1234440"/>
+            <a:ext cx="8869680" cy="3752557"/>
+          </a:xfrm>
+          <a:prstGeom prst="rect">
+            <a:avLst/>
+          </a:prstGeom>
+        </p:spPr>
+      </p:pic>
+      <p:sp>
+        <p:nvSpPr>
+          <p:cNvPr id="7" name="Rounded Rectangle 6"/>
           <p:cNvSpPr/>
           <p:nvPr/>
         </p:nvSpPr>
         <p:spPr>
           <a:xfrm>
-            <a:off x="731520" y="1280160"/>
-            <a:ext cx="5166360" cy="3840480"/>
+            <a:off x="731520" y="5440680"/>
+            <a:ext cx="10728655" cy="914400"/>
           </a:xfrm>
           <a:prstGeom prst="roundRect">
             <a:avLst/>
@@ -4465,212 +4489,18 @@
           </a:fontRef>
         </p:style>
         <p:txBody>
-          <a:bodyPr rtlCol="0" anchor="ctr" wrap="square"/>
+          <a:bodyPr rtlCol="0" anchor="ctr"/>
           <a:lstStyle/>
           <a:p>
             <a:pPr algn="ctr">
-              <a:defRPr sz="1400" b="1">
+              <a:defRPr sz="1200" b="1">
                 <a:solidFill>
                   <a:srgbClr val="BE123C"/>
                 </a:solidFill>
               </a:defRPr>
             </a:pPr>
             <a:r>
-              <a:t>❌ 1. NHÁNH BỊ LỖI (Dùng @@Html.Raw)</a:t>
-            </a:r>
-          </a:p>
-          <a:p>
-            <a:pPr>
-              <a:spcBef>
-                <a:spcPts val="800"/>
-              </a:spcBef>
-              <a:defRPr sz="1200">
-                <a:solidFill>
-                  <a:srgbClr val="334155"/>
-                </a:solidFill>
-              </a:defRPr>
-            </a:pPr>
-            <a:r>
-              <a:t>• Input khai thác: &lt;script&gt;alert(document.cookie);&lt;/script&gt;</a:t>
-            </a:r>
-            <a:br/>
-            <a:r>
-              <a:t>• Cách render:</a:t>
-            </a:r>
-            <a:br/>
-            <a:r>
-              <a:t>  @Html.Raw(comment.Content)</a:t>
-            </a:r>
-            <a:br/>
-            <a:r>
-              <a:t>• Cơ chế:</a:t>
-            </a:r>
-            <a:br/>
-            <a:r>
-              <a:t>  - Trình duyệt coi đoạn chuỗi là mã lệnh JavaScript thực thi được.</a:t>
-            </a:r>
-            <a:br/>
-            <a:r>
-              <a:t>• Hậu quả thực tế:</a:t>
-            </a:r>
-            <a:br/>
-            <a:r>
-              <a:t>  - Bật popup alert hiển thị Cookie nhạy cảm AuthSessionToken.</a:t>
-            </a:r>
-            <a:br/>
-            <a:r>
-              <a:t>  - Bất kỳ ai vào xem đánh giá chuyên gia đều bị mã độc tấn công.</a:t>
-            </a:r>
-          </a:p>
-        </p:txBody>
-      </p:sp>
-      <p:sp>
-        <p:nvSpPr>
-          <p:cNvPr id="7" name="Rounded Rectangle 6"/>
-          <p:cNvSpPr/>
-          <p:nvPr/>
-        </p:nvSpPr>
-        <p:spPr>
-          <a:xfrm>
-            <a:off x="6263640" y="1280160"/>
-            <a:ext cx="5166360" cy="3840480"/>
-          </a:xfrm>
-          <a:prstGeom prst="roundRect">
-            <a:avLst/>
-          </a:prstGeom>
-          <a:solidFill>
-            <a:srgbClr val="ECFDF5"/>
-          </a:solidFill>
-          <a:ln>
-            <a:solidFill>
-              <a:srgbClr val="A7F3D0"/>
-            </a:solidFill>
-          </a:ln>
-        </p:spPr>
-        <p:style>
-          <a:lnRef idx="1">
-            <a:schemeClr val="accent1"/>
-          </a:lnRef>
-          <a:fillRef idx="3">
-            <a:schemeClr val="accent1"/>
-          </a:fillRef>
-          <a:effectRef idx="2">
-            <a:schemeClr val="accent1"/>
-          </a:effectRef>
-          <a:fontRef idx="minor">
-            <a:schemeClr val="lt1"/>
-          </a:fontRef>
-        </p:style>
-        <p:txBody>
-          <a:bodyPr rtlCol="0" anchor="ctr" wrap="square"/>
-          <a:lstStyle/>
-          <a:p>
-            <a:pPr algn="ctr">
-              <a:defRPr sz="1400" b="1">
-                <a:solidFill>
-                  <a:srgbClr val="047857"/>
-                </a:solidFill>
-              </a:defRPr>
-            </a:pPr>
-            <a:r>
-              <a:t>✅ 2. NHÁNH AN TOÀN (Tự Động HTML Encoding)</a:t>
-            </a:r>
-          </a:p>
-          <a:p>
-            <a:pPr>
-              <a:spcBef>
-                <a:spcPts val="800"/>
-              </a:spcBef>
-              <a:defRPr sz="1200">
-                <a:solidFill>
-                  <a:srgbClr val="334155"/>
-                </a:solidFill>
-              </a:defRPr>
-            </a:pPr>
-            <a:r>
-              <a:t>• Cùng Input khai thác: &lt;script&gt;alert(document.cookie);&lt;/script&gt;</a:t>
-            </a:r>
-            <a:br/>
-            <a:r>
-              <a:t>• Cách render chuẩn:</a:t>
-            </a:r>
-            <a:br/>
-            <a:r>
-              <a:t>  @comment.Content (hoặc HtmlEncoder.Default.Encode)</a:t>
-            </a:r>
-            <a:br/>
-            <a:r>
-              <a:t>• Cơ chế:</a:t>
-            </a:r>
-            <a:br/>
-            <a:r>
-              <a:t>  - Các ký tự &lt;, &gt; được chuyển đổi thành &amp;lt;, &amp;gt;.</a:t>
-            </a:r>
-            <a:br/>
-            <a:r>
-              <a:t>• Kết quả phòng thủ:</a:t>
-            </a:r>
-            <a:br/>
-            <a:r>
-              <a:t>  - Trình duyệt chỉ in chuỗi text ra màn hình như chữ bình thường.</a:t>
-            </a:r>
-            <a:br/>
-            <a:r>
-              <a:t>  - Tuyệt đối không có bất kỳ popup hay script nào được kích hoạt.</a:t>
-            </a:r>
-          </a:p>
-        </p:txBody>
-      </p:sp>
-      <p:sp>
-        <p:nvSpPr>
-          <p:cNvPr id="8" name="Rounded Rectangle 7"/>
-          <p:cNvSpPr/>
-          <p:nvPr/>
-        </p:nvSpPr>
-        <p:spPr>
-          <a:xfrm>
-            <a:off x="731520" y="5303520"/>
-            <a:ext cx="10728655" cy="868680"/>
-          </a:xfrm>
-          <a:prstGeom prst="roundRect">
-            <a:avLst/>
-          </a:prstGeom>
-          <a:solidFill>
-            <a:srgbClr val="FFF1F2"/>
-          </a:solidFill>
-          <a:ln>
-            <a:solidFill>
-              <a:srgbClr val="FECDD3"/>
-            </a:solidFill>
-          </a:ln>
-        </p:spPr>
-        <p:style>
-          <a:lnRef idx="1">
-            <a:schemeClr val="accent1"/>
-          </a:lnRef>
-          <a:fillRef idx="3">
-            <a:schemeClr val="accent1"/>
-          </a:fillRef>
-          <a:effectRef idx="2">
-            <a:schemeClr val="accent1"/>
-          </a:effectRef>
-          <a:fontRef idx="minor">
-            <a:schemeClr val="lt1"/>
-          </a:fontRef>
-        </p:style>
-        <p:txBody>
-          <a:bodyPr rtlCol="0" anchor="ctr"/>
-          <a:lstStyle/>
-          <a:p>
-            <a:pPr algn="ctr">
-              <a:defRPr sz="1250" b="1">
-                <a:solidFill>
-                  <a:srgbClr val="BE123C"/>
-                </a:solidFill>
-              </a:defRPr>
-            </a:pPr>
-            <a:r>
-              <a:t>💬 [BÌNH LIVE DEMO]: Chuyển sang Web UI Tab 2 (Stored XSS - /Xss)</a:t>
+              <a:t>💬 [BÌNH LIVE DEMO]: Giao diện chức năng Đánh giá chuyên gia dính lỗi XSS (/Xss)</a:t>
             </a:r>
           </a:p>
           <a:p>
@@ -4685,7 +4515,11 @@
               </a:defRPr>
             </a:pPr>
             <a:r>
-              <a:t>Thao tác: Bấm nạp payload đánh cắp Cookie -&gt; Đăng bên Lỗi (bật popup alert lộ Session) -&gt; Đăng bên An toàn (chữ hiển thị an toàn).</a:t>
+              <a:t>• Bên Trái (Lỗi): Đăng nội dung chứa &lt;script&gt;alert(document.cookie)&lt;/script&gt; -&gt; Trình duyệt nạn nhân tự động thực thi script.</a:t>
+            </a:r>
+            <a:br/>
+            <a:r>
+              <a:t>• Bên Phải (Đã Vá): Dùng Razor HTML Encoding -&gt; Chuyển đổi &lt;script&gt; thành &amp;lt;script&amp;gt;, hiển thị văn bản an toàn 100%.</a:t>
             </a:r>
           </a:p>
         </p:txBody>
@@ -10073,7 +9907,7 @@
               </a:defRPr>
             </a:pPr>
             <a:r>
-              <a:t>1.4. SQL Injection: Đối Chứng Thực Nghiệm Trực Quan Trên Web UI</a:t>
+              <a:t>1.4. SQL Injection: Minh Chứng Thực Nghiệm Trực Quan Trên Web UI</a:t>
             </a:r>
           </a:p>
         </p:txBody>
@@ -10113,103 +9947,30 @@
           </a:p>
         </p:txBody>
       </p:sp>
-      <p:sp>
-        <p:nvSpPr>
-          <p:cNvPr id="6" name="Rounded Rectangle 5"/>
-          <p:cNvSpPr/>
-          <p:nvPr/>
-        </p:nvSpPr>
-        <p:spPr>
-          <a:xfrm>
-            <a:off x="731520" y="1280160"/>
-            <a:ext cx="5166360" cy="3840480"/>
-          </a:xfrm>
-          <a:prstGeom prst="roundRect">
-            <a:avLst/>
-          </a:prstGeom>
-          <a:solidFill>
-            <a:srgbClr val="FFF1F2"/>
-          </a:solidFill>
-          <a:ln>
-            <a:solidFill>
-              <a:srgbClr val="FECDD3"/>
-            </a:solidFill>
-          </a:ln>
-        </p:spPr>
-        <p:style>
-          <a:lnRef idx="1">
-            <a:schemeClr val="accent1"/>
-          </a:lnRef>
-          <a:fillRef idx="3">
-            <a:schemeClr val="accent1"/>
-          </a:fillRef>
-          <a:effectRef idx="2">
-            <a:schemeClr val="accent1"/>
-          </a:effectRef>
-          <a:fontRef idx="minor">
-            <a:schemeClr val="lt1"/>
-          </a:fontRef>
-        </p:style>
-        <p:txBody>
-          <a:bodyPr rtlCol="0" anchor="ctr" wrap="square"/>
-          <a:lstStyle/>
-          <a:p>
-            <a:pPr algn="ctr">
-              <a:defRPr sz="1400" b="1">
-                <a:solidFill>
-                  <a:srgbClr val="BE123C"/>
-                </a:solidFill>
-              </a:defRPr>
-            </a:pPr>
-            <a:r>
-              <a:t>❌ 1. NHÁNH BỊ LỖI (Nối Chuỗi SQL Thuần)</a:t>
-            </a:r>
-          </a:p>
-          <a:p>
-            <a:pPr>
-              <a:spcBef>
-                <a:spcPts val="800"/>
-              </a:spcBef>
-              <a:defRPr sz="1200">
-                <a:solidFill>
-                  <a:srgbClr val="334155"/>
-                </a:solidFill>
-              </a:defRPr>
-            </a:pPr>
-            <a:r>
-              <a:t>• Input khai thác: ' OR '1'='1' --</a:t>
-            </a:r>
-            <a:br/>
-            <a:r>
-              <a:t>• Câu lệnh thực thi:</a:t>
-            </a:r>
-            <a:br/>
-            <a:r>
-              <a:t>  SELECT * FROM Accounts WHERE Username = '' OR '1'='1' --'</a:t>
-            </a:r>
-            <a:br/>
-            <a:r>
-              <a:t>• Cơ chế thông dịch: Mệnh đề WHERE luôn TRUE.</a:t>
-            </a:r>
-            <a:br/>
-            <a:r>
-              <a:t>• Hậu quả thực tế:</a:t>
-            </a:r>
-            <a:br/>
-            <a:r>
-              <a:t>  - Đăng nhập thành công mà KHÔNG CẦN mật khẩu.</a:t>
-            </a:r>
-            <a:br/>
-            <a:r>
-              <a:t>  - Rò rỉ toàn bộ 4 tài khoản CSDL (Admin, Chuyên gia, Khách hàng).</a:t>
-            </a:r>
-            <a:br/>
-            <a:r>
-              <a:t>  - Lộ mật khẩu gốc và số dư tài khoản ngân hàng.</a:t>
-            </a:r>
-          </a:p>
-        </p:txBody>
-      </p:sp>
+      <p:pic>
+        <p:nvPicPr>
+          <p:cNvPr id="6" name="Picture 5" descr="only_cards.png"/>
+          <p:cNvPicPr>
+            <a:picLocks noChangeAspect="1"/>
+          </p:cNvPicPr>
+          <p:nvPr/>
+        </p:nvPicPr>
+        <p:blipFill>
+          <a:blip r:embed="rId2"/>
+          <a:stretch>
+            <a:fillRect/>
+          </a:stretch>
+        </p:blipFill>
+        <p:spPr>
+          <a:xfrm>
+            <a:off x="1645920" y="1234440"/>
+            <a:ext cx="8869680" cy="4739035"/>
+          </a:xfrm>
+          <a:prstGeom prst="rect">
+            <a:avLst/>
+          </a:prstGeom>
+        </p:spPr>
+      </p:pic>
       <p:sp>
         <p:nvSpPr>
           <p:cNvPr id="7" name="Rounded Rectangle 6"/>
@@ -10218,109 +9979,8 @@
         </p:nvSpPr>
         <p:spPr>
           <a:xfrm>
-            <a:off x="6263640" y="1280160"/>
-            <a:ext cx="5166360" cy="3840480"/>
-          </a:xfrm>
-          <a:prstGeom prst="roundRect">
-            <a:avLst/>
-          </a:prstGeom>
-          <a:solidFill>
-            <a:srgbClr val="ECFDF5"/>
-          </a:solidFill>
-          <a:ln>
-            <a:solidFill>
-              <a:srgbClr val="A7F3D0"/>
-            </a:solidFill>
-          </a:ln>
-        </p:spPr>
-        <p:style>
-          <a:lnRef idx="1">
-            <a:schemeClr val="accent1"/>
-          </a:lnRef>
-          <a:fillRef idx="3">
-            <a:schemeClr val="accent1"/>
-          </a:fillRef>
-          <a:effectRef idx="2">
-            <a:schemeClr val="accent1"/>
-          </a:effectRef>
-          <a:fontRef idx="minor">
-            <a:schemeClr val="lt1"/>
-          </a:fontRef>
-        </p:style>
-        <p:txBody>
-          <a:bodyPr rtlCol="0" anchor="ctr" wrap="square"/>
-          <a:lstStyle/>
-          <a:p>
-            <a:pPr algn="ctr">
-              <a:defRPr sz="1400" b="1">
-                <a:solidFill>
-                  <a:srgbClr val="047857"/>
-                </a:solidFill>
-              </a:defRPr>
-            </a:pPr>
-            <a:r>
-              <a:t>✅ 2. NHÁNH AN TOÀN (EF Core Parameterized)</a:t>
-            </a:r>
-          </a:p>
-          <a:p>
-            <a:pPr>
-              <a:spcBef>
-                <a:spcPts val="800"/>
-              </a:spcBef>
-              <a:defRPr sz="1200">
-                <a:solidFill>
-                  <a:srgbClr val="334155"/>
-                </a:solidFill>
-              </a:defRPr>
-            </a:pPr>
-            <a:r>
-              <a:t>• Cùng Input khai thác: ' OR '1'='1' --</a:t>
-            </a:r>
-            <a:br/>
-            <a:r>
-              <a:t>• Câu lệnh thực thi:</a:t>
-            </a:r>
-            <a:br/>
-            <a:r>
-              <a:t>  SELECT * FROM Accounts WHERE Username = @p0 AND Pass = @p1</a:t>
-            </a:r>
-            <a:br/>
-            <a:r>
-              <a:t>• Cơ chế thông dịch:</a:t>
-            </a:r>
-            <a:br/>
-            <a:r>
-              <a:t>  - CSDL biên dịch cây truy vấn (Execution Plan) TRƯỚC.</a:t>
-            </a:r>
-            <a:br/>
-            <a:r>
-              <a:t>  - Toàn bộ chuỗi payload được xem là văn bản (String Literal) thuần túy.</a:t>
-            </a:r>
-            <a:br/>
-            <a:r>
-              <a:t>• Kết quả phòng thủ:</a:t>
-            </a:r>
-            <a:br/>
-            <a:r>
-              <a:t>  - Hệ thống chặn đứng, trả về 0 bản ghi.</a:t>
-            </a:r>
-            <a:br/>
-            <a:r>
-              <a:t>  - Báo 'Sai tài khoản/mật khẩu', bảo vệ an toàn 100%.</a:t>
-            </a:r>
-          </a:p>
-        </p:txBody>
-      </p:sp>
-      <p:sp>
-        <p:nvSpPr>
-          <p:cNvPr id="8" name="Rounded Rectangle 7"/>
-          <p:cNvSpPr/>
-          <p:nvPr/>
-        </p:nvSpPr>
-        <p:spPr>
-          <a:xfrm>
-            <a:off x="731520" y="5303520"/>
-            <a:ext cx="10728655" cy="868680"/>
+            <a:off x="731520" y="5532120"/>
+            <a:ext cx="10728655" cy="822960"/>
           </a:xfrm>
           <a:prstGeom prst="roundRect">
             <a:avLst/>
@@ -10353,14 +10013,14 @@
           <a:lstStyle/>
           <a:p>
             <a:pPr algn="ctr">
-              <a:defRPr sz="1250" b="1">
+              <a:defRPr sz="1200" b="1">
                 <a:solidFill>
                   <a:srgbClr val="1D4ED8"/>
                 </a:solidFill>
               </a:defRPr>
             </a:pPr>
             <a:r>
-              <a:t>💻 [HỌC LIVE DEMO]: Chuyển sang Web UI Tab 1 (http://localhost:5076/SqlInjection)</a:t>
+              <a:t>💻 [HỌC LIVE DEMO]: Giao diện đối chứng thực tế trên Web UI (http://localhost:5076/SqlInjection)</a:t>
             </a:r>
           </a:p>
           <a:p>
@@ -10375,7 +10035,11 @@
               </a:defRPr>
             </a:pPr>
             <a:r>
-              <a:t>Thao tác: Bấm nạp payload ' OR '1'='1' -- -&gt; Submit bên Đỏ (rò rỉ toàn bộ CSDL) -&gt; Submit bên Xanh (chặn đứng an toàn).</a:t>
+              <a:t>• Bên Trái (Vulnerable): Bắn payload ' OR '1'='1' -- -&gt; Bypass đăng nhập, trích xuất toàn bộ mật khẩu và số dư CSDL.</a:t>
+            </a:r>
+            <a:br/>
+            <a:r>
+              <a:t>• Bên Phải (Secure): Cùng payload đưa sang EF Core LINQ -&gt; Chặn đứng hoàn toàn, bảo vệ an toàn 100%.</a:t>
             </a:r>
           </a:p>
         </p:txBody>

</xml_diff>

<commit_message>
refactor: polish presentation typography and academic phrasing, removing colloquialisms and redundancy
</commit_message>
<xml_diff>
--- a/Slide_OWASP_Top3_Nhom_WNC_G01.pptx
+++ b/Slide_OWASP_Top3_Nhom_WNC_G01.pptx
@@ -3229,7 +3229,7 @@
           <a:lstStyle/>
           <a:p>
             <a:pPr>
-              <a:defRPr sz="1600" b="1">
+              <a:defRPr sz="1500" b="1">
                 <a:solidFill>
                   <a:srgbClr val="BE123C"/>
                 </a:solidFill>
@@ -3244,14 +3244,14 @@
               <a:spcBef>
                 <a:spcPts val="800"/>
               </a:spcBef>
-              <a:defRPr sz="3000" b="1">
+              <a:defRPr sz="2800" b="1">
                 <a:solidFill>
                   <a:srgbClr val="0F172A"/>
                 </a:solidFill>
               </a:defRPr>
             </a:pPr>
             <a:r>
-              <a:t>Bộ 3 Lỗ Hổng Kinh Điển &amp; Cơ Chế Phòng Thủ</a:t>
+              <a:t>Nghiên Cứu Thực Nghiệm Lỗ Hổng Web &amp; Cơ Chế Phòng Thủ</a:t>
             </a:r>
             <a:br/>
             <a:r>
@@ -3263,14 +3263,14 @@
               <a:spcBef>
                 <a:spcPts val="800"/>
               </a:spcBef>
-              <a:defRPr sz="1400">
+              <a:defRPr sz="1350">
                 <a:solidFill>
                   <a:srgbClr val="334155"/>
                 </a:solidFill>
               </a:defRPr>
             </a:pPr>
             <a:r>
-              <a:t>Môn học: Lập trình Web nâng cao  •  Giảng viên hướng dẫn: ThS. Lê Hữu Dũng</a:t>
+              <a:t>Học phần: Lập trình Web nâng cao  •  Giảng viên hướng dẫn: ThS. Lê Hữu Dũng</a:t>
             </a:r>
           </a:p>
         </p:txBody>
@@ -3347,7 +3347,7 @@
             </a:r>
             <a:br/>
             <a:r>
-              <a:t>Trưởng nhóm • Demo CSDL &amp; API</a:t>
+              <a:t>Trưởng nhóm • Phụ trách CSDL &amp; API</a:t>
             </a:r>
           </a:p>
         </p:txBody>
@@ -3424,7 +3424,7 @@
             </a:r>
             <a:br/>
             <a:r>
-              <a:t>Thành viên • Demo Cookie &amp; DOM</a:t>
+              <a:t>Thành viên • Phụ trách Cookie &amp; DOM</a:t>
             </a:r>
           </a:p>
         </p:txBody>
@@ -3501,7 +3501,7 @@
             </a:r>
             <a:br/>
             <a:r>
-              <a:t>Thành viên • Demo Form ẩn giả mạo</a:t>
+              <a:t>Thành viên • Phụ trách Giao dịch &amp; Token</a:t>
             </a:r>
           </a:p>
         </p:txBody>
@@ -3651,7 +3651,7 @@
               </a:defRPr>
             </a:pPr>
             <a:r>
-              <a:t>2.2. Stored XSS: Phân Loại Chuẩn &amp; Mối Đe Dọa Nghiêm Trọng</a:t>
+              <a:t>2.2. Stored XSS: Đánh Giá Rủi Ro &amp; Tác Động Phía Trình Duyệt</a:t>
             </a:r>
           </a:p>
         </p:txBody>
@@ -3686,7 +3686,7 @@
               </a:defRPr>
             </a:pPr>
             <a:r>
-              <a:t>Nhóm WNC.G01 (Học - Bình - Cường) • Khoa CNTT - Đại học Mở Hà Nội • GVHD: ThS. Lê Hữu Dũng</a:t>
+              <a:t>Nhóm WNC.G01 • Trường Đại học Mở Hà Nội (HOU) • Giảng viên: ThS. Lê Hữu Dũng</a:t>
             </a:r>
           </a:p>
         </p:txBody>
@@ -3740,11 +3740,11 @@
               </a:defRPr>
             </a:pPr>
             <a:r>
-              <a:t>🍪 ĐÁNH CẮP SESSION COOKIE</a:t>
-            </a:r>
-            <a:br/>
-            <a:r>
-              <a:t>(Cookie Stealing)</a:t>
+              <a:t>ĐÁNH CẮP COOKIE &amp; PHIÊN</a:t>
+            </a:r>
+            <a:br/>
+            <a:r>
+              <a:t>(Session Hijacking)</a:t>
             </a:r>
           </a:p>
           <a:p>
@@ -3759,15 +3759,15 @@
               </a:defRPr>
             </a:pPr>
             <a:r>
-              <a:t>• Mã độc truy cập document.cookie để trích xuất Session Token của nạn nhân.</a:t>
-            </a:r>
-            <a:br/>
-            <a:r>
-              <a:t>• Tự động gửi token về máy chủ của hacker.</a:t>
-            </a:r>
-            <a:br/>
-            <a:r>
-              <a:t>• Hacker giả mạo danh tính nạn nhân (Session Hijacking) đăng nhập vào tài khoản mà không cần mật khẩu.</a:t>
+              <a:t>• Đoạn script đọc thuộc tính document.cookie để trích xuất token phiên làm việc.</a:t>
+            </a:r>
+            <a:br/>
+            <a:r>
+              <a:t>• Dữ liệu xác thực được gửi ngầm về máy chủ điều khiển của kẻ tấn công.</a:t>
+            </a:r>
+            <a:br/>
+            <a:r>
+              <a:t>• Kẻ tấn công sử dụng token để mạo danh người dùng hợp lệ.</a:t>
             </a:r>
           </a:p>
         </p:txBody>
@@ -3821,11 +3821,11 @@
               </a:defRPr>
             </a:pPr>
             <a:r>
-              <a:t>🎣 THAY ĐỔI GIAO DIỆN / LỪA ĐẢO</a:t>
-            </a:r>
-            <a:br/>
-            <a:r>
-              <a:t>(DOM Defacement &amp; Phishing)</a:t>
+              <a:t>THAY ĐỔI CẤU TRÚC DOM</a:t>
+            </a:r>
+            <a:br/>
+            <a:r>
+              <a:t>(DOM Manipulation / Phishing)</a:t>
             </a:r>
           </a:p>
           <a:p>
@@ -3840,15 +3840,15 @@
               </a:defRPr>
             </a:pPr>
             <a:r>
-              <a:t>• Hacker dùng JavaScript chèn form đăng nhập giả mạo đè lên giao diện website thật.</a:t>
-            </a:r>
-            <a:br/>
-            <a:r>
-              <a:t>• Lừa người dùng nhập lại tài khoản ngân hàng hoặc mật khẩu.</a:t>
-            </a:r>
-            <a:br/>
-            <a:r>
-              <a:t>• Chuyển hướng người dùng sang trang web lừa đảo (Open Redirect).</a:t>
+              <a:t>• Thay đổi cấu trúc giao diện trang web, chèn các form đăng nhập giả mạo.</a:t>
+            </a:r>
+            <a:br/>
+            <a:r>
+              <a:t>• Lừa người dùng nhập thông tin nhạy cảm trên giao diện đã bị sửa đổi.</a:t>
+            </a:r>
+            <a:br/>
+            <a:r>
+              <a:t>• Tự động điều hướng người dùng sang các liên kết độc hại.</a:t>
             </a:r>
           </a:p>
         </p:txBody>
@@ -3902,11 +3902,11 @@
               </a:defRPr>
             </a:pPr>
             <a:r>
-              <a:t>🤖 THAO TÁC NGẦM &amp; KEYLOGGER</a:t>
-            </a:r>
-            <a:br/>
-            <a:r>
-              <a:t>(Client-Side Hijacking)</a:t>
+              <a:t>THỰC THI THAO TÁC TRÁI PHÉP</a:t>
+            </a:r>
+            <a:br/>
+            <a:r>
+              <a:t>(Client-Side Exploitation)</a:t>
             </a:r>
           </a:p>
           <a:p>
@@ -3921,15 +3921,15 @@
               </a:defRPr>
             </a:pPr>
             <a:r>
-              <a:t>• Lắng nghe sự kiện bàn phím của nạn nhân (Keylogging) khi họ chat với chuyên gia.</a:t>
-            </a:r>
-            <a:br/>
-            <a:r>
-              <a:t>• Tự động gửi tin nhắn hoặc đánh giá 5 sao giả mạo danh nghĩa của người dùng.</a:t>
-            </a:r>
-            <a:br/>
-            <a:r>
-              <a:t>• Biến trình duyệt nạn nhân thành botnet tấn công từ chối dịch vụ.</a:t>
+              <a:t>• Ghi nhận thao tác bàn phím (Keylogging) khi người dùng nhập liệu.</a:t>
+            </a:r>
+            <a:br/>
+            <a:r>
+              <a:t>• Tự động thực hiện các hành động gửi tin nhắn hoặc đánh giá mạo danh người dùng.</a:t>
+            </a:r>
+            <a:br/>
+            <a:r>
+              <a:t>• Tận dụng quyền truy cập trình duyệt để mở rộng phạm vi tấn công.</a:t>
             </a:r>
           </a:p>
         </p:txBody>
@@ -4079,7 +4079,7 @@
               </a:defRPr>
             </a:pPr>
             <a:r>
-              <a:t>2.3. Stored XSS: Phân Tích Các Kỹ Thuật Đưa Payload Vào CSDL</a:t>
+              <a:t>2.3. Stored XSS: Phân Tích Kỹ Thuật Đưa Payload Vào CSDL</a:t>
             </a:r>
           </a:p>
         </p:txBody>
@@ -4114,7 +4114,7 @@
               </a:defRPr>
             </a:pPr>
             <a:r>
-              <a:t>Nhóm WNC.G01 (Học - Bình - Cường) • Khoa CNTT - Đại học Mở Hà Nội • GVHD: ThS. Lê Hữu Dũng</a:t>
+              <a:t>Nhóm WNC.G01 • Trường Đại học Mở Hà Nội (HOU) • Giảng viên: ThS. Lê Hữu Dũng</a:t>
             </a:r>
           </a:p>
         </p:txBody>
@@ -4168,7 +4168,7 @@
               </a:defRPr>
             </a:pPr>
             <a:r>
-              <a:t>3 Biến Thể Payload XSS Thực Nghiệm Trong Ứng Dụng</a:t>
+              <a:t>3 Biến Thể Payload XSS Thực Nghiệm Trong Hệ Thống</a:t>
             </a:r>
           </a:p>
           <a:p>
@@ -4183,15 +4183,15 @@
               </a:defRPr>
             </a:pPr>
             <a:r>
-              <a:t>1. Payload 1 (Thẻ Script Truyền Thống):</a:t>
-            </a:r>
-            <a:br/>
-            <a:r>
-              <a:t>   &lt;script&gt;alert('🚨 BỊ HACK XSS! Lộ Session Cookie: ' + document.cookie);&lt;/script&gt;</a:t>
-            </a:r>
-            <a:br/>
-            <a:r>
-              <a:t>   Cơ chế: Trình duyệt gặp thẻ &lt;script&gt; sẽ tạm dừng render HTML và thực thi mã JavaScript ngay lập tức.</a:t>
+              <a:t>1. Payload 1 (Thẻ Script Cơ Bản):</a:t>
+            </a:r>
+            <a:br/>
+            <a:r>
+              <a:t>   &lt;script&gt;alert('Session Cookie: ' + document.cookie);&lt;/script&gt;</a:t>
+            </a:r>
+            <a:br/>
+            <a:r>
+              <a:t>   Cơ chế: Trình duyệt phân tích cú pháp HTML, nhận diện khối mã và thực thi câu lệnh JavaScript.</a:t>
             </a:r>
           </a:p>
           <a:p>
@@ -4206,15 +4206,15 @@
               </a:defRPr>
             </a:pPr>
             <a:r>
-              <a:t>2. Payload 2 (Bypass Bộ Lọc Qua Thẻ Ảnh - Event Handler):</a:t>
-            </a:r>
-            <a:br/>
-            <a:r>
-              <a:t>   &lt;img src=x onerror=alert('🚨 XSS kích hoạt qua thẻ IMG onerror!')&gt;</a:t>
-            </a:r>
-            <a:br/>
-            <a:r>
-              <a:t>   Cơ chế: Hacker qua mặt các bộ lọc từ khóa '&lt;script&gt;' bằng cách dùng thuộc tính sự kiện 'onerror' của thẻ &lt;img&gt; khi đường dẫn ảnh bị lỗi (src=x).</a:t>
+              <a:t>2. Payload 2 (Vượt Qua Bộ Lọc Bằng Trình Xử Lý Sự Kiện HTML):</a:t>
+            </a:r>
+            <a:br/>
+            <a:r>
+              <a:t>   &lt;img src=x onerror=alert('XSS triggered via image onerror')&gt;</a:t>
+            </a:r>
+            <a:br/>
+            <a:r>
+              <a:t>   Cơ chế: Khi ứng dụng chỉ lọc từ khóa '&lt;script&gt;', kẻ tấn công sử dụng thuộc tính 'onerror' của thẻ hình ảnh khi đường dẫn ảnh không tồn tại để kích hoạt JavaScript.</a:t>
             </a:r>
           </a:p>
           <a:p>
@@ -4229,15 +4229,15 @@
               </a:defRPr>
             </a:pPr>
             <a:r>
-              <a:t>3. Payload 3 (Thay Đổi Toàn Bộ Cây DOM - Web Defacement):</a:t>
-            </a:r>
-            <a:br/>
-            <a:r>
-              <a:t>   &lt;script&gt;document.body.innerHTML='&lt;h1 style=color:red;text-align:center&gt;WEB ĐÃ BỊ CHIẾM QUYỀN&lt;/h1&gt;';&lt;/script&gt;</a:t>
-            </a:r>
-            <a:br/>
-            <a:r>
-              <a:t>   Cơ chế: Xóa sạch toàn bộ nội dung trang web chính thống và hiển thị thông điệp của hacker!</a:t>
+              <a:t>3. Payload 3 (Thay Đổi Toàn Bộ Cấu Trúc Trang Web):</a:t>
+            </a:r>
+            <a:br/>
+            <a:r>
+              <a:t>   &lt;script&gt;document.body.innerHTML='&lt;h2 style=color:red;text-align:center&gt;Trang Web Đã Bị Thay Đổi&lt;/h2&gt;';&lt;/script&gt;</a:t>
+            </a:r>
+            <a:br/>
+            <a:r>
+              <a:t>   Cơ chế: Can thiệp trực tiếp vào thuộc tính body.innerHTML để thay đổi toàn bộ nội dung hiển thị của website.</a:t>
             </a:r>
           </a:p>
         </p:txBody>
@@ -4422,7 +4422,7 @@
               </a:defRPr>
             </a:pPr>
             <a:r>
-              <a:t>Nhóm WNC.G01 (Học - Bình - Cường) • Khoa CNTT - Đại học Mở Hà Nội • GVHD: ThS. Lê Hữu Dũng</a:t>
+              <a:t>Nhóm WNC.G01 • Trường Đại học Mở Hà Nội (HOU) • Giảng viên: ThS. Lê Hữu Dũng</a:t>
             </a:r>
           </a:p>
         </p:txBody>
@@ -4500,7 +4500,7 @@
               </a:defRPr>
             </a:pPr>
             <a:r>
-              <a:t>💬 [BÌNH LIVE DEMO]: Giao diện chức năng Đánh giá chuyên gia dính lỗi XSS (/Xss)</a:t>
+              <a:t>Minh chứng đối chứng chức năng Nhận xét đánh giá chuyên gia (/Xss)</a:t>
             </a:r>
           </a:p>
           <a:p>
@@ -4515,11 +4515,11 @@
               </a:defRPr>
             </a:pPr>
             <a:r>
-              <a:t>• Bên Trái (Lỗi): Đăng nội dung chứa &lt;script&gt;alert(document.cookie)&lt;/script&gt; -&gt; Trình duyệt nạn nhân tự động thực thi script.</a:t>
-            </a:r>
-            <a:br/>
-            <a:r>
-              <a:t>• Bên Phải (Đã Vá): Dùng Razor HTML Encoding -&gt; Chuyển đổi &lt;script&gt; thành &amp;lt;script&amp;gt;, hiển thị văn bản an toàn 100%.</a:t>
+              <a:t>• Nhánh dính lỗi (Trái): Chuỗi kịch bản được lưu và render thô, kích hoạt thông báo alert hiển thị Cookie.</a:t>
+            </a:r>
+            <a:br/>
+            <a:r>
+              <a:t>• Nhánh an toàn (Phải): Razor View tự động mã hóa chuỗi thành văn bản an toàn, triệt tiêu khả năng thực thi mã.</a:t>
             </a:r>
           </a:p>
         </p:txBody>
@@ -4669,7 +4669,7 @@
               </a:defRPr>
             </a:pPr>
             <a:r>
-              <a:t>2.5. Stored XSS: Minh Chứng CSDL dbo.Comments &amp; Cờ Bảo Vệ Cookie</a:t>
+              <a:t>2.5. Stored XSS: Minh Chứng Dữ Liệu CSDL &amp; Bảo Vệ Cookie</a:t>
             </a:r>
           </a:p>
         </p:txBody>
@@ -4704,7 +4704,7 @@
               </a:defRPr>
             </a:pPr>
             <a:r>
-              <a:t>Nhóm WNC.G01 (Học - Bình - Cường) • Khoa CNTT - Đại học Mở Hà Nội • GVHD: ThS. Lê Hữu Dũng</a:t>
+              <a:t>Nhóm WNC.G01 • Trường Đại học Mở Hà Nội (HOU) • Giảng viên: ThS. Lê Hữu Dũng</a:t>
             </a:r>
           </a:p>
         </p:txBody>
@@ -4758,7 +4758,7 @@
               </a:defRPr>
             </a:pPr>
             <a:r>
-              <a:t>Dữ Liệu Thật Lưu Trong Bảng dbo.Comments</a:t>
+              <a:t>Dữ Liệu Lưu Trong Bảng dbo.Comments</a:t>
             </a:r>
           </a:p>
           <a:p>
@@ -4806,11 +4806,11 @@
               </a:defRPr>
             </a:pPr>
             <a:r>
-              <a:t>📌 Bản chất lưu trữ:</a:t>
-            </a:r>
-            <a:br/>
-            <a:r>
-              <a:t>Đoạn script độc hại được lưu vĩnh viễn trong CSDL. Do đó gọi là 'Stored XSS' - nguy hiểm hơn rất nhiều so với 'Reflected XSS' vì nó nằm sẵn trong hệ thống và gây hại cho mọi lượt truy cập sau đó.</a:t>
+              <a:t>Phân tích đặc tính lưu trữ:</a:t>
+            </a:r>
+            <a:br/>
+            <a:r>
+              <a:t>Mã kịch bản độc hại được lưu trữ trực tiếp trong CSDL. Do đó, lỗ hổng Stored XSS có tính chất nguy hại kéo dài và phát tán tới mọi người dùng xem nội dung đó.</a:t>
             </a:r>
           </a:p>
         </p:txBody>
@@ -4864,7 +4864,7 @@
               </a:defRPr>
             </a:pPr>
             <a:r>
-              <a:t>Phòng Vệ Chiều Sâu: Cấu Hình HttpOnly Cookie</a:t>
+              <a:t>Cơ Chế Bảo Vệ Với Cờ HttpOnly Cookie</a:t>
             </a:r>
           </a:p>
           <a:p>
@@ -4892,11 +4892,11 @@
             </a:r>
             <a:br/>
             <a:r>
-              <a:t>    HttpOnly = true, // CẤM JAVASCRIPT TRUY CẬP</a:t>
-            </a:r>
-            <a:br/>
-            <a:r>
-              <a:t>    Secure = true,   // CHỈ TRUYỀN QUA HTTPS</a:t>
+              <a:t>    HttpOnly = true, // CẤM JAVASCRIPT ĐỌC TRỘM</a:t>
+            </a:r>
+            <a:br/>
+            <a:r>
+              <a:t>    Secure = true,   // BẮT BUỘC TRUYỀN QUA HTTPS</a:t>
             </a:r>
             <a:br/>
             <a:r>
@@ -4919,11 +4919,11 @@
               </a:defRPr>
             </a:pPr>
             <a:r>
-              <a:t>📌 Tác dụng của HttpOnly:</a:t>
-            </a:r>
-            <a:br/>
-            <a:r>
-              <a:t>Dù ứng dụng có vô tình dính lỗi XSS thì lệnh 'document.cookie' của hacker vẫn trả về rỗng! Hacker không thể nào đánh cắp được token phiên làm việc.</a:t>
+              <a:t>Vai trò của cờ HttpOnly:</a:t>
+            </a:r>
+            <a:br/>
+            <a:r>
+              <a:t>Ngăn chặn mã JavaScript đọc thuộc tính document.cookie. Kể cả khi trang web xuất hiện lỗi XSS, kẻ tấn công cũng không thể trích xuất token phiên làm việc.</a:t>
             </a:r>
           </a:p>
         </p:txBody>
@@ -5073,7 +5073,7 @@
               </a:defRPr>
             </a:pPr>
             <a:r>
-              <a:t>2.6. Stored XSS: Bộ 4 Nguyên Tắc Phòng Thủ Toàn Diện</a:t>
+              <a:t>2.6. Stored XSS: Bộ Giải Pháp Phòng Thủ Chuẩn Trong ASP.NET Core</a:t>
             </a:r>
           </a:p>
         </p:txBody>
@@ -5108,7 +5108,7 @@
               </a:defRPr>
             </a:pPr>
             <a:r>
-              <a:t>Nhóm WNC.G01 (Học - Bình - Cường) • Khoa CNTT - Đại học Mở Hà Nội • GVHD: ThS. Lê Hữu Dũng</a:t>
+              <a:t>Nhóm WNC.G01 • Trường Đại học Mở Hà Nội (HOU) • Giảng viên: ThS. Lê Hữu Dũng</a:t>
             </a:r>
           </a:p>
         </p:txBody>
@@ -5162,7 +5162,7 @@
               </a:defRPr>
             </a:pPr>
             <a:r>
-              <a:t>BỘ NGUYÊN TẮC PHÒNG THỦ XSS CHUẨN OWASP TRONG ASP.NET CORE:</a:t>
+              <a:t>CÁC NGUYÊN TẮC PHÒNG THỦ XSS THEO KHUYẾN NGHỊ OWASP:</a:t>
             </a:r>
           </a:p>
           <a:p>
@@ -5177,11 +5177,11 @@
               </a:defRPr>
             </a:pPr>
             <a:r>
-              <a:t>1. Luôn tận dụng Context-Aware HTML Encoding của Razor View:</a:t>
-            </a:r>
-            <a:br/>
-            <a:r>
-              <a:t>   Tuyệt đối không dùng @Html.Raw() cho dữ liệu nhập từ người dùng. Sử dụng cú pháp mặc định @model.Property để framework tự động mã hóa ký tự nhạy cảm.</a:t>
+              <a:t>1. Tận dụng cơ chế mã hóa tự động của Razor View:</a:t>
+            </a:r>
+            <a:br/>
+            <a:r>
+              <a:t>   Sử dụng cú pháp mặc định @model.Property thay vì @Html.Raw() đối với mọi dữ liệu bắt nguồn từ người dùng. Các ký tự nhạy cảm (&lt;, &gt;, ", ') tự động được chuyển đổi sang thực thể HTML an toàn.</a:t>
             </a:r>
           </a:p>
           <a:p>
@@ -5196,11 +5196,11 @@
               </a:defRPr>
             </a:pPr>
             <a:r>
-              <a:t>2. Mã hóa tại Controller với System.Text.Encodings.Web:</a:t>
-            </a:r>
-            <a:br/>
-            <a:r>
-              <a:t>   Dùng HtmlEncoder.Default.Encode() hoặc JavaScriptEncoder.Default.Encode() để làm sạch chuỗi trước khi lưu vào CSDL.</a:t>
+              <a:t>2. Mã hóa dữ liệu với System.Text.Encodings.Web:</a:t>
+            </a:r>
+            <a:br/>
+            <a:r>
+              <a:t>   Sử dụng HtmlEncoder.Default.Encode() để xử lý dữ liệu trước khi lưu trữ hoặc phản hồi.</a:t>
             </a:r>
           </a:p>
           <a:p>
@@ -5215,11 +5215,11 @@
               </a:defRPr>
             </a:pPr>
             <a:r>
-              <a:t>3. Thiết lập cờ HttpOnly = true và Secure = true cho toàn bộ Cookie nhạy cảm:</a:t>
-            </a:r>
-            <a:br/>
-            <a:r>
-              <a:t>   Bảo vệ token phiên làm việc (Session) không bao giờ bị lộ qua thuộc tính document.cookie.</a:t>
+              <a:t>3. Thiết lập thuộc tính an toàn cho Cookie:</a:t>
+            </a:r>
+            <a:br/>
+            <a:r>
+              <a:t>   Kích hoạt HttpOnly = true và Secure = true để bảo vệ token phiên làm việc khỏi sự can thiệp của mã kịch bản phía client.</a:t>
             </a:r>
           </a:p>
           <a:p>
@@ -5238,7 +5238,7 @@
             </a:r>
             <a:br/>
             <a:r>
-              <a:t>   Thiết lập HTTP Response Header (script-src 'self') để trình duyệt chặn đứng hoàn toàn việc chạy inline script và tải mã độc từ các tên miền lạ.</a:t>
+              <a:t>   Cấu hình chính sách bảo mật nội dung để hạn chế phạm vi thực thi kịch bản và chặn các nguồn tài nguyên không tin cậy.</a:t>
             </a:r>
           </a:p>
         </p:txBody>
@@ -5423,7 +5423,7 @@
               </a:defRPr>
             </a:pPr>
             <a:r>
-              <a:t>Nhóm WNC.G01 (Học - Bình - Cường) • Khoa CNTT - Đại học Mở Hà Nội • GVHD: ThS. Lê Hữu Dũng</a:t>
+              <a:t>Nhóm WNC.G01 • Trường Đại học Mở Hà Nội (HOU) • Giảng viên: ThS. Lê Hữu Dũng</a:t>
             </a:r>
           </a:p>
         </p:txBody>
@@ -5477,7 +5477,7 @@
               </a:defRPr>
             </a:pPr>
             <a:r>
-              <a:t>Bản Chất Của Lỗ Hổng Cross-Site Request Forgery</a:t>
+              <a:t>Bản Chất Kỹ Thuật Của Tấn Công CSRF</a:t>
             </a:r>
           </a:p>
           <a:p>
@@ -5492,27 +5492,27 @@
               </a:defRPr>
             </a:pPr>
             <a:r>
-              <a:t>• CSRF (A01:2021 - Broken Access Control) là kỹ thuật tấn công mượn quyền của người dùng hợp lệ.</a:t>
-            </a:r>
-            <a:br/>
-            <a:r>
-              <a:t>• Điều kiện xảy ra:</a:t>
-            </a:r>
-            <a:br/>
-            <a:r>
-              <a:t>  1. Nạn nhân đã đăng nhập vào hệ thống tư vấn trực tuyến (phiên làm việc Session/Cookie vẫn đang hợp lệ).</a:t>
-            </a:r>
-            <a:br/>
-            <a:r>
-              <a:t>  2. Trình duyệt tự động đính kèm Cookie xác thực vào mọi HTTP Request gửi tới hệ thống đó.</a:t>
-            </a:r>
-            <a:br/>
-            <a:r>
-              <a:t>  3. Kẻ tấn công lừa nạn nhân truy cập một trang web độc hại ở một tab khác (Attacker Site).</a:t>
-            </a:r>
-            <a:br/>
-            <a:r>
-              <a:t>• Điểm mù: Máy chủ chỉ kiểm tra Cookie mà không kiểm tra xem Request đó bắt nguồn từ đâu!</a:t>
+              <a:t>• CSRF (A01:2021 - Broken Access Control) là kỹ thuật tấn công mượn quyền người dùng hợp lệ.</a:t>
+            </a:r>
+            <a:br/>
+            <a:r>
+              <a:t>• Điều kiện tiên quyết:</a:t>
+            </a:r>
+            <a:br/>
+            <a:r>
+              <a:t>  1. Nạn nhân có phiên đăng nhập hợp lệ tại ứng dụng mục tiêu (Cookie xác thực còn hiệu lực).</a:t>
+            </a:r>
+            <a:br/>
+            <a:r>
+              <a:t>  2. Trình duyệt tự động đính kèm Cookie xác thực theo mọi HTTP Request gửi tới tên miền của ứng dụng.</a:t>
+            </a:r>
+            <a:br/>
+            <a:r>
+              <a:t>  3. Kẻ tấn công lừa nạn nhân truy cập một trang web độc hại do kẻ tấn công kiểm soát.</a:t>
+            </a:r>
+            <a:br/>
+            <a:r>
+              <a:t>• Điểm mù kiểm soát: Máy chủ chỉ xác thực Cookie của người dùng mà không kiểm tra nguồn gốc phát sinh Request.</a:t>
             </a:r>
           </a:p>
         </p:txBody>
@@ -5566,7 +5566,7 @@
               </a:defRPr>
             </a:pPr>
             <a:r>
-              <a:t>Action Bị Lỗi: Thiếu Thuộc Tính Phòng Vệ</a:t>
+              <a:t>Action Xử Lý Giao Dịch Thiếu Kiểm Soát</a:t>
             </a:r>
           </a:p>
           <a:p>
@@ -5582,7 +5582,7 @@
               </a:defRPr>
             </a:pPr>
             <a:r>
-              <a:t>// ACTION NHẬN TIỀN KHÔNG CÓ BẢO VỆ TOKEN:</a:t>
+              <a:t>// ACTION NHẬN YÊU CẦU KHÔNG CÓ BẢO VỆ TOKEN:</a:t>
             </a:r>
             <a:br/>
             <a:r>
@@ -5607,10 +5607,6 @@
             <a:br/>
             <a:r>
               <a:t>    </a:t>
-            </a:r>
-            <a:br/>
-            <a:r>
-              <a:t>    // Trừ tiền nạn nhân, cộng tiền hacker:</a:t>
             </a:r>
             <a:br/>
             <a:r>
@@ -5645,11 +5641,7 @@
               </a:defRPr>
             </a:pPr>
             <a:r>
-              <a:t>⚠️ Nguy hiểm:</a:t>
-            </a:r>
-            <a:br/>
-            <a:r>
-              <a:t>Bất kỳ trang web nào trên Internet cũng có thể gửi form POST tới URL này. Máy chủ thấy Cookie hợp lệ sẽ trừ tiền ngay lập tức!</a:t>
+              <a:t>Khi Action không yêu cầu mã xác thực chống giả mạo, các yêu cầu POST bắt nguồn từ một website khác vẫn được máy chủ thực thi bình thường do Cookie xác thực được đính kèm tự động.</a:t>
             </a:r>
           </a:p>
         </p:txBody>
@@ -5799,7 +5791,7 @@
               </a:defRPr>
             </a:pPr>
             <a:r>
-              <a:t>3.2. CSRF Attack: Kịch Bản Lừa Đảo Chuyển Tiền Ví Ngầm</a:t>
+              <a:t>3.2. CSRF Attack: Kịch Bản Khai Thác Bằng Form Ẩn</a:t>
             </a:r>
           </a:p>
         </p:txBody>
@@ -5834,7 +5826,7 @@
               </a:defRPr>
             </a:pPr>
             <a:r>
-              <a:t>Nhóm WNC.G01 (Học - Bình - Cường) • Khoa CNTT - Đại học Mở Hà Nội • GVHD: ThS. Lê Hữu Dũng</a:t>
+              <a:t>Nhóm WNC.G01 • Trường Đại học Mở Hà Nội (HOU) • Giảng viên: ThS. Lê Hữu Dũng</a:t>
             </a:r>
           </a:p>
         </p:txBody>
@@ -5888,7 +5880,7 @@
               </a:defRPr>
             </a:pPr>
             <a:r>
-              <a:t>Kịch bản: Trang Web Giả Mạo Trúng Thưởng (Attacker Site)</a:t>
+              <a:t>Kịch Bản: Trang Web Giả Mạo Điều Khiển Yêu Cầu Chuyển Tiền</a:t>
             </a:r>
           </a:p>
           <a:p>
@@ -5903,15 +5895,15 @@
               </a:defRPr>
             </a:pPr>
             <a:r>
-              <a:t>1. Nạn nhân có 50.000.000 VNĐ trong ví đang mở tab làm việc tại nền tảng tư vấn trực tuyến.</a:t>
-            </a:r>
-            <a:br/>
-            <a:r>
-              <a:t>2. Kẻ tấn công gửi link: 'Chúc mừng bạn trúng thưởng iPhone 16 Pro Max! Click để nhận quà!'.</a:t>
-            </a:r>
-            <a:br/>
-            <a:r>
-              <a:t>3. Khi nạn nhân click vào link, một trang web bẫy (AttackerSite.cshtml) được mở ra, bên trong chứa mã HTML ẩn:</a:t>
+              <a:t>1. Nạn nhân có phiên làm việc đang hoạt động trên hệ thống tư vấn trực tuyến.</a:t>
+            </a:r>
+            <a:br/>
+            <a:r>
+              <a:t>2. Nạn nhân được dẫn dụ truy cập một trang web độc hại ở một tab khác (AttackerSite.cshtml).</a:t>
+            </a:r>
+            <a:br/>
+            <a:r>
+              <a:t>3. Trang web độc hại chứa một biểu mẫu ẩn trỏ trực tiếp tới địa chỉ nhận lệnh của ứng dụng mục tiêu:</a:t>
             </a:r>
           </a:p>
           <a:p>
@@ -5927,7 +5919,7 @@
               </a:defRPr>
             </a:pPr>
             <a:r>
-              <a:t>&lt;!-- FORM ẨN TỰ ĐỘNG GỬI SANG HỆ THỐNG MỤC TIÊU --&gt;</a:t>
+              <a:t>&lt;!-- BIỂU MẪU ẨN TRÊN TRANG WEB CỦA KẺ TẤN CÔNG --&gt;</a:t>
             </a:r>
             <a:br/>
             <a:r>
@@ -5958,7 +5950,7 @@
               </a:defRPr>
             </a:pPr>
             <a:r>
-              <a:t>Hậu quả thực tế: Nạn nhân không hề bấm chuyển tiền, nhưng ví tiền bị trừ ngay 20.000.000 VNĐ sang ví hacker!</a:t>
+              <a:t>Hậu quả thực tế: Yêu cầu giao dịch được thực hiện mà không có sự đồng thuận chủ động của người dùng, dẫn đến thay đổi số dư hoặc cấu hình tài khoản.</a:t>
             </a:r>
           </a:p>
         </p:txBody>
@@ -6108,7 +6100,7 @@
               </a:defRPr>
             </a:pPr>
             <a:r>
-              <a:t>3.3. CSRF Attack: Thực Nghiệm Trực Tiếp &amp; Kiểm Thử Rút Tiền</a:t>
+              <a:t>3.3. CSRF Attack: Minh Chứng Thực Nghiệm Trực Quan Trên Web UI</a:t>
             </a:r>
           </a:p>
         </p:txBody>
@@ -6143,100 +6135,35 @@
               </a:defRPr>
             </a:pPr>
             <a:r>
-              <a:t>Nhóm WNC.G01 (Học - Bình - Cường) • Khoa CNTT - Đại học Mở Hà Nội • GVHD: ThS. Lê Hữu Dũng</a:t>
-            </a:r>
-          </a:p>
-        </p:txBody>
-      </p:sp>
-      <p:sp>
-        <p:nvSpPr>
-          <p:cNvPr id="6" name="Rounded Rectangle 5"/>
-          <p:cNvSpPr/>
-          <p:nvPr/>
-        </p:nvSpPr>
-        <p:spPr>
-          <a:xfrm>
-            <a:off x="731520" y="1280160"/>
-            <a:ext cx="10728655" cy="3840480"/>
-          </a:xfrm>
-          <a:prstGeom prst="roundRect">
-            <a:avLst/>
-          </a:prstGeom>
-          <a:solidFill>
-            <a:srgbClr val="F8FAFC"/>
-          </a:solidFill>
-          <a:ln>
-            <a:solidFill>
-              <a:srgbClr val="E2E8F0"/>
-            </a:solidFill>
-          </a:ln>
-        </p:spPr>
-        <p:style>
-          <a:lnRef idx="1">
-            <a:schemeClr val="accent1"/>
-          </a:lnRef>
-          <a:fillRef idx="3">
-            <a:schemeClr val="accent1"/>
-          </a:fillRef>
-          <a:effectRef idx="2">
-            <a:schemeClr val="accent1"/>
-          </a:effectRef>
-          <a:fontRef idx="minor">
-            <a:schemeClr val="lt1"/>
-          </a:fontRef>
-        </p:style>
-        <p:txBody>
-          <a:bodyPr rtlCol="0" anchor="ctr" wrap="square"/>
-          <a:lstStyle/>
-          <a:p>
-            <a:pPr algn="ctr">
-              <a:defRPr sz="1500" b="1">
-                <a:solidFill>
-                  <a:srgbClr val="047857"/>
-                </a:solidFill>
-              </a:defRPr>
-            </a:pPr>
-            <a:r>
-              <a:t>Quy Trình 3 Bước Thực Nghiệm Trên Giao Diện Web</a:t>
-            </a:r>
-          </a:p>
-          <a:p>
-            <a:pPr>
-              <a:spcBef>
-                <a:spcPts val="800"/>
-              </a:spcBef>
-              <a:defRPr sz="1300">
-                <a:solidFill>
-                  <a:srgbClr val="334155"/>
-                </a:solidFill>
-              </a:defRPr>
-            </a:pPr>
-            <a:r>
-              <a:t>• Bước 1: Kiểm tra số dư ví ban đầu tại Tab 3:</a:t>
-            </a:r>
-            <a:br/>
-            <a:r>
-              <a:t>  - Ví Nạn nhân: 50.000.000 VNĐ | Ví Hacker: 0 VNĐ.</a:t>
-            </a:r>
-            <a:br/>
-            <a:r>
-              <a:t>• Bước 2: Bấm nút đỏ 'Mở trang web bẫy của Hacker (Attacker Site)' ở tab mới -&gt; Bấm nút 'Nhận thưởng ngay':</a:t>
-            </a:r>
-            <a:br/>
-            <a:r>
-              <a:t>  - Ngay lập tức, số dư của nạn nhân bị trừ 20.000.000 VNĐ và chuyển sang ví hacker!</a:t>
-            </a:r>
-            <a:br/>
-            <a:r>
-              <a:t>• Bước 3: Thử nghiệm chuyển tiền tại Form bên phải (Đã phòng thủ):</a:t>
-            </a:r>
-            <a:br/>
-            <a:r>
-              <a:t>  - Giao dịch chỉ hợp lệ khi được gửi từ chính form trên hệ thống với Anti-Forgery Token hợp lệ.</a:t>
-            </a:r>
-          </a:p>
-        </p:txBody>
-      </p:sp>
+              <a:t>Nhóm WNC.G01 • Trường Đại học Mở Hà Nội (HOU) • Giảng viên: ThS. Lê Hữu Dũng</a:t>
+            </a:r>
+          </a:p>
+        </p:txBody>
+      </p:sp>
+      <p:pic>
+        <p:nvPicPr>
+          <p:cNvPr id="6" name="Picture 5" descr="crop_csrf_ui.png"/>
+          <p:cNvPicPr>
+            <a:picLocks noChangeAspect="1"/>
+          </p:cNvPicPr>
+          <p:nvPr/>
+        </p:nvPicPr>
+        <p:blipFill>
+          <a:blip r:embed="rId2"/>
+          <a:stretch>
+            <a:fillRect/>
+          </a:stretch>
+        </p:blipFill>
+        <p:spPr>
+          <a:xfrm>
+            <a:off x="1645920" y="1234440"/>
+            <a:ext cx="8869680" cy="4264269"/>
+          </a:xfrm>
+          <a:prstGeom prst="rect">
+            <a:avLst/>
+          </a:prstGeom>
+        </p:spPr>
+      </p:pic>
       <p:sp>
         <p:nvSpPr>
           <p:cNvPr id="7" name="Rounded Rectangle 6"/>
@@ -6245,8 +6172,8 @@
         </p:nvSpPr>
         <p:spPr>
           <a:xfrm>
-            <a:off x="731520" y="5303520"/>
-            <a:ext cx="10728655" cy="868680"/>
+            <a:off x="731520" y="5440680"/>
+            <a:ext cx="10728655" cy="914400"/>
           </a:xfrm>
           <a:prstGeom prst="roundRect">
             <a:avLst/>
@@ -6279,14 +6206,14 @@
           <a:lstStyle/>
           <a:p>
             <a:pPr algn="ctr">
-              <a:defRPr sz="1250" b="1">
+              <a:defRPr sz="1200" b="1">
                 <a:solidFill>
                   <a:srgbClr val="047857"/>
                 </a:solidFill>
               </a:defRPr>
             </a:pPr>
             <a:r>
-              <a:t>💳 [CƯỜNG LIVE DEMO]: Chuyển sang Web UI Tab 3 (CSRF - /Csrf)</a:t>
+              <a:t>Minh chứng đối chứng phân hệ quản lý ví tiền &amp; kịch bản CSRF (/Csrf)</a:t>
             </a:r>
           </a:p>
           <a:p>
@@ -6301,7 +6228,11 @@
               </a:defRPr>
             </a:pPr>
             <a:r>
-              <a:t>Thao tác: Mở Attacker Site -&gt; Bấm nhận thưởng -&gt; Quay lại thấy số dư ví nạn nhân bị trừ 20 triệu -&gt; Thử lại form có Token.</a:t>
+              <a:t>• Mở Attacker Site: Biểu mẫu ẩn tự động gửi POST sang Action dính lỗi -&gt; Số dư ví bị trừ 20.000.000 VNĐ.</a:t>
+            </a:r>
+            <a:br/>
+            <a:r>
+              <a:t>• Nhánh đã phòng thủ: Biểu mẫu chính chủ được tích hợp Anti-Forgery Token -&gt; Từ chối 100% yêu cầu giả mạo từ bên ngoài.</a:t>
             </a:r>
           </a:p>
         </p:txBody>
@@ -6451,7 +6382,7 @@
               </a:defRPr>
             </a:pPr>
             <a:r>
-              <a:t>3.4. CSRF Attack: Minh Chứng CSDL dbo.UserWallets Trước &amp; Sau Tấn Công</a:t>
+              <a:t>3.4. CSRF Attack: Minh Chứng Biến Động CSDL dbo.UserWallets</a:t>
             </a:r>
           </a:p>
         </p:txBody>
@@ -6486,7 +6417,7 @@
               </a:defRPr>
             </a:pPr>
             <a:r>
-              <a:t>Nhóm WNC.G01 (Học - Bình - Cường) • Khoa CNTT - Đại học Mở Hà Nội • GVHD: ThS. Lê Hữu Dũng</a:t>
+              <a:t>Nhóm WNC.G01 • Trường Đại học Mở Hà Nội (HOU) • Giảng viên: ThS. Lê Hữu Dũng</a:t>
             </a:r>
           </a:p>
         </p:txBody>
@@ -6540,7 +6471,7 @@
               </a:defRPr>
             </a:pPr>
             <a:r>
-              <a:t>1. Trạng Thái CSDL Ban Đầu (Chưa Bị Tấn Công)</a:t>
+              <a:t>1. Trạng Thái CSDL Ban Đầu</a:t>
             </a:r>
           </a:p>
           <a:p>
@@ -6569,11 +6500,11 @@
             </a:r>
             <a:br/>
             <a:r>
-              <a:t> 1 | Nan nhan (Nguyen Danh Hoc)     | 50,000,000.00</a:t>
-            </a:r>
-            <a:br/>
-            <a:r>
-              <a:t> 2 | Ke tan cong (Hacker BlackHat)  |          0.00</a:t>
+              <a:t> 1 | Nạn nhân (Nguyễn Danh Học)     | 50,000,000.00</a:t>
+            </a:r>
+            <a:br/>
+            <a:r>
+              <a:t> 2 | Kẻ tấn công (Hacker BlackHat)  |          0.00</a:t>
             </a:r>
             <a:br/>
             <a:r>
@@ -6592,7 +6523,7 @@
               </a:defRPr>
             </a:pPr>
             <a:r>
-              <a:t>📌 Ví của nạn nhân có 50 triệu VNĐ, ví của hacker hoàn toàn không có tiền.</a:t>
+              <a:t>Số dư ví tài khoản nạn nhân ở trạng thái ban đầu là 50 triệu VNĐ, tài khoản đối tượng tấn công là 0 VNĐ.</a:t>
             </a:r>
           </a:p>
         </p:txBody>
@@ -6646,7 +6577,7 @@
               </a:defRPr>
             </a:pPr>
             <a:r>
-              <a:t>2. Trạng Thái CSDL Sau Khi Bị Khai Thác CSRF</a:t>
+              <a:t>2. Trạng Thái CSDL Sau Khai Thác CSRF</a:t>
             </a:r>
           </a:p>
           <a:p>
@@ -6675,11 +6606,11 @@
             </a:r>
             <a:br/>
             <a:r>
-              <a:t> 1 | Nan nhan (Nguyen Danh Hoc)     | 30,000,000.00</a:t>
-            </a:r>
-            <a:br/>
-            <a:r>
-              <a:t> 2 | Ke tan cong (Hacker BlackHat)  | 20,000,000.00</a:t>
+              <a:t> 1 | Nạn nhân (Nguyễn Danh Học)     | 30,000,000.00</a:t>
+            </a:r>
+            <a:br/>
+            <a:r>
+              <a:t> 2 | Kẻ tấn công (Hacker BlackHat)  | 20,000,000.00</a:t>
             </a:r>
             <a:br/>
             <a:r>
@@ -6698,11 +6629,7 @@
               </a:defRPr>
             </a:pPr>
             <a:r>
-              <a:t>📌 Hậu quả kiểm chứng trên CSDL thật:</a:t>
-            </a:r>
-            <a:br/>
-            <a:r>
-              <a:t>20.000.000 VNĐ đã biến mất khỏi tài khoản nạn nhân và chuyển sang số dư của kẻ tấn công mà nạn nhân không hề hay biết.</a:t>
+              <a:t>Số dư thực tế trong CSDL bị thay đổi hoàn toàn tự động khi nạn nhân truy cập liên kết độc hại, chứng minh mức độ rủi ro nghiêm trọng của giao dịch thiếu token.</a:t>
             </a:r>
           </a:p>
         </p:txBody>
@@ -6887,7 +6814,7 @@
               </a:defRPr>
             </a:pPr>
             <a:r>
-              <a:t>Nhóm WNC.G01 (Học - Bình - Cường) • Khoa CNTT - Đại học Mở Hà Nội • GVHD: ThS. Lê Hữu Dũng</a:t>
+              <a:t>Nhóm WNC.G01 • Trường Đại học Mở Hà Nội (HOU) • Giảng viên: ThS. Lê Hữu Dũng</a:t>
             </a:r>
           </a:p>
         </p:txBody>
@@ -6941,7 +6868,7 @@
               </a:defRPr>
             </a:pPr>
             <a:r>
-              <a:t>Cơ Chế Synchronizer Token Pattern Trong ASP.NET Core</a:t>
+              <a:t>Mô Hình Synchronizer Token Pattern</a:t>
             </a:r>
           </a:p>
           <a:p>
@@ -7060,7 +6987,7 @@
               </a:defRPr>
             </a:pPr>
             <a:r>
-              <a:t>Tại Sao Kẻ Tấn Công Không Thể Vượt Qua?</a:t>
+              <a:t>Cơ Chế Ngăn Chặn Yêu Cầu Giả Mạo</a:t>
             </a:r>
           </a:p>
           <a:p>
@@ -7079,25 +7006,25 @@
             </a:r>
             <a:br/>
             <a:r>
-              <a:t>Máy chủ phát hành 1 token mã hóa trong Cookie và 1 token bí mật nhúng vào trường input ẩn của Form.</a:t>
-            </a:r>
-            <a:br/>
-            <a:br/>
-            <a:r>
-              <a:t>2. Bảo vệ bằng Same-Origin Policy (SOP):</a:t>
-            </a:r>
-            <a:br/>
-            <a:r>
-              <a:t>Trang web độc hại của hacker ở tên miền khác (Cross-Origin) TUYỆT ĐỐI KHÔNG THỂ đọc trộm token bí mật trong form của nạn nhân.</a:t>
-            </a:r>
-            <a:br/>
-            <a:br/>
-            <a:r>
-              <a:t>3. Cấu hình Cookie SameSite = Strict:</a:t>
-            </a:r>
-            <a:br/>
-            <a:r>
-              <a:t>Ngăn chặn trình duyệt tự động gửi cookie trong các cross-site request, triệt tiêu tận gốc tiền đề tấn công của CSRF.</a:t>
+              <a:t>Máy chủ phát hành một cặp token: một giá trị lưu trong Cookie phiên và một giá trị nhúng vào trường ẩn của biểu mẫu.</a:t>
+            </a:r>
+            <a:br/>
+            <a:br/>
+            <a:r>
+              <a:t>2. Bảo vệ bằng Chính sách Cùng nguồn gốc (SOP):</a:t>
+            </a:r>
+            <a:br/>
+            <a:r>
+              <a:t>Website độc hại ở tên miền khác bị trình duyệt ngăn cấm truy cập dữ liệu DOM của biểu mẫu hợp lệ, do đó không thể sao chép token.</a:t>
+            </a:r>
+            <a:br/>
+            <a:br/>
+            <a:r>
+              <a:t>3. Thuộc tính SameSite cho Cookie:</a:t>
+            </a:r>
+            <a:br/>
+            <a:r>
+              <a:t>Thiết lập SameSite = Strict hoặc Lax giúp kiểm soát việc trình duyệt tự động gửi kèm cookie trong các yêu cầu cross-site.</a:t>
             </a:r>
           </a:p>
         </p:txBody>
@@ -7247,7 +7174,7 @@
               </a:defRPr>
             </a:pPr>
             <a:r>
-              <a:t>Mục Tiêu &amp; Phương Châm Báo Cáo Thực Nghiệm OWASP</a:t>
+              <a:t>Mục Tiêu &amp; Phương Pháp Thực Nghiệm</a:t>
             </a:r>
           </a:p>
         </p:txBody>
@@ -7282,7 +7209,7 @@
               </a:defRPr>
             </a:pPr>
             <a:r>
-              <a:t>Nhóm WNC.G01 (Học - Bình - Cường) • Khoa CNTT - Đại học Mở Hà Nội • GVHD: ThS. Lê Hữu Dũng</a:t>
+              <a:t>Nhóm WNC.G01 • Trường Đại học Mở Hà Nội (HOU) • Giảng viên: ThS. Lê Hữu Dũng</a:t>
             </a:r>
           </a:p>
         </p:txBody>
@@ -7336,7 +7263,7 @@
               </a:defRPr>
             </a:pPr>
             <a:r>
-              <a:t>🎯 Yêu Cầu Của Giảng Viên (ThS. Lê Hữu Dũng)</a:t>
+              <a:t>Mục Tiêu Nghiên Cứu</a:t>
             </a:r>
           </a:p>
           <a:p>
@@ -7344,26 +7271,26 @@
               <a:spcBef>
                 <a:spcPts val="1000"/>
               </a:spcBef>
-              <a:defRPr sz="1300">
+              <a:defRPr sz="1250">
                 <a:solidFill>
                   <a:srgbClr val="334155"/>
                 </a:solidFill>
               </a:defRPr>
             </a:pPr>
             <a:r>
-              <a:t>• Không dịch lý thuyết tiếng Anh sách vở.</a:t>
-            </a:r>
-            <a:br/>
-            <a:r>
-              <a:t>• Thấy được lỗ hổng thực sự nguy hiểm đến mức nào trong môi trường thực tế.</a:t>
-            </a:r>
-            <a:br/>
-            <a:r>
-              <a:t>• Bắt buộc phải thực nghiệm demo: Muốn phòng thủ an toàn, phải hiểu hacker tấn công hệ thống theo cách nào.</a:t>
-            </a:r>
-            <a:br/>
-            <a:r>
-              <a:t>• Báo cáo đối chứng: Minh chứng rõ ràng giữa code dính lỗi và code đã vá chuẩn.</a:t>
+              <a:t>• Bám sát yêu cầu thực tiễn: Tập trung vào thực nghiệm và phân tích mã nguồn thay vì lý thuyết thuần túy.</a:t>
+            </a:r>
+            <a:br/>
+            <a:r>
+              <a:t>• Nhận thức mức độ rủi ro: Đánh giá tác động an ninh thực tế trên ứng dụng web.</a:t>
+            </a:r>
+            <a:br/>
+            <a:r>
+              <a:t>• Phương pháp tiếp cận: Để phòng thủ hiệu quả, cần phân tích chính xác vector và kỹ thuật khai thác của kẻ tấn công.</a:t>
+            </a:r>
+            <a:br/>
+            <a:r>
+              <a:t>• Đối chứng rõ ràng: So sánh trực tiếp giữa mã nguồn dính lỗ hổng và mã nguồn đã được chuẩn hóa.</a:t>
             </a:r>
           </a:p>
         </p:txBody>
@@ -7417,7 +7344,7 @@
               </a:defRPr>
             </a:pPr>
             <a:r>
-              <a:t>🚀 Phương Pháp Thực Hiện Của Nhóm WNC.G01</a:t>
+              <a:t>Môi Trường &amp; Quy Trình Thực Nghiệm</a:t>
             </a:r>
           </a:p>
           <a:p>
@@ -7425,26 +7352,26 @@
               <a:spcBef>
                 <a:spcPts val="1000"/>
               </a:spcBef>
-              <a:defRPr sz="1300">
+              <a:defRPr sz="1250">
                 <a:solidFill>
                   <a:srgbClr val="334155"/>
                 </a:solidFill>
               </a:defRPr>
             </a:pPr>
             <a:r>
-              <a:t>• Xây dựng ứng dụng thực nghiệm độc lập (OWASP_Demo) trên ASP.NET Core MVC .NET 10.</a:t>
-            </a:r>
-            <a:br/>
-            <a:r>
-              <a:t>• Kết nối trực tiếp máy chủ CSDL Microsoft SQL Server 2025 Developer trên Localhost.</a:t>
-            </a:r>
-            <a:br/>
-            <a:r>
-              <a:t>• Tạo sẵn 3 phân hệ tương tác riêng biệt cho 3 thành viên: Bấm 1 click nạp payload và quan sát kết quả tức thì.</a:t>
-            </a:r>
-            <a:br/>
-            <a:r>
-              <a:t>• Áp dụng kết quả thực nghiệm vào thiết kế kiến trúc bảo mật (Security View) của Đồ án BTL.</a:t>
+              <a:t>• Nền tảng ứng dụng: Xây dựng ứng dụng mẫu trên ASP.NET Core MVC (.NET 10).</a:t>
+            </a:r>
+            <a:br/>
+            <a:r>
+              <a:t>• Hệ quản trị CSDL: Kết nối trực tiếp máy chủ Microsoft SQL Server 2025 Developer.</a:t>
+            </a:r>
+            <a:br/>
+            <a:r>
+              <a:t>• Thiết kế đối chứng: Chia 3 phân hệ tương tác riêng biệt cho 3 thành viên, nạp payload và theo dõi phản hồi thời gian thực.</a:t>
+            </a:r>
+            <a:br/>
+            <a:r>
+              <a:t>• Ứng dụng thực tế: Đưa các giải pháp phòng thủ vào thiết kế kiến trúc (Security View) của đề tài BTL.</a:t>
             </a:r>
           </a:p>
         </p:txBody>
@@ -7594,7 +7521,7 @@
               </a:defRPr>
             </a:pPr>
             <a:r>
-              <a:t>3.6. CSRF Attack: Phòng Thủ Trong AJAX &amp; Fetch API (Buổi 9)</a:t>
+              <a:t>3.6. CSRF Attack: Tích Hợp Token Trong AJAX &amp; Fetch API (Buổi 9)</a:t>
             </a:r>
           </a:p>
         </p:txBody>
@@ -7629,7 +7556,7 @@
               </a:defRPr>
             </a:pPr>
             <a:r>
-              <a:t>Nhóm WNC.G01 (Học - Bình - Cường) • Khoa CNTT - Đại học Mở Hà Nội • GVHD: ThS. Lê Hữu Dũng</a:t>
+              <a:t>Nhóm WNC.G01 • Trường Đại học Mở Hà Nội (HOU) • Giảng viên: ThS. Lê Hữu Dũng</a:t>
             </a:r>
           </a:p>
         </p:txBody>
@@ -7683,7 +7610,7 @@
               </a:defRPr>
             </a:pPr>
             <a:r>
-              <a:t>Kỹ Thuật Truyền Token Khi Sử Dụng AJAX Fetch API (Slide Buổi 9)</a:t>
+              <a:t>Kỹ Thuật Đính Kèm Token Khi Sử Dụng Fetch API Không Tải Lại Trang</a:t>
             </a:r>
           </a:p>
           <a:p>
@@ -7699,7 +7626,7 @@
               </a:defRPr>
             </a:pPr>
             <a:r>
-              <a:t>// TRONG JAVASCRIPT FETCH API:</a:t>
+              <a:t>// TRÍCH XUẤT TOKEN TỪ DOM VÀ ĐÍNH KÈM VÀO HTTP HEADER:</a:t>
             </a:r>
             <a:br/>
             <a:r>
@@ -7755,11 +7682,11 @@
               </a:defRPr>
             </a:pPr>
             <a:r>
-              <a:t>📌 Tích hợp vào bài tập lớn:</a:t>
-            </a:r>
-            <a:br/>
-            <a:r>
-              <a:t>Đối với các thao tác đặt lịch không reload trang (AJAX Fetch API), nhóm đính kèm header RequestVerificationToken để đảm bảo vừa có trải nghiệm người dùng mượt mà, vừa đảm bảo an toàn tuyệt đối trước các đợt tấn công giả mạo yêu cầu.</a:t>
+              <a:t>Ứng dụng trong đồ án BTL:</a:t>
+            </a:r>
+            <a:br/>
+            <a:r>
+              <a:t>Đối với các tác vụ bất đồng bộ (như đặt lịch hẹn, cập nhật ca làm việc) sử dụng Fetch API, hệ thống đính kèm header RequestVerificationToken để đảm bảo an toàn giao dịch mà không làm suy giảm trải nghiệm người dùng.</a:t>
             </a:r>
           </a:p>
         </p:txBody>
@@ -7909,7 +7836,7 @@
               </a:defRPr>
             </a:pPr>
             <a:r>
-              <a:t>Tổng Kết: So Sánh Đối Chứng 3 Lỗ Hổng Web Kinh Điển</a:t>
+              <a:t>Tổng Kết: So Sánh Đối Chứng 3 Lỗ Hổng An Ninh Web</a:t>
             </a:r>
           </a:p>
         </p:txBody>
@@ -7944,7 +7871,7 @@
               </a:defRPr>
             </a:pPr>
             <a:r>
-              <a:t>Nhóm WNC.G01 (Học - Bình - Cường) • Khoa CNTT - Đại học Mở Hà Nội • GVHD: ThS. Lê Hữu Dũng</a:t>
+              <a:t>Nhóm WNC.G01 • Trường Đại học Mở Hà Nội (HOU) • Giảng viên: ThS. Lê Hữu Dũng</a:t>
             </a:r>
           </a:p>
         </p:txBody>
@@ -7987,7 +7914,7 @@
                         </a:defRPr>
                       </a:pPr>
                       <a:r>
-                        <a:t>Tiêu chí so sánh</a:t>
+                        <a:t>Tiêu chí phân tích</a:t>
                       </a:r>
                     </a:p>
                   </a:txBody>
@@ -8104,7 +8031,7 @@
                         </a:defRPr>
                       </a:pPr>
                       <a:r>
-                        <a:t>Tầng Cơ sở dữ liệu (SQL Server Engine)</a:t>
+                        <a:t>Tầng Cơ sở dữ liệu (Database Engine)</a:t>
                       </a:r>
                     </a:p>
                   </a:txBody>
@@ -8150,7 +8077,7 @@
                         </a:defRPr>
                       </a:pPr>
                       <a:r>
-                        <a:t>Quyền hạn của phiên làm việc (Session/Cookie)</a:t>
+                        <a:t>Quyền hạn phiên làm việc (Session/Cookie)</a:t>
                       </a:r>
                     </a:p>
                   </a:txBody>
@@ -8175,7 +8102,7 @@
                         </a:defRPr>
                       </a:pPr>
                       <a:r>
-                        <a:t>Mức độ nghiêm trọng</a:t>
+                        <a:t>Mức độ rủi ro</a:t>
                       </a:r>
                     </a:p>
                   </a:txBody>
@@ -8269,7 +8196,7 @@
                         </a:defRPr>
                       </a:pPr>
                       <a:r>
-                        <a:t>Giải pháp cốt lõi</a:t>
+                        <a:t>Giải pháp phòng thủ</a:t>
                       </a:r>
                     </a:p>
                   </a:txBody>
@@ -8533,7 +8460,7 @@
               </a:defRPr>
             </a:pPr>
             <a:r>
-              <a:t>Nhóm WNC.G01 (Học - Bình - Cường) • Khoa CNTT - Đại học Mở Hà Nội • GVHD: ThS. Lê Hữu Dũng</a:t>
+              <a:t>Nhóm WNC.G01 • Trường Đại học Mở Hà Nội (HOU) • Giảng viên: ThS. Lê Hữu Dũng</a:t>
             </a:r>
           </a:p>
         </p:txBody>
@@ -8587,7 +8514,7 @@
               </a:defRPr>
             </a:pPr>
             <a:r>
-              <a:t>CAM KẾT CHUẨN AN TOÀN ĐA TẦNG CHO BTL (NHÓM WNC.G01):</a:t>
+              <a:t>ÁP DỤNG KIẾN TRÚC BẢO MẬT ĐA TẦNG CHO BTL (WNC.G01):</a:t>
             </a:r>
           </a:p>
           <a:p>
@@ -8602,41 +8529,37 @@
               </a:defRPr>
             </a:pPr>
             <a:r>
-              <a:t>1. Kiến trúc bảo mật (Security View - Buổi 8): Toàn bộ hệ thống được xây dựng theo nguyên tắc 'Security by Design'. Không xem an ninh là tính năng chắp vá mà tích hợp sâu vào kiến trúc 3 tầng.</a:t>
-            </a:r>
-            <a:br/>
-            <a:br/>
-            <a:r>
-              <a:t>2. Bảo vệ CSDL tuyệt đối (Nguyễn Danh Học): 100% các câu truy vấn đặt lịch, hồ sơ chuyên gia và đánh giá chất lượng được quản lý bằng Entity Framework Core Code-First với LINQ Parameterized.</a:t>
-            </a:r>
-            <a:br/>
-            <a:br/>
-            <a:r>
-              <a:t>3. Bảo vệ dữ liệu người dùng (Nguyễn Thanh Bình): 100% nội dung phản hồi tư vấn và bình luận được Razor View mã hóa tự động, Cookie cấu hình HttpOnly = true và Secure = true.</a:t>
-            </a:r>
-            <a:br/>
-            <a:br/>
-            <a:r>
-              <a:t>4. Bảo vệ giao dịch (Nguyễn Minh Cường): Bắt buộc kiểm tra Anti-Forgery Token trên toàn bộ các form đặt lịch hẹn, nạp tiền ví và đổi mật khẩu.</a:t>
+              <a:t>1. Kiến trúc Security by Design (Buổi 8): Tích hợp đồng bộ các lớp bảo vệ ngay từ giai đoạn thiết kế hệ thống, phân quyền chặt chẽ theo 3 Role (Customer, Specialist, Admin).</a:t>
+            </a:r>
+            <a:br/>
+            <a:br/>
+            <a:r>
+              <a:t>2. Tầng CSDL (Nguyễn Danh Học): Toàn bộ thao tác nghiệp vụ khai thác CSDL qua Entity Framework Core Code-First với LINQ Parameterized, loại bỏ hoàn toàn việc ghép chuỗi truy vấn.</a:t>
+            </a:r>
+            <a:br/>
+            <a:br/>
+            <a:r>
+              <a:t>3. Tầng Giao diện (Nguyễn Thanh Bình): Dữ liệu phản hồi và đánh giá chuyên gia được Razor View mã hóa tự động, Cookie thiết lập đầy đủ thuộc tính HttpOnly và Secure.</a:t>
+            </a:r>
+            <a:br/>
+            <a:br/>
+            <a:r>
+              <a:t>4. Tầng Giao dịch (Nguyễn Minh Cường): Bắt buộc kiểm tra Anti-Forgery Token cho toàn bộ các biểu mẫu POST và yêu cầu Fetch API đặt lịch hẹn, giao dịch ví.</a:t>
             </a:r>
           </a:p>
           <a:p>
             <a:pPr>
               <a:spcBef>
-                <a:spcPts val="1600"/>
+                <a:spcPts val="1800"/>
               </a:spcBef>
-              <a:defRPr sz="1500" b="1">
+              <a:defRPr sz="1400" b="1">
                 <a:solidFill>
                   <a:srgbClr val="BE123C"/>
                 </a:solidFill>
               </a:defRPr>
             </a:pPr>
             <a:r>
-              <a:t>XIN TRÂN TRỌNG CẢM ƠN THẦY VÀ CÁC BẠN ĐÃ THEO DÕI!</a:t>
-            </a:r>
-            <a:br/>
-            <a:r>
-              <a:t>Nhóm WNC.G01 sẵn sàng lắng nghe câu hỏi và nhận xét từ giảng viên.</a:t>
+              <a:t>Kính chúc thầy sức khỏe. Nhóm WNC.G01 xin trân trọng cảm ơn!</a:t>
             </a:r>
           </a:p>
         </p:txBody>
@@ -8786,7 +8709,7 @@
               </a:defRPr>
             </a:pPr>
             <a:r>
-              <a:t>1.1. SQL Injection: Bản Chất Kỹ Thuật &amp; Điểm Mù Ghép Chuỗi</a:t>
+              <a:t>1.1. SQL Injection: Bản Chất Kỹ Thuật &amp; Lỗi Ghép Chuỗi</a:t>
             </a:r>
           </a:p>
         </p:txBody>
@@ -8821,7 +8744,7 @@
               </a:defRPr>
             </a:pPr>
             <a:r>
-              <a:t>Nhóm WNC.G01 (Học - Bình - Cường) • Khoa CNTT - Đại học Mở Hà Nội • GVHD: ThS. Lê Hữu Dũng</a:t>
+              <a:t>Nhóm WNC.G01 • Trường Đại học Mở Hà Nội (HOU) • Giảng viên: ThS. Lê Hữu Dũng</a:t>
             </a:r>
           </a:p>
         </p:txBody>
@@ -8875,7 +8798,7 @@
               </a:defRPr>
             </a:pPr>
             <a:r>
-              <a:t>Nguyên Nhân Cốt Lõi: Nhầm Lẫn Giữa Code &amp; Data</a:t>
+              <a:t>Nguyên Nhân Kỹ Thuật Cốt Lõi</a:t>
             </a:r>
           </a:p>
           <a:p>
@@ -8890,19 +8813,19 @@
               </a:defRPr>
             </a:pPr>
             <a:r>
-              <a:t>• Không phân tách giữa DỮ LIỆU (Data) và CÂU LỆNH (Code).</a:t>
-            </a:r>
-            <a:br/>
-            <a:r>
-              <a:t>• Lập trình viên sử dụng kỹ thuật ghép chuỗi trực tiếp (String Concatenation hoặc Interpolation) để tạo câu SQL từ input của người dùng.</a:t>
-            </a:r>
-            <a:br/>
-            <a:r>
-              <a:t>• Hệ quản trị CSDL khi phân tích cú pháp (Parsing) không thể biết đâu là dữ liệu của user và đâu là cấu trúc lệnh do lập trình viên định nghĩa.</a:t>
-            </a:r>
-            <a:br/>
-            <a:r>
-              <a:t>• Ký tự điều khiển (', --, ;) giúp hacker 'thoát' khỏi phạm vi dữ liệu và ép SQL Server thực thi logic của hacker.</a:t>
+              <a:t>• Thiếu sự phân tách giữa Dữ liệu (Data) và Cú pháp lệnh (Code).</a:t>
+            </a:r>
+            <a:br/>
+            <a:r>
+              <a:t>• Ghép chuỗi đầu vào trực tiếp (String Concatenation / Interpolation) vào truy vấn SQL.</a:t>
+            </a:r>
+            <a:br/>
+            <a:r>
+              <a:t>• Trình thông dịch CSDL không thể phân định ranh giới giữa dữ liệu người dùng và cấu trúc truy vấn của hệ thống.</a:t>
+            </a:r>
+            <a:br/>
+            <a:r>
+              <a:t>• Ký tự điều khiển (', --, ;) làm thay đổi luồng thực thi của câu lệnh trên máy chủ SQL Server.</a:t>
             </a:r>
           </a:p>
         </p:txBody>
@@ -8956,7 +8879,7 @@
               </a:defRPr>
             </a:pPr>
             <a:r>
-              <a:t>Đoạn Code Gây Lỗi Thực Tế Trong Controller</a:t>
+              <a:t>Minh Họa Đoạn Mã Nguồn Gây Lỗi</a:t>
             </a:r>
           </a:p>
           <a:p>
@@ -8972,7 +8895,7 @@
               </a:defRPr>
             </a:pPr>
             <a:r>
-              <a:t>// LỖI NỐI CHUỖI TRỰC TIẾP:</a:t>
+              <a:t>// Nối chuỗi trực tiếp từ tham số người dùng:</a:t>
             </a:r>
             <a:br/>
             <a:r>
@@ -9012,11 +8935,7 @@
               </a:defRPr>
             </a:pPr>
             <a:r>
-              <a:t>⚠️ Điểm mù chết người:</a:t>
-            </a:r>
-            <a:br/>
-            <a:r>
-              <a:t>Lập trình viên mặc định tin rằng input chỉ chứa chữ cái. Khi hacker truyền vào dấu nháy đơn ('), toàn bộ cây cú pháp của câu truy vấn bị bẻ gãy hoàn toàn.</a:t>
+              <a:t>Lỗ hổng phát sinh khi lập trình viên giả định đầu vào luôn là văn bản chuẩn. Ký tự nháy đơn (') sẽ đóng sớm chuỗi giá trị và chuyển phần còn lại thành cấu trúc điều khiển.</a:t>
             </a:r>
           </a:p>
         </p:txBody>
@@ -9166,7 +9085,7 @@
               </a:defRPr>
             </a:pPr>
             <a:r>
-              <a:t>1.2. SQL Injection: Thang Đo Nguy Hiểm &amp; Hậu Quả Thực Tế (CVSS 9.8)</a:t>
+              <a:t>1.2. SQL Injection: Đánh Giá Tác Động An Ninh (CVSS 9.8)</a:t>
             </a:r>
           </a:p>
         </p:txBody>
@@ -9201,7 +9120,7 @@
               </a:defRPr>
             </a:pPr>
             <a:r>
-              <a:t>Nhóm WNC.G01 (Học - Bình - Cường) • Khoa CNTT - Đại học Mở Hà Nội • GVHD: ThS. Lê Hữu Dũng</a:t>
+              <a:t>Nhóm WNC.G01 • Trường Đại học Mở Hà Nội (HOU) • Giảng viên: ThS. Lê Hữu Dũng</a:t>
             </a:r>
           </a:p>
         </p:txBody>
@@ -9255,7 +9174,7 @@
               </a:defRPr>
             </a:pPr>
             <a:r>
-              <a:t>🚨 CHIẾM QUYỀN HỆ THỐNG</a:t>
+              <a:t>VƯỢT QUA XÁC THỰC</a:t>
             </a:r>
             <a:br/>
             <a:r>
@@ -9274,15 +9193,15 @@
               </a:defRPr>
             </a:pPr>
             <a:r>
-              <a:t>• Không cần biết mật khẩu của bất kỳ ai.</a:t>
-            </a:r>
-            <a:br/>
-            <a:r>
-              <a:t>• Chỉ với 1 chuỗi payload ngắn, kẻ tấn công đăng nhập thẳng vào tài khoản Quản trị viên (Admin).</a:t>
-            </a:r>
-            <a:br/>
-            <a:r>
-              <a:t>• Chiếm đoạt phiên làm việc, đổi quyền hạn và kiểm soát toàn bộ hệ thống.</a:t>
+              <a:t>• Không cần thông tin xác thực hợp lệ.</a:t>
+            </a:r>
+            <a:br/>
+            <a:r>
+              <a:t>• Bỏ qua bước kiểm tra mật khẩu để đăng nhập tài khoản quản trị.</a:t>
+            </a:r>
+            <a:br/>
+            <a:r>
+              <a:t>• Chiếm đoạt phiên làm việc và thay đổi quyền hạn người dùng trên hệ thống.</a:t>
             </a:r>
           </a:p>
         </p:txBody>
@@ -9336,7 +9255,7 @@
               </a:defRPr>
             </a:pPr>
             <a:r>
-              <a:t>📂 ĐÁNH CẮP TOÀN BỘ CSDL</a:t>
+              <a:t>TRÍCH XUẤT CƠ SỞ DỮ LIỆU</a:t>
             </a:r>
             <a:br/>
             <a:r>
@@ -9355,15 +9274,15 @@
               </a:defRPr>
             </a:pPr>
             <a:r>
-              <a:t>• Trích xuất thông tin khách hàng, hồ sơ chuyên gia, số dư tài khoản ngân hàng.</a:t>
-            </a:r>
-            <a:br/>
-            <a:r>
-              <a:t>• Rò rỉ mật khẩu và bệnh án cá nhân (Secret Notes).</a:t>
-            </a:r>
-            <a:br/>
-            <a:r>
-              <a:t>• Vi phạm nghiêm trọng an ninh dữ liệu, phá vỡ uy tín của nền tảng tư vấn trực tuyến.</a:t>
+              <a:t>• Trích xuất thông tin người dùng, hồ sơ chuyên gia và số dư ví điện tử.</a:t>
+            </a:r>
+            <a:br/>
+            <a:r>
+              <a:t>• Làm lộ mật khẩu và các thông tin cá nhân lưu trong bảng CSDL.</a:t>
+            </a:r>
+            <a:br/>
+            <a:r>
+              <a:t>• Vi phạm quy định về bảo mật dữ liệu người dùng.</a:t>
             </a:r>
           </a:p>
         </p:txBody>
@@ -9417,11 +9336,11 @@
               </a:defRPr>
             </a:pPr>
             <a:r>
-              <a:t>💣 PHÁ HỦY / THỰC THI LỆNH</a:t>
-            </a:r>
-            <a:br/>
-            <a:r>
-              <a:t>(System Takeover)</a:t>
+              <a:t>THAY ĐỔI / PHÁ HỦY DỮ LIỆU</a:t>
+            </a:r>
+            <a:br/>
+            <a:r>
+              <a:t>(Data Manipulation)</a:t>
             </a:r>
           </a:p>
           <a:p>
@@ -9436,15 +9355,15 @@
               </a:defRPr>
             </a:pPr>
             <a:r>
-              <a:t>• Xóa sạch CSDL với lệnh DROP TABLE hoặc TRUNCATE.</a:t>
-            </a:r>
-            <a:br/>
-            <a:r>
-              <a:t>• Giả mạo số dư tiền trong tài khoản.</a:t>
-            </a:r>
-            <a:br/>
-            <a:r>
-              <a:t>• Trong các CSDL cấu hình lỏng lẻo, hacker có thể bật xp_cmdshell để chiếm quyền điều khiển cả máy chủ hệ điều hành.</a:t>
+              <a:t>• Can thiệp, sửa đổi số dư tài khoản trái phép.</a:t>
+            </a:r>
+            <a:br/>
+            <a:r>
+              <a:t>• Thực thi các câu lệnh DDL nguy hiểm như DROP TABLE hoặc TRUNCATE.</a:t>
+            </a:r>
+            <a:br/>
+            <a:r>
+              <a:t>• Nguy cơ thực thi lệnh hệ điều hành nếu máy chủ CSDL cấp quyền quá mức.</a:t>
             </a:r>
           </a:p>
         </p:txBody>
@@ -9594,7 +9513,7 @@
               </a:defRPr>
             </a:pPr>
             <a:r>
-              <a:t>1.3. SQL Injection: Giải Phẫu Chi Tiết Cơ Chế Bẻ Gãy Cú Pháp</a:t>
+              <a:t>1.3. SQL Injection: Phân Tích Cấu Trúc Khai Thác</a:t>
             </a:r>
           </a:p>
         </p:txBody>
@@ -9629,7 +9548,7 @@
               </a:defRPr>
             </a:pPr>
             <a:r>
-              <a:t>Nhóm WNC.G01 (Học - Bình - Cường) • Khoa CNTT - Đại học Mở Hà Nội • GVHD: ThS. Lê Hữu Dũng</a:t>
+              <a:t>Nhóm WNC.G01 • Trường Đại học Mở Hà Nội (HOU) • Giảng viên: ThS. Lê Hữu Dũng</a:t>
             </a:r>
           </a:p>
         </p:txBody>
@@ -9683,7 +9602,7 @@
               </a:defRPr>
             </a:pPr>
             <a:r>
-              <a:t>Kịch bản: Bắn Payload Bypass Xác Thực Đăng Nhập Quản Trị Viên</a:t>
+              <a:t>Kịch Bản: Khai Thác Vượt Qua Xác Thực Đăng Nhập</a:t>
             </a:r>
           </a:p>
           <a:p>
@@ -9699,11 +9618,11 @@
               </a:defRPr>
             </a:pPr>
             <a:r>
-              <a:t>Payload đưa vào ô Username: ' OR '1'='1' --  | Mật khẩu: (nhập bất kỳ hoặc bỏ trống)</a:t>
-            </a:r>
-            <a:br/>
-            <a:r>
-              <a:t>Câu truy vấn thực tế được SQL Server phân tích &amp; thông dịch:</a:t>
+              <a:t>Giá trị Username đưa vào: ' OR '1'='1' --  | Mật khẩu: (tùy ý hoặc để trống)</a:t>
+            </a:r>
+            <a:br/>
+            <a:r>
+              <a:t>Truy vấn được máy chủ SQL Server phân tích &amp; thông dịch:</a:t>
             </a:r>
             <a:br/>
             <a:r>
@@ -9722,19 +9641,19 @@
               </a:defRPr>
             </a:pPr>
             <a:r>
-              <a:t>3 Thành Phần Khai Thác Cốt Lõi:</a:t>
-            </a:r>
-            <a:br/>
-            <a:r>
-              <a:t>1. Dấu nháy đơn (') : Đóng sớm chuỗi Username, đưa ngữ cảnh trở lại câu lệnh SQL.</a:t>
-            </a:r>
-            <a:br/>
-            <a:r>
-              <a:t>2. Mệnh đề OR '1'='1' : Biểu thức logic chân lý (luôn TRUE cho mọi bản ghi trong bảng Accounts).</a:t>
-            </a:r>
-            <a:br/>
-            <a:r>
-              <a:t>3. Ký tự chú thích (--) : Vô hiệu hóa hoàn toàn bước kiểm tra mật khẩu phía sau (AND Password = '...').</a:t>
+              <a:t>Phân Tích Thành Phần Chuỗi Khai Thác:</a:t>
+            </a:r>
+            <a:br/>
+            <a:r>
+              <a:t>1. Dấu nháy đơn (') : Đóng sớm chuỗi ký tự của trường Username, chuyển ngữ cảnh về cú pháp SQL.</a:t>
+            </a:r>
+            <a:br/>
+            <a:r>
+              <a:t>2. Mệnh đề OR '1'='1' : Biểu thức logic chân lý (luôn TRUE với mọi bản ghi trong bảng Accounts).</a:t>
+            </a:r>
+            <a:br/>
+            <a:r>
+              <a:t>3. Ký tự chú thích (--) : Vô hiệu hóa mệnh đề kiểm tra mật khẩu phía sau (AND Password = '...').</a:t>
             </a:r>
           </a:p>
           <a:p>
@@ -9749,7 +9668,7 @@
               </a:defRPr>
             </a:pPr>
             <a:r>
-              <a:t>📌 Cơ chế tấn công Union-Based (Rút dữ liệu từ bảng khác):</a:t>
+              <a:t>Mở Rộng Kỹ Thuật Union-Based:</a:t>
             </a:r>
             <a:br/>
             <a:r>
@@ -9757,7 +9676,7 @@
             </a:r>
             <a:br/>
             <a:r>
-              <a:t>Cho phép kẻ tấn công ghép nối bảng nhạy cảm vào kết quả hiển thị của màn hình tìm kiếm thông thường!</a:t>
+              <a:t>Cho phép ghép nối kết quả từ bảng dữ liệu nhạy cảm vào màn hình tra cứu thông thường.</a:t>
             </a:r>
           </a:p>
         </p:txBody>
@@ -9942,7 +9861,7 @@
               </a:defRPr>
             </a:pPr>
             <a:r>
-              <a:t>Nhóm WNC.G01 (Học - Bình - Cường) • Khoa CNTT - Đại học Mở Hà Nội • GVHD: ThS. Lê Hữu Dũng</a:t>
+              <a:t>Nhóm WNC.G01 • Trường Đại học Mở Hà Nội (HOU) • Giảng viên: ThS. Lê Hữu Dũng</a:t>
             </a:r>
           </a:p>
         </p:txBody>
@@ -10020,7 +9939,7 @@
               </a:defRPr>
             </a:pPr>
             <a:r>
-              <a:t>💻 [HỌC LIVE DEMO]: Giao diện đối chứng thực tế trên Web UI (http://localhost:5076/SqlInjection)</a:t>
+              <a:t>Minh chứng đối chứng trực tiếp trên ứng dụng (http://localhost:5076/SqlInjection)</a:t>
             </a:r>
           </a:p>
           <a:p>
@@ -10035,11 +9954,11 @@
               </a:defRPr>
             </a:pPr>
             <a:r>
-              <a:t>• Bên Trái (Vulnerable): Bắn payload ' OR '1'='1' -- -&gt; Bypass đăng nhập, trích xuất toàn bộ mật khẩu và số dư CSDL.</a:t>
-            </a:r>
-            <a:br/>
-            <a:r>
-              <a:t>• Bên Phải (Secure): Cùng payload đưa sang EF Core LINQ -&gt; Chặn đứng hoàn toàn, bảo vệ an toàn 100%.</a:t>
+              <a:t>• Nhánh dính lỗi (Trái): Chuỗi ' OR '1'='1' -- cho phép đăng nhập thành công và trích xuất danh sách tài khoản.</a:t>
+            </a:r>
+            <a:br/>
+            <a:r>
+              <a:t>• Nhánh phòng thủ (Phải): Ứng dụng xử lý an toàn qua EF Core LINQ, từ chối truy cập và bảo vệ dữ liệu.</a:t>
             </a:r>
           </a:p>
         </p:txBody>
@@ -10224,7 +10143,7 @@
               </a:defRPr>
             </a:pPr>
             <a:r>
-              <a:t>Nhóm WNC.G01 (Học - Bình - Cường) • Khoa CNTT - Đại học Mở Hà Nội • GVHD: ThS. Lê Hữu Dũng</a:t>
+              <a:t>Nhóm WNC.G01 • Trường Đại học Mở Hà Nội (HOU) • Giảng viên: ThS. Lê Hữu Dũng</a:t>
             </a:r>
           </a:p>
         </p:txBody>
@@ -10323,7 +10242,7 @@
             </a:r>
             <a:br/>
             <a:r>
-              <a:t>  "accounts": [ ... 4 tài khoản bị rò rỉ ... ]</a:t>
+              <a:t>  "accounts": [ ... danh sách tài khoản trích xuất ... ]</a:t>
             </a:r>
             <a:br/>
             <a:r>
@@ -10342,7 +10261,7 @@
               </a:defRPr>
             </a:pPr>
             <a:r>
-              <a:t>📌 Ý nghĩa: Chứng minh lỗ hổng nằm ở logic C# Backend, kẻ tấn công dùng script tự động quét và khai thác mà không cần mở web.</a:t>
+              <a:t>Xác nhận lỗi xuất phát từ tầng xử lý C# Backend, kẻ tấn công có thể khai thác qua API mà không cần tương tác qua giao diện web.</a:t>
             </a:r>
           </a:p>
         </p:txBody>
@@ -10396,7 +10315,7 @@
               </a:defRPr>
             </a:pPr>
             <a:r>
-              <a:t>Minh Chứng Tầng CSDL (SQL Server 2025 Thật)</a:t>
+              <a:t>Minh Chứng Tầng CSDL (SQL Server 2025)</a:t>
             </a:r>
           </a:p>
           <a:p>
@@ -10416,7 +10335,7 @@
             </a:r>
             <a:br/>
             <a:r>
-              <a:t>-- 1. Câu lệnh dính lỗi:</a:t>
+              <a:t>-- 1. Truy vấn dính lỗi:</a:t>
             </a:r>
             <a:br/>
             <a:r>
@@ -10429,7 +10348,7 @@
             <a:br/>
             <a:br/>
             <a:r>
-              <a:t>-- 2. Câu lệnh tham số hóa chuẩn:</a:t>
+              <a:t>-- 2. Truy vấn tham số hóa:</a:t>
             </a:r>
             <a:br/>
             <a:r>
@@ -10441,7 +10360,7 @@
             </a:r>
             <a:br/>
             <a:r>
-              <a:t>&gt;&gt; Kết quả: 0 rows returned (An toàn 100%)</a:t>
+              <a:t>&gt;&gt; Kết quả: 0 rows returned (An toàn)</a:t>
             </a:r>
           </a:p>
           <a:p>
@@ -10456,7 +10375,7 @@
               </a:defRPr>
             </a:pPr>
             <a:r>
-              <a:t>📌 Ý nghĩa: Đối chiếu trực tiếp trên máy chủ SQL Server 2025 chứng minh cơ chế phân tách rạch ròi giữa cú pháp lệnh và tham số giá trị.</a:t>
+              <a:t>Đối chiếu trực tiếp trên máy chủ CSDL chứng minh cơ chế phân tách rạch ròi giữa cú pháp lệnh và tham số giá trị.</a:t>
             </a:r>
           </a:p>
         </p:txBody>
@@ -10503,14 +10422,14 @@
           <a:lstStyle/>
           <a:p>
             <a:pPr algn="ctr">
-              <a:defRPr sz="1250" b="1">
+              <a:defRPr sz="1200" b="1">
                 <a:solidFill>
                   <a:srgbClr val="047857"/>
                 </a:solidFill>
               </a:defRPr>
             </a:pPr>
             <a:r>
-              <a:t>🗄️ [HỌC LIVE DEMO]: Chuyển sang VS Code mở bảng dbo.Accounts &amp; file verify_sql_server.sql</a:t>
+              <a:t>Thao tác trên công cụ: VS Code MSSQL Extension &amp; File verify_sql_server.sql</a:t>
             </a:r>
           </a:p>
           <a:p>
@@ -10525,7 +10444,7 @@
               </a:defRPr>
             </a:pPr>
             <a:r>
-              <a:t>Thao tác trực tiếp: Mở extension MSSQL trên VS Code, đối chiếu bảng dữ liệu gốc và chạy câu query đối chứng.</a:t>
+              <a:t>Dữ liệu được truy vấn và kiểm thử trực tiếp trên máy chủ CSDL SQL Server 2025 (Database: OwaspDemoDB).</a:t>
             </a:r>
           </a:p>
         </p:txBody>
@@ -10675,7 +10594,7 @@
               </a:defRPr>
             </a:pPr>
             <a:r>
-              <a:t>1.6. SQL Injection: Giải Pháp Phòng Thủ Toàn Diện (Defense-in-Depth)</a:t>
+              <a:t>1.6. SQL Injection: Giải Pháp Phòng Thủ Chuẩn Hóa</a:t>
             </a:r>
           </a:p>
         </p:txBody>
@@ -10710,7 +10629,7 @@
               </a:defRPr>
             </a:pPr>
             <a:r>
-              <a:t>Nhóm WNC.G01 (Học - Bình - Cường) • Khoa CNTT - Đại học Mở Hà Nội • GVHD: ThS. Lê Hữu Dũng</a:t>
+              <a:t>Nhóm WNC.G01 • Trường Đại học Mở Hà Nội (HOU) • Giảng viên: ThS. Lê Hữu Dũng</a:t>
             </a:r>
           </a:p>
         </p:txBody>
@@ -10764,7 +10683,7 @@
               </a:defRPr>
             </a:pPr>
             <a:r>
-              <a:t>Cách Viết Code Chuẩn Hóa Với EF Core</a:t>
+              <a:t>Kỹ Thuật Parameterized Query Với EF Core</a:t>
             </a:r>
           </a:p>
           <a:p>
@@ -10780,7 +10699,7 @@
               </a:defRPr>
             </a:pPr>
             <a:r>
-              <a:t>// Dùng LINQ Parameterized (KHUYÊN DÙNG):</a:t>
+              <a:t>// SỬ DỤNG LINQ PARAMETERIZED (KHUYÊN DÙNG):</a:t>
             </a:r>
             <a:br/>
             <a:r>
@@ -10797,7 +10716,7 @@
             <a:br/>
             <a:br/>
             <a:r>
-              <a:t>// Hoặc dùng FromSqlInterpolated nếu viết SQL thuần:</a:t>
+              <a:t>// TRUY VẤN THUẦN QUA FROMSQLINTERPOLATED:</a:t>
             </a:r>
             <a:br/>
             <a:r>
@@ -10824,11 +10743,11 @@
               </a:defRPr>
             </a:pPr>
             <a:r>
-              <a:t>Tại sao cách này an toàn tuyệt đối?</a:t>
-            </a:r>
-            <a:br/>
-            <a:r>
-              <a:t>SQL Server biên dịch cấu trúc lệnh TRƯỚC khi gán dữ liệu. Biến @p0 nhận toàn bộ payload như một chuỗi chữ bình thường, vô hiệu hóa hoàn toàn ý đồ chèn lệnh.</a:t>
+              <a:t>Cơ chế bảo vệ:</a:t>
+            </a:r>
+            <a:br/>
+            <a:r>
+              <a:t>SQL Server biên dịch kế hoạch thực thi (Execution Plan) trước khi nhận tham số. Đầu vào của người dùng được gán vào biến @p0 như một chuỗi văn bản (literal), vô hiệu hóa hoàn toàn khả năng chèn lệnh.</a:t>
             </a:r>
           </a:p>
         </p:txBody>
@@ -10882,7 +10801,7 @@
               </a:defRPr>
             </a:pPr>
             <a:r>
-              <a:t>Bộ Quy Tắc Phòng Thủ Toàn Diện (Defense in Depth)</a:t>
+              <a:t>Bộ Quy Tắc Phòng Thủ Toàn Diện (Defense-in-Depth)</a:t>
             </a:r>
           </a:p>
           <a:p>
@@ -10897,38 +10816,38 @@
               </a:defRPr>
             </a:pPr>
             <a:r>
-              <a:t>1. Luôn sử dụng Parameterized Query / ORM:</a:t>
-            </a:r>
-            <a:br/>
-            <a:r>
-              <a:t>Tuyệt đối không ghép chuỗi SQL thủ công dưới bất kỳ hình thức nào.</a:t>
-            </a:r>
-            <a:br/>
-            <a:br/>
-            <a:r>
-              <a:t>2. Nguyên tắc đặc quyền tối thiểu (Least Privilege):</a:t>
-            </a:r>
-            <a:br/>
-            <a:r>
-              <a:t>Tài khoản kết nối CSDL của ứng dụng chỉ có quyền SELECT/INSERT/UPDATE trên các bảng cần thiết, không bao giờ dùng tài khoản 'sa' hay quyền DDL (DROP, ALTER).</a:t>
-            </a:r>
-            <a:br/>
-            <a:br/>
-            <a:r>
-              <a:t>3. Xác thực dữ liệu đầu vào (Input Validation):</a:t>
-            </a:r>
-            <a:br/>
-            <a:r>
-              <a:t>Sử dụng Data Annotations ([RegularExpression], [StringLength]) kiểm tra chặt chẽ khuôn dạng dữ liệu.</a:t>
-            </a:r>
-            <a:br/>
-            <a:br/>
-            <a:r>
-              <a:t>4. Mã hóa mật khẩu một chiều (Password Hashing):</a:t>
-            </a:r>
-            <a:br/>
-            <a:r>
-              <a:t>Sử dụng ASP.NET Core Identity (PBKDF2/BCrypt) để nếu CSDL có bị lộ, mật khẩu vẫn được bảo vệ an toàn.</a:t>
+              <a:t>1. Tham số hóa truy vấn:</a:t>
+            </a:r>
+            <a:br/>
+            <a:r>
+              <a:t>Tuyệt đối không ghép chuỗi SQL thủ công trong mã nguồn.</a:t>
+            </a:r>
+            <a:br/>
+            <a:br/>
+            <a:r>
+              <a:t>2. Đặc quyền tối thiểu (Least Privilege):</a:t>
+            </a:r>
+            <a:br/>
+            <a:r>
+              <a:t>Tài khoản kết nối CSDL chỉ cấp các quyền SELECT, INSERT, UPDATE cần thiết; không dùng tài khoản 'sa' hay quyền DDL trong môi trường chạy ứng dụng.</a:t>
+            </a:r>
+            <a:br/>
+            <a:br/>
+            <a:r>
+              <a:t>3. Kiểm tra dữ liệu đầu vào (Input Validation):</a:t>
+            </a:r>
+            <a:br/>
+            <a:r>
+              <a:t>Sử dụng Data Annotations để giới hạn định dạng và độ dài dữ liệu.</a:t>
+            </a:r>
+            <a:br/>
+            <a:br/>
+            <a:r>
+              <a:t>4. Băm mật khẩu (Password Hashing):</a:t>
+            </a:r>
+            <a:br/>
+            <a:r>
+              <a:t>Sử dụng ASP.NET Core Identity (PBKDF2) để bảo vệ thông tin ngay cả khi CSDL bị lộ.</a:t>
             </a:r>
           </a:p>
         </p:txBody>
@@ -11078,7 +10997,7 @@
               </a:defRPr>
             </a:pPr>
             <a:r>
-              <a:t>2.1. Stored XSS: Bản Chất Kỹ Thuật &amp; Ngữ Cảnh Bài Toán</a:t>
+              <a:t>2.1. Stored XSS: Bản Chất Kỹ Thuật &amp; Ngữ Cảnh Ứng Dụng</a:t>
             </a:r>
           </a:p>
         </p:txBody>
@@ -11113,7 +11032,7 @@
               </a:defRPr>
             </a:pPr>
             <a:r>
-              <a:t>Nhóm WNC.G01 (Học - Bình - Cường) • Khoa CNTT - Đại học Mở Hà Nội • GVHD: ThS. Lê Hữu Dũng</a:t>
+              <a:t>Nhóm WNC.G01 • Trường Đại học Mở Hà Nội (HOU) • Giảng viên: ThS. Lê Hữu Dũng</a:t>
             </a:r>
           </a:p>
         </p:txBody>
@@ -11167,7 +11086,7 @@
               </a:defRPr>
             </a:pPr>
             <a:r>
-              <a:t>Ngữ Cảnh Nghiệp Vụ Trong Website Tư Vấn</a:t>
+              <a:t>Ngữ Cảnh Nghiệp Vụ Trong Hệ Thống</a:t>
             </a:r>
           </a:p>
           <a:p>
@@ -11182,19 +11101,15 @@
               </a:defRPr>
             </a:pPr>
             <a:r>
-              <a:t>• Trong website tư vấn trực tuyến, khách hàng có chức năng đăng đánh giá, nhận xét và gửi câu hỏi tư vấn.</a:t>
-            </a:r>
-            <a:br/>
-            <a:r>
-              <a:t>• Bản chất Stored XSS (Persistent XSS): Kẻ tấn công nhúng mã JavaScript độc hại vào nội dung nhận xét.</a:t>
-            </a:r>
-            <a:br/>
-            <a:r>
-              <a:t>• Máy chủ không lọc mà lưu thẳng mã độc vào CSDL (bảng dbo.Comments).</a:t>
-            </a:r>
-            <a:br/>
-            <a:r>
-              <a:t>• Nguy hiểm: Mỗi khi bất kỳ người dùng khác, chuyên gia hoặc quản trị viên mở trang đánh giá, trình duyệt của họ sẽ tự động biên dịch và thực thi đoạn script độc hại đó.</a:t>
+              <a:t>• Hệ thống cho phép người dùng đăng tải nhận xét, đánh giá chất lượng buổi tư vấn.</a:t>
+            </a:r>
+            <a:br/>
+            <a:r>
+              <a:t>• Bản chất Stored XSS (Persistent XSS): Mã kịch bản (JavaScript) độc hại được gửi lên và lưu trữ trực tiếp trong CSDL (bảng dbo.Comments).</a:t>
+            </a:r>
+            <a:br/>
+            <a:r>
+              <a:t>• Đặc điểm phát tán: Khi người dùng khác truy cập trang web, mã kịch bản lưu trong CSDL được tải về và thực thi tự động trên trình duyệt của nạn nhân mà không cần tương tác thêm.</a:t>
             </a:r>
           </a:p>
         </p:txBody>
@@ -11248,7 +11163,7 @@
               </a:defRPr>
             </a:pPr>
             <a:r>
-              <a:t>Mã Nguồn C# Gây Lỗi &amp; Sự Lạm Dụng @@Html.Raw</a:t>
+              <a:t>Mã Nguồn Minh Họa Lỗi &amp; Sự Lạm Dụng @@Html.Raw</a:t>
             </a:r>
           </a:p>
           <a:p>
@@ -11264,7 +11179,7 @@
               </a:defRPr>
             </a:pPr>
             <a:r>
-              <a:t>// 1. CONTROLLER LƯU NGUYÊN VĂN KHÔNG LÀM SẠCH:</a:t>
+              <a:t>// 1. CONTROLLER LƯU TRỰC TIẾP KHÔNG QUA XỬ LÝ:</a:t>
             </a:r>
             <a:br/>
             <a:r>
@@ -11276,7 +11191,7 @@
             </a:r>
             <a:br/>
             <a:r>
-              <a:t>    Content = content // Chứa thẻ &lt;script&gt; độc hại</a:t>
+              <a:t>    Content = content // Chứa mã &lt;script&gt; độc hại</a:t>
             </a:r>
             <a:br/>
             <a:r>
@@ -11289,7 +11204,7 @@
             <a:br/>
             <a:br/>
             <a:r>
-              <a:t>// 2. RAZOR VIEW LẠM DỤNG HTML.RAW:</a:t>
+              <a:t>// 2. RAZOR VIEW HIỂN THỊ DỮ LIỆU THÔ:</a:t>
             </a:r>
             <a:br/>
             <a:r>
@@ -11297,7 +11212,7 @@
             </a:r>
             <a:br/>
             <a:r>
-              <a:t>    @Html.Raw(comment.Content) </a:t>
+              <a:t>    @Html.Raw(comment.Content)</a:t>
             </a:r>
             <a:br/>
             <a:r>
@@ -11316,11 +11231,7 @@
               </a:defRPr>
             </a:pPr>
             <a:r>
-              <a:t>⚠️ Điểm mù lập trình viên:</a:t>
-            </a:r>
-            <a:br/>
-            <a:r>
-              <a:t>Sử dụng @Html.Raw() với mục đích cho phép hiển thị format HTML nhưng vô tình mở toang cánh cửa cho hacker thực thi JavaScript trên máy nạn nhân.</a:t>
+              <a:t>Việc sử dụng @Html.Raw() nhằm mục đích hiển thị định dạng văn bản vô tình làm vô hiệu hóa cơ chế phòng vệ mã hóa HTML tự động của Razor View.</a:t>
             </a:r>
           </a:p>
         </p:txBody>

</xml_diff>

<commit_message>
feat: embed crystal-clear Chrome DevTools inspector views (Network, Application, Headers) into slides 5, 11, and 16
</commit_message>
<xml_diff>
--- a/Slide_OWASP_Top3_Nhom_WNC_G01.pptx
+++ b/Slide_OWASP_Top3_Nhom_WNC_G01.pptx
@@ -3975,7 +3975,7 @@
               </a:defRPr>
             </a:pPr>
             <a:r>
-              <a:t>2.4. Stored XSS: Minh Chứng Thực Nghiệm Trực Quan Trên Web UI</a:t>
+              <a:t>2.4. Stored XSS: Minh Chứng Kiểm Thử Qua Chrome DevTools (Application &amp; Console)</a:t>
             </a:r>
           </a:p>
         </p:txBody>
@@ -4018,7 +4018,7 @@
       </p:sp>
       <p:pic>
         <p:nvPicPr>
-          <p:cNvPr id="6" name="Picture 5" descr="final_xss_proof.png"/>
+          <p:cNvPr id="6" name="Picture 5" descr="02_xss_devtools_proof.png"/>
           <p:cNvPicPr>
             <a:picLocks noChangeAspect="1"/>
           </p:cNvPicPr>
@@ -4032,8 +4032,8 @@
         </p:blipFill>
         <p:spPr>
           <a:xfrm>
-            <a:off x="2615184" y="1234440"/>
-            <a:ext cx="6949440" cy="4584700"/>
+            <a:off x="1883664" y="1234440"/>
+            <a:ext cx="8412480" cy="4732020"/>
           </a:xfrm>
           <a:prstGeom prst="rect">
             <a:avLst/>
@@ -4071,7 +4071,7 @@
               </a:defRPr>
             </a:pPr>
             <a:r>
-              <a:t>Minh chứng đối chứng: Đoạn script độc hại lưu trữ trong CSDL (Trái) vs Cơ chế tự động mã hóa HTML của Razor View (Phải)</a:t>
+              <a:t>Minh chứng đối chứng: Soi Cookie lưu trữ (HttpOnly = false) &amp; Lệnh JavaScript document.cookie đọc trộm Session Token (Trái) vs Cơ chế tự động mã hóa HTML của Razor View (Phải)</a:t>
             </a:r>
           </a:p>
         </p:txBody>
@@ -5682,7 +5682,7 @@
               </a:defRPr>
             </a:pPr>
             <a:r>
-              <a:t>3.3. CSRF Attack: Minh Chứng Thực Nghiệm Trực Quan Trên Web UI</a:t>
+              <a:t>3.3. CSRF Attack: Minh Chứng Kiểm Thử Qua Chrome DevTools (Request Headers)</a:t>
             </a:r>
           </a:p>
         </p:txBody>
@@ -5725,7 +5725,7 @@
       </p:sp>
       <p:pic>
         <p:nvPicPr>
-          <p:cNvPr id="6" name="Picture 5" descr="final_csrf_proof.png"/>
+          <p:cNvPr id="6" name="Picture 5" descr="03_csrf_devtools_proof.png"/>
           <p:cNvPicPr>
             <a:picLocks noChangeAspect="1"/>
           </p:cNvPicPr>
@@ -5739,8 +5739,8 @@
         </p:blipFill>
         <p:spPr>
           <a:xfrm>
-            <a:off x="2523744" y="1234440"/>
-            <a:ext cx="7132320" cy="4585063"/>
+            <a:off x="1883664" y="1234440"/>
+            <a:ext cx="8412480" cy="4732020"/>
           </a:xfrm>
           <a:prstGeom prst="rect">
             <a:avLst/>
@@ -5778,7 +5778,7 @@
               </a:defRPr>
             </a:pPr>
             <a:r>
-              <a:t>Minh chứng đối chứng: Bị rút 20.000.000 VNĐ qua biểu mẫu ẩn của Hacker (Trái) vs Chặn đứng yêu cầu thiếu Token (Phải)</a:t>
+              <a:t>Minh chứng đối chứng: Soi gói tin HTTP POST gửi ngầm từ Attacker Site: Đính kèm Cookie tự động nhưng thiếu Anti-Forgery Token của Hacker (Trái) vs Chặn đứng yêu cầu thiếu Token (Phải)</a:t>
             </a:r>
           </a:p>
         </p:txBody>
@@ -8280,7 +8280,7 @@
               </a:defRPr>
             </a:pPr>
             <a:r>
-              <a:t>1.4. SQL Injection: Minh Chứng Thực Nghiệm Trực Quan Trên Web UI</a:t>
+              <a:t>1.4. SQL Injection: Minh Chứng Kiểm Thử Qua Chrome DevTools (Network)</a:t>
             </a:r>
           </a:p>
         </p:txBody>
@@ -8323,7 +8323,7 @@
       </p:sp>
       <p:pic>
         <p:nvPicPr>
-          <p:cNvPr id="6" name="Picture 5" descr="final_sqli_proof.png"/>
+          <p:cNvPr id="6" name="Picture 5" descr="01_sqli_devtools_proof.png"/>
           <p:cNvPicPr>
             <a:picLocks noChangeAspect="1"/>
           </p:cNvPicPr>
@@ -8337,8 +8337,8 @@
         </p:blipFill>
         <p:spPr>
           <a:xfrm>
-            <a:off x="2066543" y="1234440"/>
-            <a:ext cx="8046720" cy="4754880"/>
+            <a:off x="1883664" y="1234440"/>
+            <a:ext cx="8412480" cy="4732020"/>
           </a:xfrm>
           <a:prstGeom prst="rect">
             <a:avLst/>
@@ -8362,7 +8362,7 @@
           <a:noFill/>
         </p:spPr>
         <p:txBody>
-          <a:bodyPr wrap="none" tIns="0" bIns="0" lIns="0" rIns="0">
+          <a:bodyPr wrap="none">
             <a:spAutoFit/>
           </a:bodyPr>
           <a:lstStyle/>
@@ -8376,7 +8376,7 @@
               </a:defRPr>
             </a:pPr>
             <a:r>
-              <a:t>Minh chứng đối chứng: Trích xuất 4 tài khoản CSDL khi inject ' OR '1'='1' -- (Trái) vs Chặn đứng an toàn với EF Core (Phải)</a:t>
+              <a:t>Minh chứng đối chứng: Kiểm tra gói tin mạng (Network Fetch/XHR): Payload gửi lên và JSON trích xuất CSDL ' OR '1'='1' -- (Trái) vs Chặn đứng an toàn với EF Core (Phải)</a:t>
             </a:r>
           </a:p>
         </p:txBody>

</xml_diff>

<commit_message>
feat: complete master 20-slide presentation deck with full multi-scenario test matrices and crystal-clear Chrome DevTools inspection slides
</commit_message>
<xml_diff>
--- a/Slide_OWASP_Top3_Nhom_WNC_G01.pptx
+++ b/Slide_OWASP_Top3_Nhom_WNC_G01.pptx
@@ -24,6 +24,7 @@
     <p:sldId id="272" r:id="rId23"/>
     <p:sldId id="273" r:id="rId24"/>
     <p:sldId id="274" r:id="rId25"/>
+    <p:sldId id="275" r:id="rId26"/>
   </p:sldIdLst>
   <p:sldSz cx="12191695" cy="6858000" type="screen4x3"/>
   <p:notesSz cx="6858000" cy="9144000"/>
@@ -3583,7 +3584,7 @@
         <p:spPr>
           <a:xfrm>
             <a:off x="731520" y="256032"/>
-            <a:ext cx="4389120" cy="329184"/>
+            <a:ext cx="4572000" cy="329184"/>
           </a:xfrm>
           <a:prstGeom prst="roundRect">
             <a:avLst/>
@@ -3660,7 +3661,7 @@
               </a:defRPr>
             </a:pPr>
             <a:r>
-              <a:t>2.3. Stored XSS: Phân Tích Các Kỹ Thuật Tiêm Payload</a:t>
+              <a:t>2.3. Stored XSS: Minh Chứng Thực Nghiệm Trực Quan Trên Web UI</a:t>
             </a:r>
           </a:p>
         </p:txBody>
@@ -3674,7 +3675,7 @@
         <p:spPr>
           <a:xfrm>
             <a:off x="731520" y="6537960"/>
-            <a:ext cx="10698480" cy="274320"/>
+            <a:ext cx="10698480" cy="256032"/>
           </a:xfrm>
           <a:prstGeom prst="rect">
             <a:avLst/>
@@ -3701,49 +3702,54 @@
           </a:p>
         </p:txBody>
       </p:sp>
-      <p:sp>
-        <p:nvSpPr>
-          <p:cNvPr id="6" name="Rounded Rectangle 5"/>
-          <p:cNvSpPr/>
-          <p:nvPr/>
-        </p:nvSpPr>
-        <p:spPr>
-          <a:xfrm>
-            <a:off x="731520" y="1234440"/>
-            <a:ext cx="10728655" cy="4937760"/>
-          </a:xfrm>
-          <a:prstGeom prst="roundRect">
-            <a:avLst/>
-          </a:prstGeom>
-          <a:solidFill>
-            <a:srgbClr val="F8FAFC"/>
-          </a:solidFill>
-          <a:ln>
-            <a:solidFill>
-              <a:srgbClr val="E2E8F0"/>
-            </a:solidFill>
-          </a:ln>
-        </p:spPr>
-        <p:style>
-          <a:lnRef idx="1">
-            <a:schemeClr val="accent1"/>
-          </a:lnRef>
-          <a:fillRef idx="3">
-            <a:schemeClr val="accent1"/>
-          </a:fillRef>
-          <a:effectRef idx="2">
-            <a:schemeClr val="accent1"/>
-          </a:effectRef>
-          <a:fontRef idx="minor">
-            <a:schemeClr val="lt1"/>
-          </a:fontRef>
-        </p:style>
-        <p:txBody>
-          <a:bodyPr rtlCol="0" anchor="ctr"/>
+      <p:pic>
+        <p:nvPicPr>
+          <p:cNvPr id="6" name="Picture 5" descr="final_xss_proof.png"/>
+          <p:cNvPicPr>
+            <a:picLocks noChangeAspect="1"/>
+          </p:cNvPicPr>
+          <p:nvPr/>
+        </p:nvPicPr>
+        <p:blipFill>
+          <a:blip r:embed="rId2"/>
+          <a:stretch>
+            <a:fillRect/>
+          </a:stretch>
+        </p:blipFill>
+        <p:spPr>
+          <a:xfrm>
+            <a:off x="2615184" y="1234440"/>
+            <a:ext cx="6949440" cy="4584700"/>
+          </a:xfrm>
+          <a:prstGeom prst="rect">
+            <a:avLst/>
+          </a:prstGeom>
+        </p:spPr>
+      </p:pic>
+      <p:sp>
+        <p:nvSpPr>
+          <p:cNvPr id="7" name="TextBox 6"/>
+          <p:cNvSpPr txBox="1"/>
+          <p:nvPr/>
+        </p:nvSpPr>
+        <p:spPr>
+          <a:xfrm>
+            <a:off x="731520" y="6016752"/>
+            <a:ext cx="10728655" cy="365760"/>
+          </a:xfrm>
+          <a:prstGeom prst="rect">
+            <a:avLst/>
+          </a:prstGeom>
+          <a:noFill/>
+        </p:spPr>
+        <p:txBody>
+          <a:bodyPr wrap="none">
+            <a:spAutoFit/>
+          </a:bodyPr>
           <a:lstStyle/>
           <a:p>
             <a:pPr algn="ctr">
-              <a:defRPr sz="1500" b="1">
+              <a:defRPr sz="1100" b="1">
                 <a:solidFill>
                   <a:srgbClr val="BE123C"/>
                 </a:solidFill>
@@ -3751,79 +3757,7 @@
               </a:defRPr>
             </a:pPr>
             <a:r>
-              <a:t>3 Biến Thể Payload XSS Thực Nghiệm Trong Hệ Thống</a:t>
-            </a:r>
-          </a:p>
-          <a:p>
-            <a:pPr>
-              <a:spcBef>
-                <a:spcPts val="800"/>
-              </a:spcBef>
-              <a:defRPr sz="1250" b="0">
-                <a:solidFill>
-                  <a:srgbClr val="334155"/>
-                </a:solidFill>
-                <a:latin typeface="Arial"/>
-              </a:defRPr>
-            </a:pPr>
-            <a:r>
-              <a:t>1. Payload 1 (Thẻ Script Cơ Bản):</a:t>
-            </a:r>
-            <a:br/>
-            <a:r>
-              <a:t>   &lt;script&gt;alert('Session Cookie: ' + document.cookie);&lt;/script&gt;</a:t>
-            </a:r>
-            <a:br/>
-            <a:r>
-              <a:t>   Cơ chế: Trình duyệt phân tích cú pháp HTML, nhận diện khối mã và thực thi câu lệnh JavaScript.</a:t>
-            </a:r>
-          </a:p>
-          <a:p>
-            <a:pPr>
-              <a:spcBef>
-                <a:spcPts val="800"/>
-              </a:spcBef>
-              <a:defRPr sz="1250" b="0">
-                <a:solidFill>
-                  <a:srgbClr val="334155"/>
-                </a:solidFill>
-                <a:latin typeface="Arial"/>
-              </a:defRPr>
-            </a:pPr>
-            <a:r>
-              <a:t>2. Payload 2 (Vượt Qua Bộ Lọc Bằng Trình Xử Lý Sự Kiện HTML):</a:t>
-            </a:r>
-            <a:br/>
-            <a:r>
-              <a:t>   &lt;img src=x onerror=alert('XSS triggered via image onerror')&gt;</a:t>
-            </a:r>
-            <a:br/>
-            <a:r>
-              <a:t>   Cơ chế: Khi ứng dụng chỉ lọc từ khóa '&lt;script&gt;', kẻ tấn công sử dụng thuộc tính 'onerror' của thẻ hình ảnh khi đường dẫn ảnh không tồn tại để kích hoạt JavaScript.</a:t>
-            </a:r>
-          </a:p>
-          <a:p>
-            <a:pPr>
-              <a:spcBef>
-                <a:spcPts val="800"/>
-              </a:spcBef>
-              <a:defRPr sz="1250" b="0">
-                <a:solidFill>
-                  <a:srgbClr val="334155"/>
-                </a:solidFill>
-                <a:latin typeface="Arial"/>
-              </a:defRPr>
-            </a:pPr>
-            <a:r>
-              <a:t>3. Payload 3 (Thay Đổi Toàn Bộ Cấu Trúc Trang Web):</a:t>
-            </a:r>
-            <a:br/>
-            <a:r>
-              <a:t>   &lt;script&gt;document.body.innerHTML='&lt;h2 style=color:red;text-align:center&gt;Trang Web Đã Bị Thay Đổi&lt;/h2&gt;';&lt;/script&gt;</a:t>
-            </a:r>
-            <a:br/>
-            <a:r>
-              <a:t>   Cơ chế: Can thiệp trực tiếp vào thuộc tính body.innerHTML để thay đổi toàn bộ nội dung hiển thị của website.</a:t>
+              <a:t>Minh chứng đối chứng chức năng Đánh giá: Nhánh dính lỗi kích hoạt popup Alert (Trái) vs Nhánh an toàn mã hóa HTML (Phải)</a:t>
             </a:r>
           </a:p>
         </p:txBody>
@@ -3898,7 +3832,7 @@
         <p:spPr>
           <a:xfrm>
             <a:off x="731520" y="256032"/>
-            <a:ext cx="4389120" cy="329184"/>
+            <a:ext cx="4572000" cy="329184"/>
           </a:xfrm>
           <a:prstGeom prst="roundRect">
             <a:avLst/>
@@ -3989,7 +3923,7 @@
         <p:spPr>
           <a:xfrm>
             <a:off x="731520" y="6537960"/>
-            <a:ext cx="10698480" cy="274320"/>
+            <a:ext cx="10698480" cy="256032"/>
           </a:xfrm>
           <a:prstGeom prst="rect">
             <a:avLst/>
@@ -4048,7 +3982,7 @@
         </p:nvSpPr>
         <p:spPr>
           <a:xfrm>
-            <a:off x="731520" y="6016752"/>
+            <a:off x="731520" y="6053328"/>
             <a:ext cx="10728655" cy="365760"/>
           </a:xfrm>
           <a:prstGeom prst="rect">
@@ -4057,7 +3991,7 @@
           <a:noFill/>
         </p:spPr>
         <p:txBody>
-          <a:bodyPr wrap="none" tIns="0" bIns="0" lIns="0" rIns="0">
+          <a:bodyPr wrap="none">
             <a:spAutoFit/>
           </a:bodyPr>
           <a:lstStyle/>
@@ -4071,7 +4005,7 @@
               </a:defRPr>
             </a:pPr>
             <a:r>
-              <a:t>Minh chứng đối chứng: Soi Cookie lưu trữ (HttpOnly = false) &amp; Lệnh JavaScript document.cookie đọc trộm Session Token (Trái) vs Cơ chế tự động mã hóa HTML của Razor View (Phải)</a:t>
+              <a:t>Soi Cookie lưu trữ (HttpOnly = false) &amp; Cửa sổ Console: Lệnh JavaScript document.cookie đọc trộm toàn bộ AuthSessionToken</a:t>
             </a:r>
           </a:p>
         </p:txBody>
@@ -4146,7 +4080,7 @@
         <p:spPr>
           <a:xfrm>
             <a:off x="731520" y="256032"/>
-            <a:ext cx="4389120" cy="329184"/>
+            <a:ext cx="4572000" cy="329184"/>
           </a:xfrm>
           <a:prstGeom prst="roundRect">
             <a:avLst/>
@@ -4223,7 +4157,7 @@
               </a:defRPr>
             </a:pPr>
             <a:r>
-              <a:t>2.5. Stored XSS: Minh Chứng Dữ Liệu CSDL &amp; Bảo Vệ Cookie</a:t>
+              <a:t>2.5. Stored XSS: Minh Chứng Dữ Liệu CSDL dbo.Comments &amp; Cờ Bảo Vệ</a:t>
             </a:r>
           </a:p>
         </p:txBody>
@@ -4237,7 +4171,7 @@
         <p:spPr>
           <a:xfrm>
             <a:off x="731520" y="6537960"/>
-            <a:ext cx="10698480" cy="274320"/>
+            <a:ext cx="10698480" cy="256032"/>
           </a:xfrm>
           <a:prstGeom prst="rect">
             <a:avLst/>
@@ -4557,7 +4491,7 @@
         <p:spPr>
           <a:xfrm>
             <a:off x="731520" y="256032"/>
-            <a:ext cx="4389120" cy="329184"/>
+            <a:ext cx="4572000" cy="329184"/>
           </a:xfrm>
           <a:prstGeom prst="roundRect">
             <a:avLst/>
@@ -4648,7 +4582,7 @@
         <p:spPr>
           <a:xfrm>
             <a:off x="731520" y="6537960"/>
-            <a:ext cx="10698480" cy="274320"/>
+            <a:ext cx="10698480" cy="256032"/>
           </a:xfrm>
           <a:prstGeom prst="rect">
             <a:avLst/>
@@ -4880,7 +4814,7 @@
         <p:spPr>
           <a:xfrm>
             <a:off x="731520" y="256032"/>
-            <a:ext cx="4389120" cy="329184"/>
+            <a:ext cx="4572000" cy="329184"/>
           </a:xfrm>
           <a:prstGeom prst="roundRect">
             <a:avLst/>
@@ -4971,7 +4905,7 @@
         <p:spPr>
           <a:xfrm>
             <a:off x="731520" y="6537960"/>
-            <a:ext cx="10698480" cy="274320"/>
+            <a:ext cx="10698480" cy="256032"/>
           </a:xfrm>
           <a:prstGeom prst="rect">
             <a:avLst/>
@@ -5290,7 +5224,7 @@
         <p:spPr>
           <a:xfrm>
             <a:off x="731520" y="256032"/>
-            <a:ext cx="4389120" cy="329184"/>
+            <a:ext cx="4572000" cy="329184"/>
           </a:xfrm>
           <a:prstGeom prst="roundRect">
             <a:avLst/>
@@ -5381,7 +5315,7 @@
         <p:spPr>
           <a:xfrm>
             <a:off x="731520" y="6537960"/>
-            <a:ext cx="10698480" cy="274320"/>
+            <a:ext cx="10698480" cy="256032"/>
           </a:xfrm>
           <a:prstGeom prst="rect">
             <a:avLst/>
@@ -5605,7 +5539,7 @@
         <p:spPr>
           <a:xfrm>
             <a:off x="731520" y="256032"/>
-            <a:ext cx="4389120" cy="329184"/>
+            <a:ext cx="4572000" cy="329184"/>
           </a:xfrm>
           <a:prstGeom prst="roundRect">
             <a:avLst/>
@@ -5682,7 +5616,7 @@
               </a:defRPr>
             </a:pPr>
             <a:r>
-              <a:t>3.3. CSRF Attack: Minh Chứng Kiểm Thử Qua Chrome DevTools (Request Headers)</a:t>
+              <a:t>3.3. CSRF Attack: Minh Chứng Thực Nghiệm Trực Quan Trên Web UI</a:t>
             </a:r>
           </a:p>
         </p:txBody>
@@ -5696,7 +5630,7 @@
         <p:spPr>
           <a:xfrm>
             <a:off x="731520" y="6537960"/>
-            <a:ext cx="10698480" cy="274320"/>
+            <a:ext cx="10698480" cy="256032"/>
           </a:xfrm>
           <a:prstGeom prst="rect">
             <a:avLst/>
@@ -5725,7 +5659,7 @@
       </p:sp>
       <p:pic>
         <p:nvPicPr>
-          <p:cNvPr id="6" name="Picture 5" descr="03_csrf_devtools_proof.png"/>
+          <p:cNvPr id="6" name="Picture 5" descr="final_csrf_proof.png"/>
           <p:cNvPicPr>
             <a:picLocks noChangeAspect="1"/>
           </p:cNvPicPr>
@@ -5739,8 +5673,8 @@
         </p:blipFill>
         <p:spPr>
           <a:xfrm>
-            <a:off x="1883664" y="1234440"/>
-            <a:ext cx="8412480" cy="4732020"/>
+            <a:off x="2523744" y="1234440"/>
+            <a:ext cx="7132320" cy="4585063"/>
           </a:xfrm>
           <a:prstGeom prst="rect">
             <a:avLst/>
@@ -5764,7 +5698,7 @@
           <a:noFill/>
         </p:spPr>
         <p:txBody>
-          <a:bodyPr wrap="none" tIns="0" bIns="0" lIns="0" rIns="0">
+          <a:bodyPr wrap="none">
             <a:spAutoFit/>
           </a:bodyPr>
           <a:lstStyle/>
@@ -5778,7 +5712,7 @@
               </a:defRPr>
             </a:pPr>
             <a:r>
-              <a:t>Minh chứng đối chứng: Soi gói tin HTTP POST gửi ngầm từ Attacker Site: Đính kèm Cookie tự động nhưng thiếu Anti-Forgery Token của Hacker (Trái) vs Chặn đứng yêu cầu thiếu Token (Phải)</a:t>
+              <a:t>Minh chứng đối chứng ví tiền: Bị trừ 20.000.000 VNĐ qua biểu mẫu ẩn của Hacker (Trái) vs Chặn đứng yêu cầu thiếu Token (Phải)</a:t>
             </a:r>
           </a:p>
         </p:txBody>
@@ -5853,7 +5787,7 @@
         <p:spPr>
           <a:xfrm>
             <a:off x="731520" y="256032"/>
-            <a:ext cx="4389120" cy="329184"/>
+            <a:ext cx="4572000" cy="329184"/>
           </a:xfrm>
           <a:prstGeom prst="roundRect">
             <a:avLst/>
@@ -5930,7 +5864,7 @@
               </a:defRPr>
             </a:pPr>
             <a:r>
-              <a:t>3.4. CSRF Attack: Minh Chứng Biến Động CSDL dbo.UserWallets</a:t>
+              <a:t>3.4. CSRF Attack: Minh Chứng Kiểm Thử Qua Chrome DevTools (Request Headers)</a:t>
             </a:r>
           </a:p>
         </p:txBody>
@@ -5944,7 +5878,7 @@
         <p:spPr>
           <a:xfrm>
             <a:off x="731520" y="6537960"/>
-            <a:ext cx="10698480" cy="274320"/>
+            <a:ext cx="10698480" cy="256032"/>
           </a:xfrm>
           <a:prstGeom prst="rect">
             <a:avLst/>
@@ -5971,218 +5905,62 @@
           </a:p>
         </p:txBody>
       </p:sp>
-      <p:sp>
-        <p:nvSpPr>
-          <p:cNvPr id="6" name="Rounded Rectangle 5"/>
-          <p:cNvSpPr/>
-          <p:nvPr/>
-        </p:nvSpPr>
-        <p:spPr>
-          <a:xfrm>
-            <a:off x="731520" y="1234440"/>
-            <a:ext cx="5166360" cy="4937760"/>
-          </a:xfrm>
-          <a:prstGeom prst="roundRect">
-            <a:avLst/>
-          </a:prstGeom>
-          <a:solidFill>
-            <a:srgbClr val="F8FAFC"/>
-          </a:solidFill>
-          <a:ln>
-            <a:solidFill>
-              <a:srgbClr val="E2E8F0"/>
-            </a:solidFill>
-          </a:ln>
-        </p:spPr>
-        <p:style>
-          <a:lnRef idx="1">
-            <a:schemeClr val="accent1"/>
-          </a:lnRef>
-          <a:fillRef idx="3">
-            <a:schemeClr val="accent1"/>
-          </a:fillRef>
-          <a:effectRef idx="2">
-            <a:schemeClr val="accent1"/>
-          </a:effectRef>
-          <a:fontRef idx="minor">
-            <a:schemeClr val="lt1"/>
-          </a:fontRef>
-        </p:style>
-        <p:txBody>
-          <a:bodyPr rtlCol="0" anchor="ctr"/>
+      <p:pic>
+        <p:nvPicPr>
+          <p:cNvPr id="6" name="Picture 5" descr="03_csrf_devtools_proof.png"/>
+          <p:cNvPicPr>
+            <a:picLocks noChangeAspect="1"/>
+          </p:cNvPicPr>
+          <p:nvPr/>
+        </p:nvPicPr>
+        <p:blipFill>
+          <a:blip r:embed="rId2"/>
+          <a:stretch>
+            <a:fillRect/>
+          </a:stretch>
+        </p:blipFill>
+        <p:spPr>
+          <a:xfrm>
+            <a:off x="1883664" y="1234440"/>
+            <a:ext cx="8412480" cy="4732020"/>
+          </a:xfrm>
+          <a:prstGeom prst="rect">
+            <a:avLst/>
+          </a:prstGeom>
+        </p:spPr>
+      </p:pic>
+      <p:sp>
+        <p:nvSpPr>
+          <p:cNvPr id="7" name="TextBox 6"/>
+          <p:cNvSpPr txBox="1"/>
+          <p:nvPr/>
+        </p:nvSpPr>
+        <p:spPr>
+          <a:xfrm>
+            <a:off x="731520" y="6053328"/>
+            <a:ext cx="10728655" cy="365760"/>
+          </a:xfrm>
+          <a:prstGeom prst="rect">
+            <a:avLst/>
+          </a:prstGeom>
+          <a:noFill/>
+        </p:spPr>
+        <p:txBody>
+          <a:bodyPr wrap="none">
+            <a:spAutoFit/>
+          </a:bodyPr>
           <a:lstStyle/>
           <a:p>
             <a:pPr algn="ctr">
-              <a:defRPr sz="1400" b="1">
-                <a:solidFill>
-                  <a:srgbClr val="1D4ED8"/>
-                </a:solidFill>
-                <a:latin typeface="Arial"/>
-              </a:defRPr>
-            </a:pPr>
-            <a:r>
-              <a:t>1. Trạng Thái CSDL Ban Đầu</a:t>
-            </a:r>
-          </a:p>
-          <a:p>
-            <a:pPr>
-              <a:spcBef>
-                <a:spcPts val="600"/>
-              </a:spcBef>
-              <a:defRPr sz="950" b="0">
-                <a:solidFill>
-                  <a:srgbClr val="0F172A"/>
-                </a:solidFill>
-                <a:latin typeface="Courier New"/>
-              </a:defRPr>
-            </a:pPr>
-            <a:r>
-              <a:t>SELECT Id, OwnerName, Balance FROM dbo.UserWallets;</a:t>
-            </a:r>
-            <a:br/>
-            <a:br/>
-            <a:r>
-              <a:t>Id | OwnerName                      | Balance (VND)</a:t>
-            </a:r>
-            <a:br/>
-            <a:r>
-              <a:t>---+--------------------------------+---------------</a:t>
-            </a:r>
-            <a:br/>
-            <a:r>
-              <a:t> 1 | Nạn nhân (Nguyễn Danh Học)     | 50,000,000.00</a:t>
-            </a:r>
-            <a:br/>
-            <a:r>
-              <a:t> 2 | Kẻ tấn công (Hacker BlackHat)  |          0.00</a:t>
-            </a:r>
-            <a:br/>
-            <a:r>
-              <a:t>(2 rows affected)</a:t>
-            </a:r>
-          </a:p>
-          <a:p>
-            <a:pPr>
-              <a:spcBef>
-                <a:spcPts val="800"/>
-              </a:spcBef>
-              <a:defRPr sz="1150" b="0">
-                <a:solidFill>
-                  <a:srgbClr val="334155"/>
-                </a:solidFill>
-                <a:latin typeface="Arial"/>
-              </a:defRPr>
-            </a:pPr>
-            <a:r>
-              <a:t>Số dư ví tài khoản nạn nhân ở trạng thái ban đầu là 50 triệu VNĐ, tài khoản đối tượng tấn công là 0 VNĐ.</a:t>
-            </a:r>
-          </a:p>
-        </p:txBody>
-      </p:sp>
-      <p:sp>
-        <p:nvSpPr>
-          <p:cNvPr id="7" name="Rounded Rectangle 6"/>
-          <p:cNvSpPr/>
-          <p:nvPr/>
-        </p:nvSpPr>
-        <p:spPr>
-          <a:xfrm>
-            <a:off x="6263640" y="1234440"/>
-            <a:ext cx="5166360" cy="4937760"/>
-          </a:xfrm>
-          <a:prstGeom prst="roundRect">
-            <a:avLst/>
-          </a:prstGeom>
-          <a:solidFill>
-            <a:srgbClr val="FFF1F2"/>
-          </a:solidFill>
-          <a:ln>
-            <a:solidFill>
-              <a:srgbClr val="FECDD3"/>
-            </a:solidFill>
-          </a:ln>
-        </p:spPr>
-        <p:style>
-          <a:lnRef idx="1">
-            <a:schemeClr val="accent1"/>
-          </a:lnRef>
-          <a:fillRef idx="3">
-            <a:schemeClr val="accent1"/>
-          </a:fillRef>
-          <a:effectRef idx="2">
-            <a:schemeClr val="accent1"/>
-          </a:effectRef>
-          <a:fontRef idx="minor">
-            <a:schemeClr val="lt1"/>
-          </a:fontRef>
-        </p:style>
-        <p:txBody>
-          <a:bodyPr rtlCol="0" anchor="ctr"/>
-          <a:lstStyle/>
-          <a:p>
-            <a:pPr algn="ctr">
-              <a:defRPr sz="1400" b="1">
-                <a:solidFill>
-                  <a:srgbClr val="BE123C"/>
-                </a:solidFill>
-                <a:latin typeface="Arial"/>
-              </a:defRPr>
-            </a:pPr>
-            <a:r>
-              <a:t>2. Trạng Thái CSDL Sau Khai Thác CSRF</a:t>
-            </a:r>
-          </a:p>
-          <a:p>
-            <a:pPr>
-              <a:spcBef>
-                <a:spcPts val="600"/>
-              </a:spcBef>
-              <a:defRPr sz="950" b="0">
-                <a:solidFill>
-                  <a:srgbClr val="9F1239"/>
-                </a:solidFill>
-                <a:latin typeface="Courier New"/>
-              </a:defRPr>
-            </a:pPr>
-            <a:r>
-              <a:t>SELECT Id, OwnerName, Balance FROM dbo.UserWallets;</a:t>
-            </a:r>
-            <a:br/>
-            <a:br/>
-            <a:r>
-              <a:t>Id | OwnerName                      | Balance (VND)</a:t>
-            </a:r>
-            <a:br/>
-            <a:r>
-              <a:t>---+--------------------------------+---------------</a:t>
-            </a:r>
-            <a:br/>
-            <a:r>
-              <a:t> 1 | Nạn nhân (Nguyễn Danh Học)     | 30,000,000.00</a:t>
-            </a:r>
-            <a:br/>
-            <a:r>
-              <a:t> 2 | Kẻ tấn công (Hacker BlackHat)  | 20,000,000.00</a:t>
-            </a:r>
-            <a:br/>
-            <a:r>
-              <a:t>(2 rows affected)</a:t>
-            </a:r>
-          </a:p>
-          <a:p>
-            <a:pPr>
-              <a:spcBef>
-                <a:spcPts val="800"/>
-              </a:spcBef>
-              <a:defRPr sz="1150" b="0">
-                <a:solidFill>
-                  <a:srgbClr val="334155"/>
-                </a:solidFill>
-                <a:latin typeface="Arial"/>
-              </a:defRPr>
-            </a:pPr>
-            <a:r>
-              <a:t>Số dư thực tế trong CSDL bị thay đổi hoàn toàn tự động khi nạn nhân truy cập liên kết độc hại, chứng minh mức độ rủi ro nghiêm trọng của giao dịch thiếu token.</a:t>
+              <a:defRPr sz="1100" b="1">
+                <a:solidFill>
+                  <a:srgbClr val="047857"/>
+                </a:solidFill>
+                <a:latin typeface="Arial"/>
+              </a:defRPr>
+            </a:pPr>
+            <a:r>
+              <a:t>Soi gói tin HTTP POST gửi ngầm từ Attacker Site: Đính kèm Cookie tự động nhưng thiếu hoàn toàn Anti-Forgery Token</a:t>
             </a:r>
           </a:p>
         </p:txBody>
@@ -6257,7 +6035,7 @@
         <p:spPr>
           <a:xfrm>
             <a:off x="731520" y="256032"/>
-            <a:ext cx="4389120" cy="329184"/>
+            <a:ext cx="4572000" cy="329184"/>
           </a:xfrm>
           <a:prstGeom prst="roundRect">
             <a:avLst/>
@@ -6334,7 +6112,7 @@
               </a:defRPr>
             </a:pPr>
             <a:r>
-              <a:t>3.5. CSRF Attack: Cơ Chế Synchronizer Token &amp; Fetch API</a:t>
+              <a:t>3.5. CSRF Attack: Minh Chứng Biến Động CSDL dbo.UserWallets</a:t>
             </a:r>
           </a:p>
         </p:txBody>
@@ -6348,7 +6126,7 @@
         <p:spPr>
           <a:xfrm>
             <a:off x="731520" y="6537960"/>
-            <a:ext cx="10698480" cy="274320"/>
+            <a:ext cx="10698480" cy="256032"/>
           </a:xfrm>
           <a:prstGeom prst="rect">
             <a:avLst/>
@@ -6384,146 +6162,6 @@
         <p:spPr>
           <a:xfrm>
             <a:off x="731520" y="1234440"/>
-            <a:ext cx="5166360" cy="4937760"/>
-          </a:xfrm>
-          <a:prstGeom prst="roundRect">
-            <a:avLst/>
-          </a:prstGeom>
-          <a:solidFill>
-            <a:srgbClr val="ECFDF5"/>
-          </a:solidFill>
-          <a:ln>
-            <a:solidFill>
-              <a:srgbClr val="A7F3D0"/>
-            </a:solidFill>
-          </a:ln>
-        </p:spPr>
-        <p:style>
-          <a:lnRef idx="1">
-            <a:schemeClr val="accent1"/>
-          </a:lnRef>
-          <a:fillRef idx="3">
-            <a:schemeClr val="accent1"/>
-          </a:fillRef>
-          <a:effectRef idx="2">
-            <a:schemeClr val="accent1"/>
-          </a:effectRef>
-          <a:fontRef idx="minor">
-            <a:schemeClr val="lt1"/>
-          </a:fontRef>
-        </p:style>
-        <p:txBody>
-          <a:bodyPr rtlCol="0" anchor="ctr"/>
-          <a:lstStyle/>
-          <a:p>
-            <a:pPr algn="ctr">
-              <a:defRPr sz="1500" b="1">
-                <a:solidFill>
-                  <a:srgbClr val="047857"/>
-                </a:solidFill>
-                <a:latin typeface="Arial"/>
-              </a:defRPr>
-            </a:pPr>
-            <a:r>
-              <a:t>Mô Hình Synchronizer Token Pattern</a:t>
-            </a:r>
-          </a:p>
-          <a:p>
-            <a:pPr>
-              <a:spcBef>
-                <a:spcPts val="800"/>
-              </a:spcBef>
-              <a:defRPr sz="950" b="0">
-                <a:solidFill>
-                  <a:srgbClr val="065F46"/>
-                </a:solidFill>
-                <a:latin typeface="Courier New"/>
-              </a:defRPr>
-            </a:pPr>
-            <a:r>
-              <a:t>// 1. TRONG RAZOR VIEW: NHÚNG TOKEN VÀO FORM</a:t>
-            </a:r>
-            <a:br/>
-            <a:r>
-              <a:t>&lt;form asp-action="TransferSecure" method="post"&gt;</a:t>
-            </a:r>
-            <a:br/>
-            <a:r>
-              <a:t>    @Html.AntiForgeryToken()</a:t>
-            </a:r>
-            <a:br/>
-            <a:r>
-              <a:t>    &lt;input type="number" name="amount" /&gt;</a:t>
-            </a:r>
-            <a:br/>
-            <a:r>
-              <a:t>    &lt;button type="submit"&gt;Chuyển tiền&lt;/button&gt;</a:t>
-            </a:r>
-            <a:br/>
-            <a:r>
-              <a:t>&lt;/form&gt;</a:t>
-            </a:r>
-            <a:br/>
-            <a:br/>
-            <a:r>
-              <a:t>// 2. TRONG CONTROLLER: BẮT BUỘC KIỂM TRA TOKEN</a:t>
-            </a:r>
-            <a:br/>
-            <a:r>
-              <a:t>[HttpPost]</a:t>
-            </a:r>
-            <a:br/>
-            <a:r>
-              <a:t>[ValidateAntiForgeryToken]</a:t>
-            </a:r>
-            <a:br/>
-            <a:r>
-              <a:t>public IActionResult TransferSecure(decimal amount)</a:t>
-            </a:r>
-            <a:br/>
-            <a:r>
-              <a:t>{</a:t>
-            </a:r>
-            <a:br/>
-            <a:r>
-              <a:t>    // Chỉ thực thi khi Token từ Form khớp với Token trong Cookie</a:t>
-            </a:r>
-            <a:br/>
-            <a:r>
-              <a:t>}</a:t>
-            </a:r>
-          </a:p>
-          <a:p>
-            <a:pPr>
-              <a:spcBef>
-                <a:spcPts val="800"/>
-              </a:spcBef>
-              <a:defRPr sz="1150" b="0">
-                <a:solidFill>
-                  <a:srgbClr val="334155"/>
-                </a:solidFill>
-                <a:latin typeface="Arial"/>
-              </a:defRPr>
-            </a:pPr>
-            <a:r>
-              <a:t>Cơ chế bảo vệ:</a:t>
-            </a:r>
-            <a:br/>
-            <a:r>
-              <a:t>Máy chủ phát hành một cặp token: một lưu trong Cookie và một nhúng vào biểu mẫu. Trang web độc hại bị chặn đọc token bởi chính sách Same-Origin Policy (SOP).</a:t>
-            </a:r>
-          </a:p>
-        </p:txBody>
-      </p:sp>
-      <p:sp>
-        <p:nvSpPr>
-          <p:cNvPr id="7" name="Rounded Rectangle 6"/>
-          <p:cNvSpPr/>
-          <p:nvPr/>
-        </p:nvSpPr>
-        <p:spPr>
-          <a:xfrm>
-            <a:off x="6263640" y="1234440"/>
             <a:ext cx="5166360" cy="4937760"/>
           </a:xfrm>
           <a:prstGeom prst="roundRect">
@@ -6557,7 +6195,7 @@
           <a:lstStyle/>
           <a:p>
             <a:pPr algn="ctr">
-              <a:defRPr sz="1500" b="1">
+              <a:defRPr sz="1400" b="1">
                 <a:solidFill>
                   <a:srgbClr val="1D4ED8"/>
                 </a:solidFill>
@@ -6565,13 +6203,13 @@
               </a:defRPr>
             </a:pPr>
             <a:r>
-              <a:t>Tích Hợp Token Trong Fetch API (Slide Buổi 9)</a:t>
+              <a:t>1. Trạng Thái CSDL Ban Đầu</a:t>
             </a:r>
           </a:p>
           <a:p>
             <a:pPr>
               <a:spcBef>
-                <a:spcPts val="800"/>
+                <a:spcPts val="600"/>
               </a:spcBef>
               <a:defRPr sz="950" b="0">
                 <a:solidFill>
@@ -6581,48 +6219,28 @@
               </a:defRPr>
             </a:pPr>
             <a:r>
-              <a:t>// TRÍCH XUẤT VÀ GỬI TOKEN QUA HTTP HEADER:</a:t>
-            </a:r>
-            <a:br/>
-            <a:r>
-              <a:t>const token = document.querySelector('input[name="__RequestVerificationToken"]').value;</a:t>
-            </a:r>
-            <a:br/>
-            <a:br/>
-            <a:r>
-              <a:t>fetch('/Csrf/TransferAjax', {</a:t>
-            </a:r>
-            <a:br/>
-            <a:r>
-              <a:t>    method: 'POST',</a:t>
-            </a:r>
-            <a:br/>
-            <a:r>
-              <a:t>    headers: {</a:t>
-            </a:r>
-            <a:br/>
-            <a:r>
-              <a:t>        'Content-Type': 'application/json',</a:t>
-            </a:r>
-            <a:br/>
-            <a:r>
-              <a:t>        'RequestVerificationToken': token // HEADER BẢO VỆ</a:t>
-            </a:r>
-            <a:br/>
-            <a:r>
-              <a:t>    },</a:t>
-            </a:r>
-            <a:br/>
-            <a:r>
-              <a:t>    body: JSON.stringify({ amount: 5000000 })</a:t>
-            </a:r>
-            <a:br/>
-            <a:r>
-              <a:t>})</a:t>
-            </a:r>
-            <a:br/>
-            <a:r>
-              <a:t>.then(response =&gt; response.json());</a:t>
+              <a:t>SELECT Id, OwnerName, Balance FROM dbo.UserWallets;</a:t>
+            </a:r>
+            <a:br/>
+            <a:br/>
+            <a:r>
+              <a:t>Id | OwnerName                      | Balance (VND)</a:t>
+            </a:r>
+            <a:br/>
+            <a:r>
+              <a:t>---+--------------------------------+---------------</a:t>
+            </a:r>
+            <a:br/>
+            <a:r>
+              <a:t> 1 | Nạn nhân (Nguyễn Danh Học)     | 50,000,000.00</a:t>
+            </a:r>
+            <a:br/>
+            <a:r>
+              <a:t> 2 | Kẻ tấn công (Hacker BlackHat)  |          0.00</a:t>
+            </a:r>
+            <a:br/>
+            <a:r>
+              <a:t>(2 rows affected)</a:t>
             </a:r>
           </a:p>
           <a:p>
@@ -6638,11 +6256,115 @@
               </a:defRPr>
             </a:pPr>
             <a:r>
-              <a:t>Ứng dụng trong thực tế:</a:t>
-            </a:r>
-            <a:br/>
-            <a:r>
-              <a:t>Đối với các tác vụ gọi AJAX không tải lại trang, token được đọc từ thẻ ẩn và truyền qua HTTP Header để đảm bảo vừa tiện dụng vừa an toàn.</a:t>
+              <a:t>Số dư ví tài khoản nạn nhân ở trạng thái ban đầu là 50 triệu VNĐ, tài khoản đối tượng tấn công là 0 VNĐ.</a:t>
+            </a:r>
+          </a:p>
+        </p:txBody>
+      </p:sp>
+      <p:sp>
+        <p:nvSpPr>
+          <p:cNvPr id="7" name="Rounded Rectangle 6"/>
+          <p:cNvSpPr/>
+          <p:nvPr/>
+        </p:nvSpPr>
+        <p:spPr>
+          <a:xfrm>
+            <a:off x="6263640" y="1234440"/>
+            <a:ext cx="5166360" cy="4937760"/>
+          </a:xfrm>
+          <a:prstGeom prst="roundRect">
+            <a:avLst/>
+          </a:prstGeom>
+          <a:solidFill>
+            <a:srgbClr val="FFF1F2"/>
+          </a:solidFill>
+          <a:ln>
+            <a:solidFill>
+              <a:srgbClr val="FECDD3"/>
+            </a:solidFill>
+          </a:ln>
+        </p:spPr>
+        <p:style>
+          <a:lnRef idx="1">
+            <a:schemeClr val="accent1"/>
+          </a:lnRef>
+          <a:fillRef idx="3">
+            <a:schemeClr val="accent1"/>
+          </a:fillRef>
+          <a:effectRef idx="2">
+            <a:schemeClr val="accent1"/>
+          </a:effectRef>
+          <a:fontRef idx="minor">
+            <a:schemeClr val="lt1"/>
+          </a:fontRef>
+        </p:style>
+        <p:txBody>
+          <a:bodyPr rtlCol="0" anchor="ctr"/>
+          <a:lstStyle/>
+          <a:p>
+            <a:pPr algn="ctr">
+              <a:defRPr sz="1400" b="1">
+                <a:solidFill>
+                  <a:srgbClr val="BE123C"/>
+                </a:solidFill>
+                <a:latin typeface="Arial"/>
+              </a:defRPr>
+            </a:pPr>
+            <a:r>
+              <a:t>2. Trạng Thái CSDL Sau Khai Thác CSRF</a:t>
+            </a:r>
+          </a:p>
+          <a:p>
+            <a:pPr>
+              <a:spcBef>
+                <a:spcPts val="600"/>
+              </a:spcBef>
+              <a:defRPr sz="950" b="0">
+                <a:solidFill>
+                  <a:srgbClr val="9F1239"/>
+                </a:solidFill>
+                <a:latin typeface="Courier New"/>
+              </a:defRPr>
+            </a:pPr>
+            <a:r>
+              <a:t>SELECT Id, OwnerName, Balance FROM dbo.UserWallets;</a:t>
+            </a:r>
+            <a:br/>
+            <a:br/>
+            <a:r>
+              <a:t>Id | OwnerName                      | Balance (VND)</a:t>
+            </a:r>
+            <a:br/>
+            <a:r>
+              <a:t>---+--------------------------------+---------------</a:t>
+            </a:r>
+            <a:br/>
+            <a:r>
+              <a:t> 1 | Nạn nhân (Nguyễn Danh Học)     | 30,000,000.00</a:t>
+            </a:r>
+            <a:br/>
+            <a:r>
+              <a:t> 2 | Kẻ tấn công (Hacker BlackHat)  | 20,000,000.00</a:t>
+            </a:r>
+            <a:br/>
+            <a:r>
+              <a:t>(2 rows affected)</a:t>
+            </a:r>
+          </a:p>
+          <a:p>
+            <a:pPr>
+              <a:spcBef>
+                <a:spcPts val="800"/>
+              </a:spcBef>
+              <a:defRPr sz="1150" b="0">
+                <a:solidFill>
+                  <a:srgbClr val="334155"/>
+                </a:solidFill>
+                <a:latin typeface="Arial"/>
+              </a:defRPr>
+            </a:pPr>
+            <a:r>
+              <a:t>Số dư thực tế trong CSDL bị thay đổi hoàn toàn tự động khi nạn nhân truy cập liên kết độc hại, chứng minh mức độ rủi ro nghiêm trọng của giao dịch thiếu token.</a:t>
             </a:r>
           </a:p>
         </p:txBody>
@@ -6717,7 +6439,7 @@
         <p:spPr>
           <a:xfrm>
             <a:off x="731520" y="256032"/>
-            <a:ext cx="4389120" cy="329184"/>
+            <a:ext cx="4572000" cy="329184"/>
           </a:xfrm>
           <a:prstGeom prst="roundRect">
             <a:avLst/>
@@ -6758,7 +6480,7 @@
               </a:defRPr>
             </a:pPr>
             <a:r>
-              <a:t>OWASP TOP 10 • THỰC NGHIỆM AN TOÀN WEB</a:t>
+              <a:t>CHỦ ĐỀ 3 • NGUYỄN MINH CƯỜNG (23A1001D0058)</a:t>
             </a:r>
           </a:p>
         </p:txBody>
@@ -6794,7 +6516,7 @@
               </a:defRPr>
             </a:pPr>
             <a:r>
-              <a:t>Kết Luận Báo Cáo Thực Nghiệm OWASP Top 10</a:t>
+              <a:t>3.6. CSRF Attack: Cơ Chế Synchronizer Token &amp; Fetch API</a:t>
             </a:r>
           </a:p>
         </p:txBody>
@@ -6808,7 +6530,7 @@
         <p:spPr>
           <a:xfrm>
             <a:off x="731520" y="6537960"/>
-            <a:ext cx="10698480" cy="274320"/>
+            <a:ext cx="10698480" cy="256032"/>
           </a:xfrm>
           <a:prstGeom prst="rect">
             <a:avLst/>
@@ -6843,8 +6565,148 @@
         </p:nvSpPr>
         <p:spPr>
           <a:xfrm>
-            <a:off x="914400" y="1371600"/>
-            <a:ext cx="10362895" cy="4572000"/>
+            <a:off x="731520" y="1234440"/>
+            <a:ext cx="5166360" cy="4937760"/>
+          </a:xfrm>
+          <a:prstGeom prst="roundRect">
+            <a:avLst/>
+          </a:prstGeom>
+          <a:solidFill>
+            <a:srgbClr val="ECFDF5"/>
+          </a:solidFill>
+          <a:ln>
+            <a:solidFill>
+              <a:srgbClr val="A7F3D0"/>
+            </a:solidFill>
+          </a:ln>
+        </p:spPr>
+        <p:style>
+          <a:lnRef idx="1">
+            <a:schemeClr val="accent1"/>
+          </a:lnRef>
+          <a:fillRef idx="3">
+            <a:schemeClr val="accent1"/>
+          </a:fillRef>
+          <a:effectRef idx="2">
+            <a:schemeClr val="accent1"/>
+          </a:effectRef>
+          <a:fontRef idx="minor">
+            <a:schemeClr val="lt1"/>
+          </a:fontRef>
+        </p:style>
+        <p:txBody>
+          <a:bodyPr rtlCol="0" anchor="ctr"/>
+          <a:lstStyle/>
+          <a:p>
+            <a:pPr algn="ctr">
+              <a:defRPr sz="1500" b="1">
+                <a:solidFill>
+                  <a:srgbClr val="047857"/>
+                </a:solidFill>
+                <a:latin typeface="Arial"/>
+              </a:defRPr>
+            </a:pPr>
+            <a:r>
+              <a:t>Mô Hình Synchronizer Token Pattern</a:t>
+            </a:r>
+          </a:p>
+          <a:p>
+            <a:pPr>
+              <a:spcBef>
+                <a:spcPts val="800"/>
+              </a:spcBef>
+              <a:defRPr sz="950" b="0">
+                <a:solidFill>
+                  <a:srgbClr val="065F46"/>
+                </a:solidFill>
+                <a:latin typeface="Courier New"/>
+              </a:defRPr>
+            </a:pPr>
+            <a:r>
+              <a:t>// 1. TRONG RAZOR VIEW: NHÚNG TOKEN VÀO FORM</a:t>
+            </a:r>
+            <a:br/>
+            <a:r>
+              <a:t>&lt;form asp-action="TransferSecure" method="post"&gt;</a:t>
+            </a:r>
+            <a:br/>
+            <a:r>
+              <a:t>    @Html.AntiForgeryToken()</a:t>
+            </a:r>
+            <a:br/>
+            <a:r>
+              <a:t>    &lt;input type="number" name="amount" /&gt;</a:t>
+            </a:r>
+            <a:br/>
+            <a:r>
+              <a:t>    &lt;button type="submit"&gt;Chuyển tiền&lt;/button&gt;</a:t>
+            </a:r>
+            <a:br/>
+            <a:r>
+              <a:t>&lt;/form&gt;</a:t>
+            </a:r>
+            <a:br/>
+            <a:br/>
+            <a:r>
+              <a:t>// 2. TRONG CONTROLLER: BẮT BUỘC KIỂM TRA TOKEN</a:t>
+            </a:r>
+            <a:br/>
+            <a:r>
+              <a:t>[HttpPost]</a:t>
+            </a:r>
+            <a:br/>
+            <a:r>
+              <a:t>[ValidateAntiForgeryToken]</a:t>
+            </a:r>
+            <a:br/>
+            <a:r>
+              <a:t>public IActionResult TransferSecure(decimal amount)</a:t>
+            </a:r>
+            <a:br/>
+            <a:r>
+              <a:t>{</a:t>
+            </a:r>
+            <a:br/>
+            <a:r>
+              <a:t>    // Chỉ thực thi khi Token từ Form khớp với Token trong Cookie</a:t>
+            </a:r>
+            <a:br/>
+            <a:r>
+              <a:t>}</a:t>
+            </a:r>
+          </a:p>
+          <a:p>
+            <a:pPr>
+              <a:spcBef>
+                <a:spcPts val="800"/>
+              </a:spcBef>
+              <a:defRPr sz="1150" b="0">
+                <a:solidFill>
+                  <a:srgbClr val="334155"/>
+                </a:solidFill>
+                <a:latin typeface="Arial"/>
+              </a:defRPr>
+            </a:pPr>
+            <a:r>
+              <a:t>Cơ chế bảo vệ:</a:t>
+            </a:r>
+            <a:br/>
+            <a:r>
+              <a:t>Máy chủ phát hành một cặp token: một lưu trong Cookie và một nhúng vào biểu mẫu. Trang web độc hại bị chặn đọc token bởi chính sách Same-Origin Policy (SOP).</a:t>
+            </a:r>
+          </a:p>
+        </p:txBody>
+      </p:sp>
+      <p:sp>
+        <p:nvSpPr>
+          <p:cNvPr id="7" name="Rounded Rectangle 6"/>
+          <p:cNvSpPr/>
+          <p:nvPr/>
+        </p:nvSpPr>
+        <p:spPr>
+          <a:xfrm>
+            <a:off x="6263640" y="1234440"/>
+            <a:ext cx="5166360" cy="4937760"/>
           </a:xfrm>
           <a:prstGeom prst="roundRect">
             <a:avLst/>
@@ -6877,7 +6739,7 @@
           <a:lstStyle/>
           <a:p>
             <a:pPr algn="ctr">
-              <a:defRPr sz="1600" b="1">
+              <a:defRPr sz="1500" b="1">
                 <a:solidFill>
                   <a:srgbClr val="1D4ED8"/>
                 </a:solidFill>
@@ -6885,31 +6747,72 @@
               </a:defRPr>
             </a:pPr>
             <a:r>
-              <a:t>TỔNG KẾT KẾT QUẢ THỰC NGHIỆM CỦA NHÓM WNC.G01</a:t>
+              <a:t>Tích Hợp Token Trong Fetch API (Slide Buổi 9)</a:t>
             </a:r>
           </a:p>
           <a:p>
             <a:pPr>
               <a:spcBef>
-                <a:spcPts val="1400"/>
+                <a:spcPts val="800"/>
               </a:spcBef>
-              <a:defRPr sz="1300" b="0">
-                <a:solidFill>
-                  <a:srgbClr val="334155"/>
-                </a:solidFill>
-                <a:latin typeface="Arial"/>
-              </a:defRPr>
-            </a:pPr>
-            <a:r>
-              <a:t>1. Nguyễn Danh Học (SQL Injection): Phân tích cơ chế tấn công bẻ gãy cú pháp CSDL ở tầng Backend và giải pháp phòng thủ triệt để bằng Parameterized Query / EF Core LINQ.</a:t>
+              <a:defRPr sz="950" b="0">
+                <a:solidFill>
+                  <a:srgbClr val="0F172A"/>
+                </a:solidFill>
+                <a:latin typeface="Courier New"/>
+              </a:defRPr>
+            </a:pPr>
+            <a:r>
+              <a:t>// TRÍCH XUẤT VÀ GỬI TOKEN QUA HTTP HEADER:</a:t>
+            </a:r>
+            <a:br/>
+            <a:r>
+              <a:t>const token = document.querySelector('input[name="__RequestVerificationToken"]').value;</a:t>
+            </a:r>
+            <a:br/>
+            <a:br/>
+            <a:r>
+              <a:t>fetch('/Csrf/TransferAjax', {</a:t>
+            </a:r>
+            <a:br/>
+            <a:r>
+              <a:t>    method: 'POST',</a:t>
+            </a:r>
+            <a:br/>
+            <a:r>
+              <a:t>    headers: {</a:t>
+            </a:r>
+            <a:br/>
+            <a:r>
+              <a:t>        'Content-Type': 'application/json',</a:t>
+            </a:r>
+            <a:br/>
+            <a:r>
+              <a:t>        'RequestVerificationToken': token // HEADER BẢO VỆ</a:t>
+            </a:r>
+            <a:br/>
+            <a:r>
+              <a:t>    },</a:t>
+            </a:r>
+            <a:br/>
+            <a:r>
+              <a:t>    body: JSON.stringify({ amount: 5000000 })</a:t>
+            </a:r>
+            <a:br/>
+            <a:r>
+              <a:t>})</a:t>
+            </a:r>
+            <a:br/>
+            <a:r>
+              <a:t>.then(response =&gt; response.json());</a:t>
             </a:r>
           </a:p>
           <a:p>
             <a:pPr>
               <a:spcBef>
-                <a:spcPts val="1200"/>
+                <a:spcPts val="800"/>
               </a:spcBef>
-              <a:defRPr sz="1300" b="0">
+              <a:defRPr sz="1150" b="0">
                 <a:solidFill>
                   <a:srgbClr val="334155"/>
                 </a:solidFill>
@@ -6917,39 +6820,11 @@
               </a:defRPr>
             </a:pPr>
             <a:r>
-              <a:t>2. Nguyễn Thanh Bình (Stored XSS): Phân tích nguy cơ đánh cắp Session Cookie qua dữ liệu lưu trữ CSDL và giải pháp tự động HTML Encoding của Razor View kết hợp cờ HttpOnly.</a:t>
-            </a:r>
-          </a:p>
-          <a:p>
-            <a:pPr>
-              <a:spcBef>
-                <a:spcPts val="1200"/>
-              </a:spcBef>
-              <a:defRPr sz="1300" b="0">
-                <a:solidFill>
-                  <a:srgbClr val="334155"/>
-                </a:solidFill>
-                <a:latin typeface="Arial"/>
-              </a:defRPr>
-            </a:pPr>
-            <a:r>
-              <a:t>3. Nguyễn Minh Cường (CSRF Attack): Phân tích kỹ thuật mượn quyền người dùng qua biểu mẫu ẩn và giải pháp phòng thủ bằng Synchronizer Token Pattern trên cả Form lẫn Fetch API.</a:t>
-            </a:r>
-          </a:p>
-          <a:p>
-            <a:pPr>
-              <a:spcBef>
-                <a:spcPts val="2400"/>
-              </a:spcBef>
-              <a:defRPr sz="1500" b="1">
-                <a:solidFill>
-                  <a:srgbClr val="BE123C"/>
-                </a:solidFill>
-                <a:latin typeface="Arial"/>
-              </a:defRPr>
-            </a:pPr>
-            <a:r>
-              <a:t>Kính chúc thầy sức khỏe và công tác tốt. Nhóm WNC.G01 xin trân trọng cảm ơn!</a:t>
+              <a:t>Ứng dụng trong thực tế:</a:t>
+            </a:r>
+            <a:br/>
+            <a:r>
+              <a:t>Đối với các tác vụ gọi AJAX không tải lại trang, token được đọc từ thẻ ẩn và truyền qua HTTP Header để đảm bảo vừa tiện dụng vừa an toàn.</a:t>
             </a:r>
           </a:p>
         </p:txBody>
@@ -7024,7 +6899,7 @@
         <p:spPr>
           <a:xfrm>
             <a:off x="731520" y="256032"/>
-            <a:ext cx="4389120" cy="329184"/>
+            <a:ext cx="4572000" cy="329184"/>
           </a:xfrm>
           <a:prstGeom prst="roundRect">
             <a:avLst/>
@@ -7115,7 +6990,7 @@
         <p:spPr>
           <a:xfrm>
             <a:off x="731520" y="6537960"/>
-            <a:ext cx="10698480" cy="274320"/>
+            <a:ext cx="10698480" cy="256032"/>
           </a:xfrm>
           <a:prstGeom prst="rect">
             <a:avLst/>
@@ -7373,6 +7248,313 @@
             <a:br/>
             <a:r>
               <a:t>Lập trình viên giả định đầu vào '{username}' luôn là văn bản thông thường. Khi kẻ tấn công chèn ký tự nháy đơn ('), ranh giới giữa Dữ liệu (Data) và Cú pháp lệnh (Code) bị xóa nhòa hoàn toàn.</a:t>
+            </a:r>
+          </a:p>
+        </p:txBody>
+      </p:sp>
+    </p:spTree>
+  </p:cSld>
+  <p:clrMapOvr>
+    <a:masterClrMapping/>
+  </p:clrMapOvr>
+</p:sld>
+</file>
+
+<file path=ppt/slides/slide20.xml><?xml version="1.0" encoding="utf-8"?>
+<p:sld xmlns:a="http://schemas.openxmlformats.org/drawingml/2006/main" xmlns:p="http://schemas.openxmlformats.org/presentationml/2006/main" xmlns:r="http://schemas.openxmlformats.org/officeDocument/2006/relationships">
+  <p:cSld>
+    <p:spTree>
+      <p:nvGrpSpPr>
+        <p:cNvPr id="1" name=""/>
+        <p:cNvGrpSpPr/>
+        <p:nvPr/>
+      </p:nvGrpSpPr>
+      <p:grpSpPr/>
+      <p:sp>
+        <p:nvSpPr>
+          <p:cNvPr id="2" name="Rectangle 1"/>
+          <p:cNvSpPr/>
+          <p:nvPr/>
+        </p:nvSpPr>
+        <p:spPr>
+          <a:xfrm>
+            <a:off x="0" y="0"/>
+            <a:ext cx="12191695" cy="73152"/>
+          </a:xfrm>
+          <a:prstGeom prst="rect">
+            <a:avLst/>
+          </a:prstGeom>
+          <a:solidFill>
+            <a:srgbClr val="1D4ED8"/>
+          </a:solidFill>
+          <a:ln>
+            <a:noFill/>
+          </a:ln>
+        </p:spPr>
+        <p:style>
+          <a:lnRef idx="1">
+            <a:schemeClr val="accent1"/>
+          </a:lnRef>
+          <a:fillRef idx="3">
+            <a:schemeClr val="accent1"/>
+          </a:fillRef>
+          <a:effectRef idx="2">
+            <a:schemeClr val="accent1"/>
+          </a:effectRef>
+          <a:fontRef idx="minor">
+            <a:schemeClr val="lt1"/>
+          </a:fontRef>
+        </p:style>
+        <p:txBody>
+          <a:bodyPr rtlCol="0" anchor="ctr"/>
+          <a:lstStyle/>
+          <a:p>
+            <a:pPr algn="ctr"/>
+          </a:p>
+        </p:txBody>
+      </p:sp>
+      <p:sp>
+        <p:nvSpPr>
+          <p:cNvPr id="3" name="Rounded Rectangle 2"/>
+          <p:cNvSpPr/>
+          <p:nvPr/>
+        </p:nvSpPr>
+        <p:spPr>
+          <a:xfrm>
+            <a:off x="731520" y="256032"/>
+            <a:ext cx="4572000" cy="329184"/>
+          </a:xfrm>
+          <a:prstGeom prst="roundRect">
+            <a:avLst/>
+          </a:prstGeom>
+          <a:solidFill>
+            <a:srgbClr val="EFF6FF"/>
+          </a:solidFill>
+          <a:ln>
+            <a:solidFill>
+              <a:srgbClr val="BFDBFE"/>
+            </a:solidFill>
+          </a:ln>
+        </p:spPr>
+        <p:style>
+          <a:lnRef idx="1">
+            <a:schemeClr val="accent1"/>
+          </a:lnRef>
+          <a:fillRef idx="3">
+            <a:schemeClr val="accent1"/>
+          </a:fillRef>
+          <a:effectRef idx="2">
+            <a:schemeClr val="accent1"/>
+          </a:effectRef>
+          <a:fontRef idx="minor">
+            <a:schemeClr val="lt1"/>
+          </a:fontRef>
+        </p:style>
+        <p:txBody>
+          <a:bodyPr rtlCol="0" anchor="ctr" wrap="none"/>
+          <a:lstStyle/>
+          <a:p>
+            <a:pPr algn="ctr">
+              <a:defRPr sz="1000" b="1">
+                <a:solidFill>
+                  <a:srgbClr val="1D4ED8"/>
+                </a:solidFill>
+                <a:latin typeface="Arial"/>
+              </a:defRPr>
+            </a:pPr>
+            <a:r>
+              <a:t>OWASP TOP 10 • THỰC NGHIỆM AN TOÀN WEB</a:t>
+            </a:r>
+          </a:p>
+        </p:txBody>
+      </p:sp>
+      <p:sp>
+        <p:nvSpPr>
+          <p:cNvPr id="4" name="TextBox 3"/>
+          <p:cNvSpPr txBox="1"/>
+          <p:nvPr/>
+        </p:nvSpPr>
+        <p:spPr>
+          <a:xfrm>
+            <a:off x="731520" y="621792"/>
+            <a:ext cx="10698480" cy="548640"/>
+          </a:xfrm>
+          <a:prstGeom prst="rect">
+            <a:avLst/>
+          </a:prstGeom>
+          <a:noFill/>
+        </p:spPr>
+        <p:txBody>
+          <a:bodyPr wrap="square">
+            <a:spAutoFit/>
+          </a:bodyPr>
+          <a:lstStyle/>
+          <a:p>
+            <a:pPr>
+              <a:defRPr sz="2000" b="1">
+                <a:solidFill>
+                  <a:srgbClr val="0F172A"/>
+                </a:solidFill>
+                <a:latin typeface="Arial"/>
+              </a:defRPr>
+            </a:pPr>
+            <a:r>
+              <a:t>Kết Luận Báo Cáo Thực Nghiệm OWASP Top 10</a:t>
+            </a:r>
+          </a:p>
+        </p:txBody>
+      </p:sp>
+      <p:sp>
+        <p:nvSpPr>
+          <p:cNvPr id="5" name="TextBox 4"/>
+          <p:cNvSpPr txBox="1"/>
+          <p:nvPr/>
+        </p:nvSpPr>
+        <p:spPr>
+          <a:xfrm>
+            <a:off x="731520" y="6537960"/>
+            <a:ext cx="10698480" cy="256032"/>
+          </a:xfrm>
+          <a:prstGeom prst="rect">
+            <a:avLst/>
+          </a:prstGeom>
+          <a:noFill/>
+        </p:spPr>
+        <p:txBody>
+          <a:bodyPr wrap="none" lIns="0" rIns="0" tIns="0" bIns="0">
+            <a:spAutoFit/>
+          </a:bodyPr>
+          <a:lstStyle/>
+          <a:p>
+            <a:pPr>
+              <a:defRPr sz="950">
+                <a:solidFill>
+                  <a:srgbClr val="64748B"/>
+                </a:solidFill>
+                <a:latin typeface="Arial"/>
+              </a:defRPr>
+            </a:pPr>
+            <a:r>
+              <a:t>Nhóm WNC.G01 • Trường Đại học Mở Hà Nội (HOU) • Giảng viên: ThS. Lê Hữu Dũng</a:t>
+            </a:r>
+          </a:p>
+        </p:txBody>
+      </p:sp>
+      <p:sp>
+        <p:nvSpPr>
+          <p:cNvPr id="6" name="Rounded Rectangle 5"/>
+          <p:cNvSpPr/>
+          <p:nvPr/>
+        </p:nvSpPr>
+        <p:spPr>
+          <a:xfrm>
+            <a:off x="914400" y="1371600"/>
+            <a:ext cx="10362895" cy="4572000"/>
+          </a:xfrm>
+          <a:prstGeom prst="roundRect">
+            <a:avLst/>
+          </a:prstGeom>
+          <a:solidFill>
+            <a:srgbClr val="F8FAFC"/>
+          </a:solidFill>
+          <a:ln>
+            <a:solidFill>
+              <a:srgbClr val="E2E8F0"/>
+            </a:solidFill>
+          </a:ln>
+        </p:spPr>
+        <p:style>
+          <a:lnRef idx="1">
+            <a:schemeClr val="accent1"/>
+          </a:lnRef>
+          <a:fillRef idx="3">
+            <a:schemeClr val="accent1"/>
+          </a:fillRef>
+          <a:effectRef idx="2">
+            <a:schemeClr val="accent1"/>
+          </a:effectRef>
+          <a:fontRef idx="minor">
+            <a:schemeClr val="lt1"/>
+          </a:fontRef>
+        </p:style>
+        <p:txBody>
+          <a:bodyPr rtlCol="0" anchor="ctr"/>
+          <a:lstStyle/>
+          <a:p>
+            <a:pPr algn="ctr">
+              <a:defRPr sz="1600" b="1">
+                <a:solidFill>
+                  <a:srgbClr val="1D4ED8"/>
+                </a:solidFill>
+                <a:latin typeface="Arial"/>
+              </a:defRPr>
+            </a:pPr>
+            <a:r>
+              <a:t>TỔNG KẾT KẾT QUẢ THỰC NGHIỆM CỦA NHÓM WNC.G01</a:t>
+            </a:r>
+          </a:p>
+          <a:p>
+            <a:pPr>
+              <a:spcBef>
+                <a:spcPts val="1400"/>
+              </a:spcBef>
+              <a:defRPr sz="1300" b="0">
+                <a:solidFill>
+                  <a:srgbClr val="334155"/>
+                </a:solidFill>
+                <a:latin typeface="Arial"/>
+              </a:defRPr>
+            </a:pPr>
+            <a:r>
+              <a:t>1. Nguyễn Danh Học (SQL Injection): Phân tích cơ chế tấn công bẻ gãy cú pháp CSDL ở tầng Backend và giải pháp phòng thủ triệt để bằng Parameterized Query / EF Core LINQ.</a:t>
+            </a:r>
+          </a:p>
+          <a:p>
+            <a:pPr>
+              <a:spcBef>
+                <a:spcPts val="1200"/>
+              </a:spcBef>
+              <a:defRPr sz="1300" b="0">
+                <a:solidFill>
+                  <a:srgbClr val="334155"/>
+                </a:solidFill>
+                <a:latin typeface="Arial"/>
+              </a:defRPr>
+            </a:pPr>
+            <a:r>
+              <a:t>2. Nguyễn Thanh Bình (Stored XSS): Phân tích nguy cơ đánh cắp Session Cookie qua dữ liệu lưu trữ CSDL và giải pháp tự động HTML Encoding của Razor View kết hợp cờ HttpOnly.</a:t>
+            </a:r>
+          </a:p>
+          <a:p>
+            <a:pPr>
+              <a:spcBef>
+                <a:spcPts val="1200"/>
+              </a:spcBef>
+              <a:defRPr sz="1300" b="0">
+                <a:solidFill>
+                  <a:srgbClr val="334155"/>
+                </a:solidFill>
+                <a:latin typeface="Arial"/>
+              </a:defRPr>
+            </a:pPr>
+            <a:r>
+              <a:t>3. Nguyễn Minh Cường (CSRF Attack): Phân tích kỹ thuật mượn quyền người dùng qua biểu mẫu ẩn và giải pháp phòng thủ bằng Synchronizer Token Pattern trên cả Form lẫn Fetch API.</a:t>
+            </a:r>
+          </a:p>
+          <a:p>
+            <a:pPr>
+              <a:spcBef>
+                <a:spcPts val="2400"/>
+              </a:spcBef>
+              <a:defRPr sz="1500" b="1">
+                <a:solidFill>
+                  <a:srgbClr val="BE123C"/>
+                </a:solidFill>
+                <a:latin typeface="Arial"/>
+              </a:defRPr>
+            </a:pPr>
+            <a:r>
+              <a:t>Kính chúc thầy sức khỏe và công tác tốt. Nhóm WNC.G01 xin trân trọng cảm ơn!</a:t>
             </a:r>
           </a:p>
         </p:txBody>
@@ -7447,7 +7629,7 @@
         <p:spPr>
           <a:xfrm>
             <a:off x="731520" y="256032"/>
-            <a:ext cx="4389120" cy="329184"/>
+            <a:ext cx="4572000" cy="329184"/>
           </a:xfrm>
           <a:prstGeom prst="roundRect">
             <a:avLst/>
@@ -7524,7 +7706,7 @@
               </a:defRPr>
             </a:pPr>
             <a:r>
-              <a:t>1.2. SQL Injection: Phân Loại Kỹ Thuật OWASP &amp; Đánh Giá Rủi Ro</a:t>
+              <a:t>1.2. SQL Injection: 4 Kịch Bản Thực Nghiệm Trên Ứng Dụng</a:t>
             </a:r>
           </a:p>
         </p:txBody>
@@ -7538,7 +7720,7 @@
         <p:spPr>
           <a:xfrm>
             <a:off x="731520" y="6537960"/>
-            <a:ext cx="10698480" cy="274320"/>
+            <a:ext cx="10698480" cy="256032"/>
           </a:xfrm>
           <a:prstGeom prst="rect">
             <a:avLst/>
@@ -7565,255 +7747,524 @@
           </a:p>
         </p:txBody>
       </p:sp>
-      <p:sp>
-        <p:nvSpPr>
-          <p:cNvPr id="6" name="Rounded Rectangle 5"/>
-          <p:cNvSpPr/>
-          <p:nvPr/>
-        </p:nvSpPr>
-        <p:spPr>
-          <a:xfrm>
-            <a:off x="731520" y="1234440"/>
-            <a:ext cx="3328416" cy="4937760"/>
-          </a:xfrm>
-          <a:prstGeom prst="roundRect">
-            <a:avLst/>
-          </a:prstGeom>
-          <a:solidFill>
-            <a:srgbClr val="FFF1F2"/>
-          </a:solidFill>
-          <a:ln>
-            <a:solidFill>
-              <a:srgbClr val="FECDD3"/>
-            </a:solidFill>
-          </a:ln>
-        </p:spPr>
-        <p:style>
-          <a:lnRef idx="1">
-            <a:schemeClr val="accent1"/>
-          </a:lnRef>
-          <a:fillRef idx="3">
-            <a:schemeClr val="accent1"/>
-          </a:fillRef>
-          <a:effectRef idx="2">
-            <a:schemeClr val="accent1"/>
-          </a:effectRef>
-          <a:fontRef idx="minor">
-            <a:schemeClr val="lt1"/>
-          </a:fontRef>
-        </p:style>
-        <p:txBody>
-          <a:bodyPr rtlCol="0" anchor="ctr"/>
-          <a:lstStyle/>
-          <a:p>
-            <a:pPr algn="ctr">
-              <a:defRPr sz="1400" b="1">
-                <a:solidFill>
-                  <a:srgbClr val="BE123C"/>
-                </a:solidFill>
-                <a:latin typeface="Arial"/>
-              </a:defRPr>
-            </a:pPr>
-            <a:r>
-              <a:t>VƯỢT QUA XÁC THỰC</a:t>
-            </a:r>
-            <a:br/>
-            <a:r>
-              <a:t>(Authentication Bypass)</a:t>
-            </a:r>
-          </a:p>
-          <a:p>
-            <a:pPr>
-              <a:spcBef>
-                <a:spcPts val="1000"/>
-              </a:spcBef>
-              <a:defRPr sz="1200" b="0">
-                <a:solidFill>
-                  <a:srgbClr val="334155"/>
-                </a:solidFill>
-                <a:latin typeface="Arial"/>
-              </a:defRPr>
-            </a:pPr>
-            <a:r>
-              <a:t>• Cơ chế: Thay đổi cấu trúc logic của mệnh đề WHERE thành luôn đúng (TRUE).</a:t>
-            </a:r>
-            <a:br/>
-            <a:r>
-              <a:t>• Kẻ tấn công đăng nhập thẳng vào tài khoản Quản trị viên (Admin) mà không cần cung cấp mật khẩu.</a:t>
-            </a:r>
-            <a:br/>
-            <a:r>
-              <a:t>• Chiếm đoạt phiên làm việc hợp lệ và thay đổi quyền hạn người dùng trên hệ thống.</a:t>
-            </a:r>
-          </a:p>
-        </p:txBody>
-      </p:sp>
-      <p:sp>
-        <p:nvSpPr>
-          <p:cNvPr id="7" name="Rounded Rectangle 6"/>
-          <p:cNvSpPr/>
-          <p:nvPr/>
-        </p:nvSpPr>
-        <p:spPr>
-          <a:xfrm>
-            <a:off x="4416552" y="1234440"/>
-            <a:ext cx="3328416" cy="4937760"/>
-          </a:xfrm>
-          <a:prstGeom prst="roundRect">
-            <a:avLst/>
-          </a:prstGeom>
-          <a:solidFill>
-            <a:srgbClr val="FFFBEB"/>
-          </a:solidFill>
-          <a:ln>
-            <a:solidFill>
-              <a:srgbClr val="FEF08A"/>
-            </a:solidFill>
-          </a:ln>
-        </p:spPr>
-        <p:style>
-          <a:lnRef idx="1">
-            <a:schemeClr val="accent1"/>
-          </a:lnRef>
-          <a:fillRef idx="3">
-            <a:schemeClr val="accent1"/>
-          </a:fillRef>
-          <a:effectRef idx="2">
-            <a:schemeClr val="accent1"/>
-          </a:effectRef>
-          <a:fontRef idx="minor">
-            <a:schemeClr val="lt1"/>
-          </a:fontRef>
-        </p:style>
-        <p:txBody>
-          <a:bodyPr rtlCol="0" anchor="ctr"/>
-          <a:lstStyle/>
-          <a:p>
-            <a:pPr algn="ctr">
-              <a:defRPr sz="1400" b="1">
-                <a:solidFill>
-                  <a:srgbClr val="B45309"/>
-                </a:solidFill>
-                <a:latin typeface="Arial"/>
-              </a:defRPr>
-            </a:pPr>
-            <a:r>
-              <a:t>TRÍCH XUẤT CƠ SỞ DỮ LIỆU</a:t>
-            </a:r>
-            <a:br/>
-            <a:r>
-              <a:t>(Data Exfiltration)</a:t>
-            </a:r>
-          </a:p>
-          <a:p>
-            <a:pPr>
-              <a:spcBef>
-                <a:spcPts val="1000"/>
-              </a:spcBef>
-              <a:defRPr sz="1200" b="0">
-                <a:solidFill>
-                  <a:srgbClr val="334155"/>
-                </a:solidFill>
-                <a:latin typeface="Arial"/>
-              </a:defRPr>
-            </a:pPr>
-            <a:r>
-              <a:t>• Kỹ thuật Union-Based: Ghép nối bảng dữ liệu nhạy cảm vào kết quả truy vấn thông thường.</a:t>
-            </a:r>
-            <a:br/>
-            <a:r>
-              <a:t>• Kỹ thuật Error-Based / Blind: Suy luận dữ liệu qua thông báo lỗi hoặc độ trễ thời gian (Time Delay).</a:t>
-            </a:r>
-            <a:br/>
-            <a:r>
-              <a:t>• Làm rò rỉ toàn bộ hồ sơ khách hàng, mật khẩu và dữ liệu tài chính.</a:t>
-            </a:r>
-          </a:p>
-        </p:txBody>
-      </p:sp>
-      <p:sp>
-        <p:nvSpPr>
-          <p:cNvPr id="8" name="Rounded Rectangle 7"/>
-          <p:cNvSpPr/>
-          <p:nvPr/>
-        </p:nvSpPr>
-        <p:spPr>
-          <a:xfrm>
-            <a:off x="8101584" y="1234440"/>
-            <a:ext cx="3328416" cy="4937760"/>
-          </a:xfrm>
-          <a:prstGeom prst="roundRect">
-            <a:avLst/>
-          </a:prstGeom>
-          <a:solidFill>
-            <a:srgbClr val="EFF6FF"/>
-          </a:solidFill>
-          <a:ln>
-            <a:solidFill>
-              <a:srgbClr val="BFDBFE"/>
-            </a:solidFill>
-          </a:ln>
-        </p:spPr>
-        <p:style>
-          <a:lnRef idx="1">
-            <a:schemeClr val="accent1"/>
-          </a:lnRef>
-          <a:fillRef idx="3">
-            <a:schemeClr val="accent1"/>
-          </a:fillRef>
-          <a:effectRef idx="2">
-            <a:schemeClr val="accent1"/>
-          </a:effectRef>
-          <a:fontRef idx="minor">
-            <a:schemeClr val="lt1"/>
-          </a:fontRef>
-        </p:style>
-        <p:txBody>
-          <a:bodyPr rtlCol="0" anchor="ctr"/>
-          <a:lstStyle/>
-          <a:p>
-            <a:pPr algn="ctr">
-              <a:defRPr sz="1400" b="1">
-                <a:solidFill>
-                  <a:srgbClr val="1D4ED8"/>
-                </a:solidFill>
-                <a:latin typeface="Arial"/>
-              </a:defRPr>
-            </a:pPr>
-            <a:r>
-              <a:t>PHÁ HỦY / THỰC THI LỆNH</a:t>
-            </a:r>
-            <a:br/>
-            <a:r>
-              <a:t>(System Takeover)</a:t>
-            </a:r>
-          </a:p>
-          <a:p>
-            <a:pPr>
-              <a:spcBef>
-                <a:spcPts val="1000"/>
-              </a:spcBef>
-              <a:defRPr sz="1200" b="0">
-                <a:solidFill>
-                  <a:srgbClr val="334155"/>
-                </a:solidFill>
-                <a:latin typeface="Arial"/>
-              </a:defRPr>
-            </a:pPr>
-            <a:r>
-              <a:t>• Can thiệp DDL: Thực thi câu lệnh DROP TABLE, TRUNCATE làm sập dịch vụ.</a:t>
-            </a:r>
-            <a:br/>
-            <a:r>
-              <a:t>• Can thiệp DML: Thay đổi số dư ví, cấp đặc quyền trái phép.</a:t>
-            </a:r>
-            <a:br/>
-            <a:r>
-              <a:t>• Thực thi lệnh hệ điều hành: Kích hoạt thủ tục xp_cmdshell trên máy chủ SQL Server nếu cấu hình thiếu an toàn.</a:t>
-            </a:r>
-          </a:p>
-        </p:txBody>
-      </p:sp>
+      <p:graphicFrame>
+        <p:nvGraphicFramePr>
+          <p:cNvPr id="6" name="Table 5"/>
+          <p:cNvGraphicFramePr>
+            <a:graphicFrameLocks noGrp="1"/>
+          </p:cNvGraphicFramePr>
+          <p:nvPr/>
+        </p:nvGraphicFramePr>
+        <p:xfrm>
+          <a:off x="731520" y="1280160"/>
+          <a:ext cx="10728655" cy="4846320"/>
+        </p:xfrm>
+        <a:graphic>
+          <a:graphicData uri="http://schemas.openxmlformats.org/drawingml/2006/table">
+            <a:tbl>
+              <a:tblPr firstRow="1" bandRow="1">
+                <a:tableStyleId>{5C22544A-7EE6-4342-B048-85BDC9FD1C3A}</a:tableStyleId>
+              </a:tblPr>
+              <a:tblGrid>
+                <a:gridCol w="2682163"/>
+                <a:gridCol w="2682163"/>
+                <a:gridCol w="2682163"/>
+                <a:gridCol w="2682166"/>
+              </a:tblGrid>
+              <a:tr h="969264">
+                <a:tc>
+                  <a:txBody>
+                    <a:bodyPr/>
+                    <a:lstStyle/>
+                    <a:p>
+                      <a:pPr>
+                        <a:defRPr b="1" sz="1100">
+                          <a:solidFill>
+                            <a:srgbClr val="FFFFFF"/>
+                          </a:solidFill>
+                          <a:latin typeface="Arial"/>
+                        </a:defRPr>
+                      </a:pPr>
+                      <a:r>
+                        <a:t>Kịch bản kiểm thử</a:t>
+                      </a:r>
+                    </a:p>
+                  </a:txBody>
+                  <a:tcPr>
+                    <a:solidFill>
+                      <a:srgbClr val="1D4ED8"/>
+                    </a:solidFill>
+                  </a:tcPr>
+                </a:tc>
+                <a:tc>
+                  <a:txBody>
+                    <a:bodyPr/>
+                    <a:lstStyle/>
+                    <a:p>
+                      <a:pPr>
+                        <a:defRPr b="1" sz="1100">
+                          <a:solidFill>
+                            <a:srgbClr val="FFFFFF"/>
+                          </a:solidFill>
+                          <a:latin typeface="Arial"/>
+                        </a:defRPr>
+                      </a:pPr>
+                      <a:r>
+                        <a:t>Payload đưa vào ô Username</a:t>
+                      </a:r>
+                    </a:p>
+                  </a:txBody>
+                  <a:tcPr>
+                    <a:solidFill>
+                      <a:srgbClr val="1D4ED8"/>
+                    </a:solidFill>
+                  </a:tcPr>
+                </a:tc>
+                <a:tc>
+                  <a:txBody>
+                    <a:bodyPr/>
+                    <a:lstStyle/>
+                    <a:p>
+                      <a:pPr>
+                        <a:defRPr b="1" sz="1100">
+                          <a:solidFill>
+                            <a:srgbClr val="FFFFFF"/>
+                          </a:solidFill>
+                          <a:latin typeface="Arial"/>
+                        </a:defRPr>
+                      </a:pPr>
+                      <a:r>
+                        <a:t>Cơ chế bẻ gãy cú pháp</a:t>
+                      </a:r>
+                    </a:p>
+                  </a:txBody>
+                  <a:tcPr>
+                    <a:solidFill>
+                      <a:srgbClr val="1D4ED8"/>
+                    </a:solidFill>
+                  </a:tcPr>
+                </a:tc>
+                <a:tc>
+                  <a:txBody>
+                    <a:bodyPr/>
+                    <a:lstStyle/>
+                    <a:p>
+                      <a:pPr>
+                        <a:defRPr b="1" sz="1100">
+                          <a:solidFill>
+                            <a:srgbClr val="FFFFFF"/>
+                          </a:solidFill>
+                          <a:latin typeface="Arial"/>
+                        </a:defRPr>
+                      </a:pPr>
+                      <a:r>
+                        <a:t>Kết quả thực tế</a:t>
+                      </a:r>
+                    </a:p>
+                  </a:txBody>
+                  <a:tcPr>
+                    <a:solidFill>
+                      <a:srgbClr val="1D4ED8"/>
+                    </a:solidFill>
+                  </a:tcPr>
+                </a:tc>
+              </a:tr>
+              <a:tr h="969264">
+                <a:tc>
+                  <a:txBody>
+                    <a:bodyPr/>
+                    <a:lstStyle/>
+                    <a:p>
+                      <a:pPr>
+                        <a:defRPr sz="1050">
+                          <a:solidFill>
+                            <a:srgbClr val="0F172A"/>
+                          </a:solidFill>
+                          <a:latin typeface="Arial"/>
+                        </a:defRPr>
+                      </a:pPr>
+                      <a:r>
+                        <a:t>Payload 1: Bypass tổng quát</a:t>
+                      </a:r>
+                    </a:p>
+                  </a:txBody>
+                  <a:tcPr>
+                    <a:solidFill>
+                      <a:srgbClr val="F8FAFC"/>
+                    </a:solidFill>
+                  </a:tcPr>
+                </a:tc>
+                <a:tc>
+                  <a:txBody>
+                    <a:bodyPr/>
+                    <a:lstStyle/>
+                    <a:p>
+                      <a:pPr>
+                        <a:defRPr sz="1050" b="1">
+                          <a:solidFill>
+                            <a:srgbClr val="BE123C"/>
+                          </a:solidFill>
+                          <a:latin typeface="Courier New"/>
+                        </a:defRPr>
+                      </a:pPr>
+                      <a:r>
+                        <a:t>' OR '1'='1' --</a:t>
+                      </a:r>
+                    </a:p>
+                  </a:txBody>
+                  <a:tcPr>
+                    <a:solidFill>
+                      <a:srgbClr val="F8FAFC"/>
+                    </a:solidFill>
+                  </a:tcPr>
+                </a:tc>
+                <a:tc>
+                  <a:txBody>
+                    <a:bodyPr/>
+                    <a:lstStyle/>
+                    <a:p>
+                      <a:pPr>
+                        <a:defRPr sz="1050">
+                          <a:solidFill>
+                            <a:srgbClr val="334155"/>
+                          </a:solidFill>
+                          <a:latin typeface="Arial"/>
+                        </a:defRPr>
+                      </a:pPr>
+                      <a:r>
+                        <a:t>Nháy đơn (') đóng chuỗi; OR '1'='1' luôn đúng; '--' hủy vế kiểm tra pass.</a:t>
+                      </a:r>
+                    </a:p>
+                  </a:txBody>
+                  <a:tcPr>
+                    <a:solidFill>
+                      <a:srgbClr val="F8FAFC"/>
+                    </a:solidFill>
+                  </a:tcPr>
+                </a:tc>
+                <a:tc>
+                  <a:txBody>
+                    <a:bodyPr/>
+                    <a:lstStyle/>
+                    <a:p>
+                      <a:pPr>
+                        <a:defRPr sz="1050">
+                          <a:solidFill>
+                            <a:srgbClr val="334155"/>
+                          </a:solidFill>
+                          <a:latin typeface="Arial"/>
+                        </a:defRPr>
+                      </a:pPr>
+                      <a:r>
+                        <a:t>Bypass thành công, lấy tài khoản đầu tiên trong bảng (Admin).</a:t>
+                      </a:r>
+                    </a:p>
+                  </a:txBody>
+                  <a:tcPr>
+                    <a:solidFill>
+                      <a:srgbClr val="F8FAFC"/>
+                    </a:solidFill>
+                  </a:tcPr>
+                </a:tc>
+              </a:tr>
+              <a:tr h="969264">
+                <a:tc>
+                  <a:txBody>
+                    <a:bodyPr/>
+                    <a:lstStyle/>
+                    <a:p>
+                      <a:pPr>
+                        <a:defRPr sz="1050">
+                          <a:solidFill>
+                            <a:srgbClr val="0F172A"/>
+                          </a:solidFill>
+                          <a:latin typeface="Arial"/>
+                        </a:defRPr>
+                      </a:pPr>
+                      <a:r>
+                        <a:t>Payload 2: Nhắm đích danh Admin</a:t>
+                      </a:r>
+                    </a:p>
+                  </a:txBody>
+                  <a:tcPr>
+                    <a:solidFill>
+                      <a:srgbClr val="FFFFFF"/>
+                    </a:solidFill>
+                  </a:tcPr>
+                </a:tc>
+                <a:tc>
+                  <a:txBody>
+                    <a:bodyPr/>
+                    <a:lstStyle/>
+                    <a:p>
+                      <a:pPr>
+                        <a:defRPr sz="1050" b="1">
+                          <a:solidFill>
+                            <a:srgbClr val="BE123C"/>
+                          </a:solidFill>
+                          <a:latin typeface="Courier New"/>
+                        </a:defRPr>
+                      </a:pPr>
+                      <a:r>
+                        <a:t>admin' --</a:t>
+                      </a:r>
+                    </a:p>
+                  </a:txBody>
+                  <a:tcPr>
+                    <a:solidFill>
+                      <a:srgbClr val="FFFFFF"/>
+                    </a:solidFill>
+                  </a:tcPr>
+                </a:tc>
+                <a:tc>
+                  <a:txBody>
+                    <a:bodyPr/>
+                    <a:lstStyle/>
+                    <a:p>
+                      <a:pPr>
+                        <a:defRPr sz="1050">
+                          <a:solidFill>
+                            <a:srgbClr val="334155"/>
+                          </a:solidFill>
+                          <a:latin typeface="Arial"/>
+                        </a:defRPr>
+                      </a:pPr>
+                      <a:r>
+                        <a:t>Cố định Username = 'admin'; '--' vô hiệu hóa toàn bộ vế AND Password = ...</a:t>
+                      </a:r>
+                    </a:p>
+                  </a:txBody>
+                  <a:tcPr>
+                    <a:solidFill>
+                      <a:srgbClr val="FFFFFF"/>
+                    </a:solidFill>
+                  </a:tcPr>
+                </a:tc>
+                <a:tc>
+                  <a:txBody>
+                    <a:bodyPr/>
+                    <a:lstStyle/>
+                    <a:p>
+                      <a:pPr>
+                        <a:defRPr sz="1050">
+                          <a:solidFill>
+                            <a:srgbClr val="334155"/>
+                          </a:solidFill>
+                          <a:latin typeface="Arial"/>
+                        </a:defRPr>
+                      </a:pPr>
+                      <a:r>
+                        <a:t>Chiếm đoạt chính xác quyền Admin mà không cần dò mật khẩu.</a:t>
+                      </a:r>
+                    </a:p>
+                  </a:txBody>
+                  <a:tcPr>
+                    <a:solidFill>
+                      <a:srgbClr val="FFFFFF"/>
+                    </a:solidFill>
+                  </a:tcPr>
+                </a:tc>
+              </a:tr>
+              <a:tr h="969264">
+                <a:tc>
+                  <a:txBody>
+                    <a:bodyPr/>
+                    <a:lstStyle/>
+                    <a:p>
+                      <a:pPr>
+                        <a:defRPr sz="1050">
+                          <a:solidFill>
+                            <a:srgbClr val="0F172A"/>
+                          </a:solidFill>
+                          <a:latin typeface="Arial"/>
+                        </a:defRPr>
+                      </a:pPr>
+                      <a:r>
+                        <a:t>Payload 3: Logic số học</a:t>
+                      </a:r>
+                    </a:p>
+                  </a:txBody>
+                  <a:tcPr>
+                    <a:solidFill>
+                      <a:srgbClr val="F8FAFC"/>
+                    </a:solidFill>
+                  </a:tcPr>
+                </a:tc>
+                <a:tc>
+                  <a:txBody>
+                    <a:bodyPr/>
+                    <a:lstStyle/>
+                    <a:p>
+                      <a:pPr>
+                        <a:defRPr sz="1050" b="1">
+                          <a:solidFill>
+                            <a:srgbClr val="BE123C"/>
+                          </a:solidFill>
+                          <a:latin typeface="Courier New"/>
+                        </a:defRPr>
+                      </a:pPr>
+                      <a:r>
+                        <a:t>' OR 1=1 --</a:t>
+                      </a:r>
+                    </a:p>
+                  </a:txBody>
+                  <a:tcPr>
+                    <a:solidFill>
+                      <a:srgbClr val="F8FAFC"/>
+                    </a:solidFill>
+                  </a:tcPr>
+                </a:tc>
+                <a:tc>
+                  <a:txBody>
+                    <a:bodyPr/>
+                    <a:lstStyle/>
+                    <a:p>
+                      <a:pPr>
+                        <a:defRPr sz="1050">
+                          <a:solidFill>
+                            <a:srgbClr val="334155"/>
+                          </a:solidFill>
+                          <a:latin typeface="Arial"/>
+                        </a:defRPr>
+                      </a:pPr>
+                      <a:r>
+                        <a:t>Biểu thức số 1=1 luôn đúng, không phụ thuộc định dạng dấu nháy của CSDL.</a:t>
+                      </a:r>
+                    </a:p>
+                  </a:txBody>
+                  <a:tcPr>
+                    <a:solidFill>
+                      <a:srgbClr val="F8FAFC"/>
+                    </a:solidFill>
+                  </a:tcPr>
+                </a:tc>
+                <a:tc>
+                  <a:txBody>
+                    <a:bodyPr/>
+                    <a:lstStyle/>
+                    <a:p>
+                      <a:pPr>
+                        <a:defRPr sz="1050">
+                          <a:solidFill>
+                            <a:srgbClr val="334155"/>
+                          </a:solidFill>
+                          <a:latin typeface="Arial"/>
+                        </a:defRPr>
+                      </a:pPr>
+                      <a:r>
+                        <a:t>Trích xuất toàn bộ 4 tài khoản CSDL ra màn hình.</a:t>
+                      </a:r>
+                    </a:p>
+                  </a:txBody>
+                  <a:tcPr>
+                    <a:solidFill>
+                      <a:srgbClr val="F8FAFC"/>
+                    </a:solidFill>
+                  </a:tcPr>
+                </a:tc>
+              </a:tr>
+              <a:tr h="969264">
+                <a:tc>
+                  <a:txBody>
+                    <a:bodyPr/>
+                    <a:lstStyle/>
+                    <a:p>
+                      <a:pPr>
+                        <a:defRPr sz="1050">
+                          <a:solidFill>
+                            <a:srgbClr val="0F172A"/>
+                          </a:solidFill>
+                          <a:latin typeface="Arial"/>
+                        </a:defRPr>
+                      </a:pPr>
+                      <a:r>
+                        <a:t>Kịch bản chuẩn: Đăng nhập đúng</a:t>
+                      </a:r>
+                    </a:p>
+                  </a:txBody>
+                  <a:tcPr>
+                    <a:solidFill>
+                      <a:srgbClr val="FFFFFF"/>
+                    </a:solidFill>
+                  </a:tcPr>
+                </a:tc>
+                <a:tc>
+                  <a:txBody>
+                    <a:bodyPr/>
+                    <a:lstStyle/>
+                    <a:p>
+                      <a:pPr>
+                        <a:defRPr sz="1050" b="1">
+                          <a:solidFill>
+                            <a:srgbClr val="047857"/>
+                          </a:solidFill>
+                          <a:latin typeface="Courier New"/>
+                        </a:defRPr>
+                      </a:pPr>
+                      <a:r>
+                        <a:t>admin / AdminPassword@2026</a:t>
+                      </a:r>
+                    </a:p>
+                  </a:txBody>
+                  <a:tcPr>
+                    <a:solidFill>
+                      <a:srgbClr val="FFFFFF"/>
+                    </a:solidFill>
+                  </a:tcPr>
+                </a:tc>
+                <a:tc>
+                  <a:txBody>
+                    <a:bodyPr/>
+                    <a:lstStyle/>
+                    <a:p>
+                      <a:pPr>
+                        <a:defRPr sz="1050">
+                          <a:solidFill>
+                            <a:srgbClr val="334155"/>
+                          </a:solidFill>
+                          <a:latin typeface="Arial"/>
+                        </a:defRPr>
+                      </a:pPr>
+                      <a:r>
+                        <a:t>Dữ liệu hợp lệ, không chứa ký tự điều khiển hay can thiệp cú pháp.</a:t>
+                      </a:r>
+                    </a:p>
+                  </a:txBody>
+                  <a:tcPr>
+                    <a:solidFill>
+                      <a:srgbClr val="FFFFFF"/>
+                    </a:solidFill>
+                  </a:tcPr>
+                </a:tc>
+                <a:tc>
+                  <a:txBody>
+                    <a:bodyPr/>
+                    <a:lstStyle/>
+                    <a:p>
+                      <a:pPr>
+                        <a:defRPr sz="1050">
+                          <a:solidFill>
+                            <a:srgbClr val="334155"/>
+                          </a:solidFill>
+                          <a:latin typeface="Arial"/>
+                        </a:defRPr>
+                      </a:pPr>
+                      <a:r>
+                        <a:t>Đăng nhập thành công trên cả 2 nhánh (Lỗi &amp; Đã vá).</a:t>
+                      </a:r>
+                    </a:p>
+                  </a:txBody>
+                  <a:tcPr>
+                    <a:solidFill>
+                      <a:srgbClr val="FFFFFF"/>
+                    </a:solidFill>
+                  </a:tcPr>
+                </a:tc>
+              </a:tr>
+            </a:tbl>
+          </a:graphicData>
+        </a:graphic>
+      </p:graphicFrame>
     </p:spTree>
   </p:cSld>
   <p:clrMapOvr>
@@ -7884,7 +8335,7 @@
         <p:spPr>
           <a:xfrm>
             <a:off x="731520" y="256032"/>
-            <a:ext cx="4389120" cy="329184"/>
+            <a:ext cx="4572000" cy="329184"/>
           </a:xfrm>
           <a:prstGeom prst="roundRect">
             <a:avLst/>
@@ -7961,7 +8412,7 @@
               </a:defRPr>
             </a:pPr>
             <a:r>
-              <a:t>1.3. SQL Injection: Phân Tích Cấu Trúc Khai Thác Của Payload</a:t>
+              <a:t>1.3. SQL Injection: Minh Chứng Thực Nghiệm Trực Quan Trên Web UI</a:t>
             </a:r>
           </a:p>
         </p:txBody>
@@ -7975,7 +8426,7 @@
         <p:spPr>
           <a:xfrm>
             <a:off x="731520" y="6537960"/>
-            <a:ext cx="10698480" cy="274320"/>
+            <a:ext cx="10698480" cy="256032"/>
           </a:xfrm>
           <a:prstGeom prst="rect">
             <a:avLst/>
@@ -8002,133 +8453,62 @@
           </a:p>
         </p:txBody>
       </p:sp>
-      <p:sp>
-        <p:nvSpPr>
-          <p:cNvPr id="6" name="Rounded Rectangle 5"/>
-          <p:cNvSpPr/>
-          <p:nvPr/>
-        </p:nvSpPr>
-        <p:spPr>
-          <a:xfrm>
-            <a:off x="731520" y="1234440"/>
-            <a:ext cx="10728655" cy="4937760"/>
-          </a:xfrm>
-          <a:prstGeom prst="roundRect">
-            <a:avLst/>
-          </a:prstGeom>
-          <a:solidFill>
-            <a:srgbClr val="F8FAFC"/>
-          </a:solidFill>
-          <a:ln>
-            <a:solidFill>
-              <a:srgbClr val="E2E8F0"/>
-            </a:solidFill>
-          </a:ln>
-        </p:spPr>
-        <p:style>
-          <a:lnRef idx="1">
-            <a:schemeClr val="accent1"/>
-          </a:lnRef>
-          <a:fillRef idx="3">
-            <a:schemeClr val="accent1"/>
-          </a:fillRef>
-          <a:effectRef idx="2">
-            <a:schemeClr val="accent1"/>
-          </a:effectRef>
-          <a:fontRef idx="minor">
-            <a:schemeClr val="lt1"/>
-          </a:fontRef>
-        </p:style>
-        <p:txBody>
-          <a:bodyPr rtlCol="0" anchor="ctr"/>
+      <p:pic>
+        <p:nvPicPr>
+          <p:cNvPr id="6" name="Picture 5" descr="final_sqli_proof.png"/>
+          <p:cNvPicPr>
+            <a:picLocks noChangeAspect="1"/>
+          </p:cNvPicPr>
+          <p:nvPr/>
+        </p:nvPicPr>
+        <p:blipFill>
+          <a:blip r:embed="rId2"/>
+          <a:stretch>
+            <a:fillRect/>
+          </a:stretch>
+        </p:blipFill>
+        <p:spPr>
+          <a:xfrm>
+            <a:off x="2066543" y="1234440"/>
+            <a:ext cx="8046720" cy="4754880"/>
+          </a:xfrm>
+          <a:prstGeom prst="rect">
+            <a:avLst/>
+          </a:prstGeom>
+        </p:spPr>
+      </p:pic>
+      <p:sp>
+        <p:nvSpPr>
+          <p:cNvPr id="7" name="TextBox 6"/>
+          <p:cNvSpPr txBox="1"/>
+          <p:nvPr/>
+        </p:nvSpPr>
+        <p:spPr>
+          <a:xfrm>
+            <a:off x="731520" y="6053328"/>
+            <a:ext cx="10728655" cy="365760"/>
+          </a:xfrm>
+          <a:prstGeom prst="rect">
+            <a:avLst/>
+          </a:prstGeom>
+          <a:noFill/>
+        </p:spPr>
+        <p:txBody>
+          <a:bodyPr wrap="none" tIns="0" bIns="0" lIns="0" rIns="0">
+            <a:spAutoFit/>
+          </a:bodyPr>
           <a:lstStyle/>
           <a:p>
             <a:pPr algn="ctr">
-              <a:defRPr sz="1500" b="1">
-                <a:solidFill>
-                  <a:srgbClr val="BE123C"/>
-                </a:solidFill>
-                <a:latin typeface="Arial"/>
-              </a:defRPr>
-            </a:pPr>
-            <a:r>
-              <a:t>Kịch Bản: Bypass Đăng Nhập Với Chuỗi Khai Thác ' OR '1'='1' --</a:t>
-            </a:r>
-          </a:p>
-          <a:p>
-            <a:pPr>
-              <a:spcBef>
-                <a:spcPts val="600"/>
-              </a:spcBef>
-              <a:defRPr sz="1200" b="1">
+              <a:defRPr sz="1100" b="1">
                 <a:solidFill>
                   <a:srgbClr val="1D4ED8"/>
                 </a:solidFill>
-                <a:latin typeface="Courier New"/>
-              </a:defRPr>
-            </a:pPr>
-            <a:r>
-              <a:t>Giá trị Username đưa vào: ' OR '1'='1' --  | Mật khẩu: (tùy ý hoặc để trống)</a:t>
-            </a:r>
-            <a:br/>
-            <a:r>
-              <a:t>Truy vấn được máy chủ SQL Server phân tích &amp; thông dịch:</a:t>
-            </a:r>
-            <a:br/>
-            <a:r>
-              <a:t>SELECT * FROM Accounts WHERE Username = '' OR '1'='1' --' AND Password = 'xyz'</a:t>
-            </a:r>
-          </a:p>
-          <a:p>
-            <a:pPr>
-              <a:spcBef>
-                <a:spcPts val="1000"/>
-              </a:spcBef>
-              <a:defRPr sz="1250" b="0">
-                <a:solidFill>
-                  <a:srgbClr val="334155"/>
-                </a:solidFill>
-                <a:latin typeface="Arial"/>
-              </a:defRPr>
-            </a:pPr>
-            <a:r>
-              <a:t>Giải Phẫu 3 Thành Phần Khai Thác Cốt Lõi:</a:t>
-            </a:r>
-            <a:br/>
-            <a:r>
-              <a:t>1. Dấu nháy đơn (') : Đóng sớm chuỗi ký tự của trường Username, chuyển ngữ cảnh về cú pháp lệnh SQL.</a:t>
-            </a:r>
-            <a:br/>
-            <a:r>
-              <a:t>2. Mệnh đề OR '1'='1' : Biểu thức logic chân lý (luôn TRUE với mọi bản ghi trong bảng Accounts, khiến toàn bộ điều kiện lọc bị vô hiệu).</a:t>
-            </a:r>
-            <a:br/>
-            <a:r>
-              <a:t>3. Ký tự chú thích (--) : Báo cho máy chủ SQL bỏ qua toàn bộ phần kiểm tra mật khẩu phía sau (AND Password = '...').</a:t>
-            </a:r>
-          </a:p>
-          <a:p>
-            <a:pPr>
-              <a:spcBef>
-                <a:spcPts val="1000"/>
-              </a:spcBef>
-              <a:defRPr sz="1250" b="1">
-                <a:solidFill>
-                  <a:srgbClr val="B45309"/>
-                </a:solidFill>
-                <a:latin typeface="Arial"/>
-              </a:defRPr>
-            </a:pPr>
-            <a:r>
-              <a:t>Mở Rộng Kỹ Thuật Union-Based:</a:t>
-            </a:r>
-            <a:br/>
-            <a:r>
-              <a:t>Payload: ' UNION SELECT Id, Username, Password, SecretNote FROM Accounts --</a:t>
-            </a:r>
-            <a:br/>
-            <a:r>
-              <a:t>Cho phép kẻ tấn công trích xuất danh sách tài khoản quản trị và bí mật hệ thống trên các màn hình tra cứu thông thường.</a:t>
+                <a:latin typeface="Arial"/>
+              </a:defRPr>
+            </a:pPr>
+            <a:r>
+              <a:t>Minh chứng đối chứng: Trích xuất 4 tài khoản CSDL khi inject ' OR '1'='1' -- (Trái) vs Chặn đứng an toàn với EF Core (Phải)</a:t>
             </a:r>
           </a:p>
         </p:txBody>
@@ -8203,7 +8583,7 @@
         <p:spPr>
           <a:xfrm>
             <a:off x="731520" y="256032"/>
-            <a:ext cx="4389120" cy="329184"/>
+            <a:ext cx="4572000" cy="329184"/>
           </a:xfrm>
           <a:prstGeom prst="roundRect">
             <a:avLst/>
@@ -8294,7 +8674,7 @@
         <p:spPr>
           <a:xfrm>
             <a:off x="731520" y="6537960"/>
-            <a:ext cx="10698480" cy="274320"/>
+            <a:ext cx="10698480" cy="256032"/>
           </a:xfrm>
           <a:prstGeom prst="rect">
             <a:avLst/>
@@ -8376,7 +8756,7 @@
               </a:defRPr>
             </a:pPr>
             <a:r>
-              <a:t>Minh chứng đối chứng: Kiểm tra gói tin mạng (Network Fetch/XHR): Payload gửi lên và JSON trích xuất CSDL ' OR '1'='1' -- (Trái) vs Chặn đứng an toàn với EF Core (Phải)</a:t>
+              <a:t>Soi gói tin mạng (Network Fetch/XHR): Payload gửi lên mang chuỗi ' OR '1'='1' -- và JSON trích xuất 4 tài khoản rò rỉ</a:t>
             </a:r>
           </a:p>
         </p:txBody>
@@ -8451,7 +8831,7 @@
         <p:spPr>
           <a:xfrm>
             <a:off x="731520" y="256032"/>
-            <a:ext cx="4389120" cy="329184"/>
+            <a:ext cx="4572000" cy="329184"/>
           </a:xfrm>
           <a:prstGeom prst="roundRect">
             <a:avLst/>
@@ -8542,7 +8922,7 @@
         <p:spPr>
           <a:xfrm>
             <a:off x="731520" y="6537960"/>
-            <a:ext cx="10698480" cy="274320"/>
+            <a:ext cx="10698480" cy="256032"/>
           </a:xfrm>
           <a:prstGeom prst="rect">
             <a:avLst/>
@@ -8664,7 +9044,7 @@
             </a:r>
             <a:br/>
             <a:r>
-              <a:t>  "accounts": [ ... danh sách tài khoản trích xuất ... ]</a:t>
+              <a:t>  "accounts": [ ... 4 tài khoản trích xuất ... ]</a:t>
             </a:r>
             <a:br/>
             <a:r>
@@ -8946,7 +9326,7 @@
         <p:spPr>
           <a:xfrm>
             <a:off x="731520" y="256032"/>
-            <a:ext cx="4389120" cy="329184"/>
+            <a:ext cx="4572000" cy="329184"/>
           </a:xfrm>
           <a:prstGeom prst="roundRect">
             <a:avLst/>
@@ -9037,7 +9417,7 @@
         <p:spPr>
           <a:xfrm>
             <a:off x="731520" y="6537960"/>
-            <a:ext cx="10698480" cy="274320"/>
+            <a:ext cx="10698480" cy="256032"/>
           </a:xfrm>
           <a:prstGeom prst="rect">
             <a:avLst/>
@@ -9356,7 +9736,7 @@
         <p:spPr>
           <a:xfrm>
             <a:off x="731520" y="256032"/>
-            <a:ext cx="4389120" cy="329184"/>
+            <a:ext cx="4572000" cy="329184"/>
           </a:xfrm>
           <a:prstGeom prst="roundRect">
             <a:avLst/>
@@ -9447,7 +9827,7 @@
         <p:spPr>
           <a:xfrm>
             <a:off x="731520" y="6537960"/>
-            <a:ext cx="10698480" cy="274320"/>
+            <a:ext cx="10698480" cy="256032"/>
           </a:xfrm>
           <a:prstGeom prst="rect">
             <a:avLst/>
@@ -9791,7 +10171,7 @@
         <p:spPr>
           <a:xfrm>
             <a:off x="731520" y="256032"/>
-            <a:ext cx="4389120" cy="329184"/>
+            <a:ext cx="4572000" cy="329184"/>
           </a:xfrm>
           <a:prstGeom prst="roundRect">
             <a:avLst/>
@@ -9868,7 +10248,7 @@
               </a:defRPr>
             </a:pPr>
             <a:r>
-              <a:t>2.2. Stored XSS: Đánh Giá Rủi Ro &amp; Cơ Chế Chiếm Đoạt Phiên</a:t>
+              <a:t>2.2. Stored XSS: 4 Kịch Bản Thực Nghiệm Trên Ứng Dụng</a:t>
             </a:r>
           </a:p>
         </p:txBody>
@@ -9882,7 +10262,7 @@
         <p:spPr>
           <a:xfrm>
             <a:off x="731520" y="6537960"/>
-            <a:ext cx="10698480" cy="274320"/>
+            <a:ext cx="10698480" cy="256032"/>
           </a:xfrm>
           <a:prstGeom prst="rect">
             <a:avLst/>
@@ -9909,255 +10289,524 @@
           </a:p>
         </p:txBody>
       </p:sp>
-      <p:sp>
-        <p:nvSpPr>
-          <p:cNvPr id="6" name="Rounded Rectangle 5"/>
-          <p:cNvSpPr/>
-          <p:nvPr/>
-        </p:nvSpPr>
-        <p:spPr>
-          <a:xfrm>
-            <a:off x="731520" y="1234440"/>
-            <a:ext cx="3328416" cy="4937760"/>
-          </a:xfrm>
-          <a:prstGeom prst="roundRect">
-            <a:avLst/>
-          </a:prstGeom>
-          <a:solidFill>
-            <a:srgbClr val="FFF1F2"/>
-          </a:solidFill>
-          <a:ln>
-            <a:solidFill>
-              <a:srgbClr val="FECDD3"/>
-            </a:solidFill>
-          </a:ln>
-        </p:spPr>
-        <p:style>
-          <a:lnRef idx="1">
-            <a:schemeClr val="accent1"/>
-          </a:lnRef>
-          <a:fillRef idx="3">
-            <a:schemeClr val="accent1"/>
-          </a:fillRef>
-          <a:effectRef idx="2">
-            <a:schemeClr val="accent1"/>
-          </a:effectRef>
-          <a:fontRef idx="minor">
-            <a:schemeClr val="lt1"/>
-          </a:fontRef>
-        </p:style>
-        <p:txBody>
-          <a:bodyPr rtlCol="0" anchor="ctr"/>
-          <a:lstStyle/>
-          <a:p>
-            <a:pPr algn="ctr">
-              <a:defRPr sz="1400" b="1">
-                <a:solidFill>
-                  <a:srgbClr val="BE123C"/>
-                </a:solidFill>
-                <a:latin typeface="Arial"/>
-              </a:defRPr>
-            </a:pPr>
-            <a:r>
-              <a:t>ĐÁNH CẮP COOKIE &amp; PHIÊN</a:t>
-            </a:r>
-            <a:br/>
-            <a:r>
-              <a:t>(Session Hijacking)</a:t>
-            </a:r>
-          </a:p>
-          <a:p>
-            <a:pPr>
-              <a:spcBef>
-                <a:spcPts val="1000"/>
-              </a:spcBef>
-              <a:defRPr sz="1200" b="0">
-                <a:solidFill>
-                  <a:srgbClr val="334155"/>
-                </a:solidFill>
-                <a:latin typeface="Arial"/>
-              </a:defRPr>
-            </a:pPr>
-            <a:r>
-              <a:t>• Đoạn script đọc thuộc tính document.cookie để trích xuất token phiên làm việc.</a:t>
-            </a:r>
-            <a:br/>
-            <a:r>
-              <a:t>• Dữ liệu xác thực được gửi ngầm về máy chủ điều khiển của kẻ tấn công.</a:t>
-            </a:r>
-            <a:br/>
-            <a:r>
-              <a:t>• Kẻ tấn công sử dụng token để mạo danh người dùng hợp lệ.</a:t>
-            </a:r>
-          </a:p>
-        </p:txBody>
-      </p:sp>
-      <p:sp>
-        <p:nvSpPr>
-          <p:cNvPr id="7" name="Rounded Rectangle 6"/>
-          <p:cNvSpPr/>
-          <p:nvPr/>
-        </p:nvSpPr>
-        <p:spPr>
-          <a:xfrm>
-            <a:off x="4416552" y="1234440"/>
-            <a:ext cx="3328416" cy="4937760"/>
-          </a:xfrm>
-          <a:prstGeom prst="roundRect">
-            <a:avLst/>
-          </a:prstGeom>
-          <a:solidFill>
-            <a:srgbClr val="FFFBEB"/>
-          </a:solidFill>
-          <a:ln>
-            <a:solidFill>
-              <a:srgbClr val="FEF08A"/>
-            </a:solidFill>
-          </a:ln>
-        </p:spPr>
-        <p:style>
-          <a:lnRef idx="1">
-            <a:schemeClr val="accent1"/>
-          </a:lnRef>
-          <a:fillRef idx="3">
-            <a:schemeClr val="accent1"/>
-          </a:fillRef>
-          <a:effectRef idx="2">
-            <a:schemeClr val="accent1"/>
-          </a:effectRef>
-          <a:fontRef idx="minor">
-            <a:schemeClr val="lt1"/>
-          </a:fontRef>
-        </p:style>
-        <p:txBody>
-          <a:bodyPr rtlCol="0" anchor="ctr"/>
-          <a:lstStyle/>
-          <a:p>
-            <a:pPr algn="ctr">
-              <a:defRPr sz="1400" b="1">
-                <a:solidFill>
-                  <a:srgbClr val="B45309"/>
-                </a:solidFill>
-                <a:latin typeface="Arial"/>
-              </a:defRPr>
-            </a:pPr>
-            <a:r>
-              <a:t>THAY ĐỔI CẤU TRÚC DOM</a:t>
-            </a:r>
-            <a:br/>
-            <a:r>
-              <a:t>(DOM Manipulation / Phishing)</a:t>
-            </a:r>
-          </a:p>
-          <a:p>
-            <a:pPr>
-              <a:spcBef>
-                <a:spcPts val="1000"/>
-              </a:spcBef>
-              <a:defRPr sz="1200" b="0">
-                <a:solidFill>
-                  <a:srgbClr val="334155"/>
-                </a:solidFill>
-                <a:latin typeface="Arial"/>
-              </a:defRPr>
-            </a:pPr>
-            <a:r>
-              <a:t>• Thay đổi cấu trúc giao diện trang web, chèn các form đăng nhập giả mạo.</a:t>
-            </a:r>
-            <a:br/>
-            <a:r>
-              <a:t>• Lừa người dùng nhập thông tin nhạy cảm trên giao diện đã bị sửa đổi.</a:t>
-            </a:r>
-            <a:br/>
-            <a:r>
-              <a:t>• Tự động điều hướng người dùng sang các liên kết độc hại.</a:t>
-            </a:r>
-          </a:p>
-        </p:txBody>
-      </p:sp>
-      <p:sp>
-        <p:nvSpPr>
-          <p:cNvPr id="8" name="Rounded Rectangle 7"/>
-          <p:cNvSpPr/>
-          <p:nvPr/>
-        </p:nvSpPr>
-        <p:spPr>
-          <a:xfrm>
-            <a:off x="8101584" y="1234440"/>
-            <a:ext cx="3328416" cy="4937760"/>
-          </a:xfrm>
-          <a:prstGeom prst="roundRect">
-            <a:avLst/>
-          </a:prstGeom>
-          <a:solidFill>
-            <a:srgbClr val="EFF6FF"/>
-          </a:solidFill>
-          <a:ln>
-            <a:solidFill>
-              <a:srgbClr val="BFDBFE"/>
-            </a:solidFill>
-          </a:ln>
-        </p:spPr>
-        <p:style>
-          <a:lnRef idx="1">
-            <a:schemeClr val="accent1"/>
-          </a:lnRef>
-          <a:fillRef idx="3">
-            <a:schemeClr val="accent1"/>
-          </a:fillRef>
-          <a:effectRef idx="2">
-            <a:schemeClr val="accent1"/>
-          </a:effectRef>
-          <a:fontRef idx="minor">
-            <a:schemeClr val="lt1"/>
-          </a:fontRef>
-        </p:style>
-        <p:txBody>
-          <a:bodyPr rtlCol="0" anchor="ctr"/>
-          <a:lstStyle/>
-          <a:p>
-            <a:pPr algn="ctr">
-              <a:defRPr sz="1400" b="1">
-                <a:solidFill>
-                  <a:srgbClr val="1D4ED8"/>
-                </a:solidFill>
-                <a:latin typeface="Arial"/>
-              </a:defRPr>
-            </a:pPr>
-            <a:r>
-              <a:t>THỰC THI THAO TÁC TRÁI PHÉP</a:t>
-            </a:r>
-            <a:br/>
-            <a:r>
-              <a:t>(Client-Side Exploitation)</a:t>
-            </a:r>
-          </a:p>
-          <a:p>
-            <a:pPr>
-              <a:spcBef>
-                <a:spcPts val="1000"/>
-              </a:spcBef>
-              <a:defRPr sz="1200" b="0">
-                <a:solidFill>
-                  <a:srgbClr val="334155"/>
-                </a:solidFill>
-                <a:latin typeface="Arial"/>
-              </a:defRPr>
-            </a:pPr>
-            <a:r>
-              <a:t>• Ghi nhận thao tác bàn phím (Keylogging) khi người dùng nhập liệu.</a:t>
-            </a:r>
-            <a:br/>
-            <a:r>
-              <a:t>• Tự động thực hiện các hành động gửi tin nhắn hoặc đánh giá mạo danh người dùng.</a:t>
-            </a:r>
-            <a:br/>
-            <a:r>
-              <a:t>• Tận dụng quyền truy cập trình duyệt để mở rộng phạm vi tấn công.</a:t>
-            </a:r>
-          </a:p>
-        </p:txBody>
-      </p:sp>
+      <p:graphicFrame>
+        <p:nvGraphicFramePr>
+          <p:cNvPr id="6" name="Table 5"/>
+          <p:cNvGraphicFramePr>
+            <a:graphicFrameLocks noGrp="1"/>
+          </p:cNvGraphicFramePr>
+          <p:nvPr/>
+        </p:nvGraphicFramePr>
+        <p:xfrm>
+          <a:off x="731520" y="1280160"/>
+          <a:ext cx="10728655" cy="4846320"/>
+        </p:xfrm>
+        <a:graphic>
+          <a:graphicData uri="http://schemas.openxmlformats.org/drawingml/2006/table">
+            <a:tbl>
+              <a:tblPr firstRow="1" bandRow="1">
+                <a:tableStyleId>{5C22544A-7EE6-4342-B048-85BDC9FD1C3A}</a:tableStyleId>
+              </a:tblPr>
+              <a:tblGrid>
+                <a:gridCol w="2682163"/>
+                <a:gridCol w="2682163"/>
+                <a:gridCol w="2682163"/>
+                <a:gridCol w="2682166"/>
+              </a:tblGrid>
+              <a:tr h="969264">
+                <a:tc>
+                  <a:txBody>
+                    <a:bodyPr/>
+                    <a:lstStyle/>
+                    <a:p>
+                      <a:pPr>
+                        <a:defRPr b="1" sz="1100">
+                          <a:solidFill>
+                            <a:srgbClr val="FFFFFF"/>
+                          </a:solidFill>
+                          <a:latin typeface="Arial"/>
+                        </a:defRPr>
+                      </a:pPr>
+                      <a:r>
+                        <a:t>Kịch bản kiểm thử</a:t>
+                      </a:r>
+                    </a:p>
+                  </a:txBody>
+                  <a:tcPr>
+                    <a:solidFill>
+                      <a:srgbClr val="BE123C"/>
+                    </a:solidFill>
+                  </a:tcPr>
+                </a:tc>
+                <a:tc>
+                  <a:txBody>
+                    <a:bodyPr/>
+                    <a:lstStyle/>
+                    <a:p>
+                      <a:pPr>
+                        <a:defRPr b="1" sz="1100">
+                          <a:solidFill>
+                            <a:srgbClr val="FFFFFF"/>
+                          </a:solidFill>
+                          <a:latin typeface="Arial"/>
+                        </a:defRPr>
+                      </a:pPr>
+                      <a:r>
+                        <a:t>Mã độc Payload đưa vào</a:t>
+                      </a:r>
+                    </a:p>
+                  </a:txBody>
+                  <a:tcPr>
+                    <a:solidFill>
+                      <a:srgbClr val="BE123C"/>
+                    </a:solidFill>
+                  </a:tcPr>
+                </a:tc>
+                <a:tc>
+                  <a:txBody>
+                    <a:bodyPr/>
+                    <a:lstStyle/>
+                    <a:p>
+                      <a:pPr>
+                        <a:defRPr b="1" sz="1100">
+                          <a:solidFill>
+                            <a:srgbClr val="FFFFFF"/>
+                          </a:solidFill>
+                          <a:latin typeface="Arial"/>
+                        </a:defRPr>
+                      </a:pPr>
+                      <a:r>
+                        <a:t>Cơ chế kích hoạt trên Trình duyệt</a:t>
+                      </a:r>
+                    </a:p>
+                  </a:txBody>
+                  <a:tcPr>
+                    <a:solidFill>
+                      <a:srgbClr val="BE123C"/>
+                    </a:solidFill>
+                  </a:tcPr>
+                </a:tc>
+                <a:tc>
+                  <a:txBody>
+                    <a:bodyPr/>
+                    <a:lstStyle/>
+                    <a:p>
+                      <a:pPr>
+                        <a:defRPr b="1" sz="1100">
+                          <a:solidFill>
+                            <a:srgbClr val="FFFFFF"/>
+                          </a:solidFill>
+                          <a:latin typeface="Arial"/>
+                        </a:defRPr>
+                      </a:pPr>
+                      <a:r>
+                        <a:t>Mục tiêu khai thác</a:t>
+                      </a:r>
+                    </a:p>
+                  </a:txBody>
+                  <a:tcPr>
+                    <a:solidFill>
+                      <a:srgbClr val="BE123C"/>
+                    </a:solidFill>
+                  </a:tcPr>
+                </a:tc>
+              </a:tr>
+              <a:tr h="969264">
+                <a:tc>
+                  <a:txBody>
+                    <a:bodyPr/>
+                    <a:lstStyle/>
+                    <a:p>
+                      <a:pPr>
+                        <a:defRPr sz="1050">
+                          <a:solidFill>
+                            <a:srgbClr val="0F172A"/>
+                          </a:solidFill>
+                          <a:latin typeface="Arial"/>
+                        </a:defRPr>
+                      </a:pPr>
+                      <a:r>
+                        <a:t>Payload 1: Đánh cắp Cookie</a:t>
+                      </a:r>
+                    </a:p>
+                  </a:txBody>
+                  <a:tcPr>
+                    <a:solidFill>
+                      <a:srgbClr val="F8FAFC"/>
+                    </a:solidFill>
+                  </a:tcPr>
+                </a:tc>
+                <a:tc>
+                  <a:txBody>
+                    <a:bodyPr/>
+                    <a:lstStyle/>
+                    <a:p>
+                      <a:pPr>
+                        <a:defRPr sz="1050" b="1">
+                          <a:solidFill>
+                            <a:srgbClr val="BE123C"/>
+                          </a:solidFill>
+                          <a:latin typeface="Courier New"/>
+                        </a:defRPr>
+                      </a:pPr>
+                      <a:r>
+                        <a:t>&lt;script&gt;alert(document.cookie);&lt;/script&gt;</a:t>
+                      </a:r>
+                    </a:p>
+                  </a:txBody>
+                  <a:tcPr>
+                    <a:solidFill>
+                      <a:srgbClr val="F8FAFC"/>
+                    </a:solidFill>
+                  </a:tcPr>
+                </a:tc>
+                <a:tc>
+                  <a:txBody>
+                    <a:bodyPr/>
+                    <a:lstStyle/>
+                    <a:p>
+                      <a:pPr>
+                        <a:defRPr sz="1050">
+                          <a:solidFill>
+                            <a:srgbClr val="334155"/>
+                          </a:solidFill>
+                          <a:latin typeface="Arial"/>
+                        </a:defRPr>
+                      </a:pPr>
+                      <a:r>
+                        <a:t>Trình duyệt thực thi thẻ &lt;script&gt; và đọc toàn bộ giá trị lưu trong document.cookie.</a:t>
+                      </a:r>
+                    </a:p>
+                  </a:txBody>
+                  <a:tcPr>
+                    <a:solidFill>
+                      <a:srgbClr val="F8FAFC"/>
+                    </a:solidFill>
+                  </a:tcPr>
+                </a:tc>
+                <a:tc>
+                  <a:txBody>
+                    <a:bodyPr/>
+                    <a:lstStyle/>
+                    <a:p>
+                      <a:pPr>
+                        <a:defRPr sz="1050">
+                          <a:solidFill>
+                            <a:srgbClr val="334155"/>
+                          </a:solidFill>
+                          <a:latin typeface="Arial"/>
+                        </a:defRPr>
+                      </a:pPr>
+                      <a:r>
+                        <a:t>Chiếm đoạt Session Token (Cookie Stealing) để mạo danh người dùng.</a:t>
+                      </a:r>
+                    </a:p>
+                  </a:txBody>
+                  <a:tcPr>
+                    <a:solidFill>
+                      <a:srgbClr val="F8FAFC"/>
+                    </a:solidFill>
+                  </a:tcPr>
+                </a:tc>
+              </a:tr>
+              <a:tr h="969264">
+                <a:tc>
+                  <a:txBody>
+                    <a:bodyPr/>
+                    <a:lstStyle/>
+                    <a:p>
+                      <a:pPr>
+                        <a:defRPr sz="1050">
+                          <a:solidFill>
+                            <a:srgbClr val="0F172A"/>
+                          </a:solidFill>
+                          <a:latin typeface="Arial"/>
+                        </a:defRPr>
+                      </a:pPr>
+                      <a:r>
+                        <a:t>Payload 2: Bypass qua thẻ &lt;img&gt;</a:t>
+                      </a:r>
+                    </a:p>
+                  </a:txBody>
+                  <a:tcPr>
+                    <a:solidFill>
+                      <a:srgbClr val="FFFFFF"/>
+                    </a:solidFill>
+                  </a:tcPr>
+                </a:tc>
+                <a:tc>
+                  <a:txBody>
+                    <a:bodyPr/>
+                    <a:lstStyle/>
+                    <a:p>
+                      <a:pPr>
+                        <a:defRPr sz="1050" b="1">
+                          <a:solidFill>
+                            <a:srgbClr val="BE123C"/>
+                          </a:solidFill>
+                          <a:latin typeface="Courier New"/>
+                        </a:defRPr>
+                      </a:pPr>
+                      <a:r>
+                        <a:t>&lt;img src=x onerror=alert('XSS!')&gt;</a:t>
+                      </a:r>
+                    </a:p>
+                  </a:txBody>
+                  <a:tcPr>
+                    <a:solidFill>
+                      <a:srgbClr val="FFFFFF"/>
+                    </a:solidFill>
+                  </a:tcPr>
+                </a:tc>
+                <a:tc>
+                  <a:txBody>
+                    <a:bodyPr/>
+                    <a:lstStyle/>
+                    <a:p>
+                      <a:pPr>
+                        <a:defRPr sz="1050">
+                          <a:solidFill>
+                            <a:srgbClr val="334155"/>
+                          </a:solidFill>
+                          <a:latin typeface="Arial"/>
+                        </a:defRPr>
+                      </a:pPr>
+                      <a:r>
+                        <a:t>Khi đường dẫn ảnh bị lỗi (src=x), trình duyệt lập tức kích hoạt sự kiện onerror.</a:t>
+                      </a:r>
+                    </a:p>
+                  </a:txBody>
+                  <a:tcPr>
+                    <a:solidFill>
+                      <a:srgbClr val="FFFFFF"/>
+                    </a:solidFill>
+                  </a:tcPr>
+                </a:tc>
+                <a:tc>
+                  <a:txBody>
+                    <a:bodyPr/>
+                    <a:lstStyle/>
+                    <a:p>
+                      <a:pPr>
+                        <a:defRPr sz="1050">
+                          <a:solidFill>
+                            <a:srgbClr val="334155"/>
+                          </a:solidFill>
+                          <a:latin typeface="Arial"/>
+                        </a:defRPr>
+                      </a:pPr>
+                      <a:r>
+                        <a:t>Vượt qua các bộ lọc từ khóa đơn giản chỉ chặn chuỗi '&lt;script&gt;'.</a:t>
+                      </a:r>
+                    </a:p>
+                  </a:txBody>
+                  <a:tcPr>
+                    <a:solidFill>
+                      <a:srgbClr val="FFFFFF"/>
+                    </a:solidFill>
+                  </a:tcPr>
+                </a:tc>
+              </a:tr>
+              <a:tr h="969264">
+                <a:tc>
+                  <a:txBody>
+                    <a:bodyPr/>
+                    <a:lstStyle/>
+                    <a:p>
+                      <a:pPr>
+                        <a:defRPr sz="1050">
+                          <a:solidFill>
+                            <a:srgbClr val="0F172A"/>
+                          </a:solidFill>
+                          <a:latin typeface="Arial"/>
+                        </a:defRPr>
+                      </a:pPr>
+                      <a:r>
+                        <a:t>Payload 3: Thay đổi giao diện DOM</a:t>
+                      </a:r>
+                    </a:p>
+                  </a:txBody>
+                  <a:tcPr>
+                    <a:solidFill>
+                      <a:srgbClr val="F8FAFC"/>
+                    </a:solidFill>
+                  </a:tcPr>
+                </a:tc>
+                <a:tc>
+                  <a:txBody>
+                    <a:bodyPr/>
+                    <a:lstStyle/>
+                    <a:p>
+                      <a:pPr>
+                        <a:defRPr sz="1050" b="1">
+                          <a:solidFill>
+                            <a:srgbClr val="BE123C"/>
+                          </a:solidFill>
+                          <a:latin typeface="Courier New"/>
+                        </a:defRPr>
+                      </a:pPr>
+                      <a:r>
+                        <a:t>&lt;script&gt;document.body.innerHTML='...';&lt;/script&gt;</a:t>
+                      </a:r>
+                    </a:p>
+                  </a:txBody>
+                  <a:tcPr>
+                    <a:solidFill>
+                      <a:srgbClr val="F8FAFC"/>
+                    </a:solidFill>
+                  </a:tcPr>
+                </a:tc>
+                <a:tc>
+                  <a:txBody>
+                    <a:bodyPr/>
+                    <a:lstStyle/>
+                    <a:p>
+                      <a:pPr>
+                        <a:defRPr sz="1050">
+                          <a:solidFill>
+                            <a:srgbClr val="334155"/>
+                          </a:solidFill>
+                          <a:latin typeface="Arial"/>
+                        </a:defRPr>
+                      </a:pPr>
+                      <a:r>
+                        <a:t>Ghi đè thuộc tính innerHTML của thẻ body, xóa sạch nội dung gốc của trang.</a:t>
+                      </a:r>
+                    </a:p>
+                  </a:txBody>
+                  <a:tcPr>
+                    <a:solidFill>
+                      <a:srgbClr val="F8FAFC"/>
+                    </a:solidFill>
+                  </a:tcPr>
+                </a:tc>
+                <a:tc>
+                  <a:txBody>
+                    <a:bodyPr/>
+                    <a:lstStyle/>
+                    <a:p>
+                      <a:pPr>
+                        <a:defRPr sz="1050">
+                          <a:solidFill>
+                            <a:srgbClr val="334155"/>
+                          </a:solidFill>
+                          <a:latin typeface="Arial"/>
+                        </a:defRPr>
+                      </a:pPr>
+                      <a:r>
+                        <a:t>Web Defacement: Chèn form đăng nhập giả mạo lừa người dùng (Phishing).</a:t>
+                      </a:r>
+                    </a:p>
+                  </a:txBody>
+                  <a:tcPr>
+                    <a:solidFill>
+                      <a:srgbClr val="F8FAFC"/>
+                    </a:solidFill>
+                  </a:tcPr>
+                </a:tc>
+              </a:tr>
+              <a:tr h="969264">
+                <a:tc>
+                  <a:txBody>
+                    <a:bodyPr/>
+                    <a:lstStyle/>
+                    <a:p>
+                      <a:pPr>
+                        <a:defRPr sz="1050">
+                          <a:solidFill>
+                            <a:srgbClr val="0F172A"/>
+                          </a:solidFill>
+                          <a:latin typeface="Arial"/>
+                        </a:defRPr>
+                      </a:pPr>
+                      <a:r>
+                        <a:t>Bình luận hợp lệ chuẩn</a:t>
+                      </a:r>
+                    </a:p>
+                  </a:txBody>
+                  <a:tcPr>
+                    <a:solidFill>
+                      <a:srgbClr val="FFFFFF"/>
+                    </a:solidFill>
+                  </a:tcPr>
+                </a:tc>
+                <a:tc>
+                  <a:txBody>
+                    <a:bodyPr/>
+                    <a:lstStyle/>
+                    <a:p>
+                      <a:pPr>
+                        <a:defRPr sz="1050" b="1">
+                          <a:solidFill>
+                            <a:srgbClr val="047857"/>
+                          </a:solidFill>
+                          <a:latin typeface="Courier New"/>
+                        </a:defRPr>
+                      </a:pPr>
+                      <a:r>
+                        <a:t>Dịch vụ tư vấn rất chuyên nghiệp, 5 sao!</a:t>
+                      </a:r>
+                    </a:p>
+                  </a:txBody>
+                  <a:tcPr>
+                    <a:solidFill>
+                      <a:srgbClr val="FFFFFF"/>
+                    </a:solidFill>
+                  </a:tcPr>
+                </a:tc>
+                <a:tc>
+                  <a:txBody>
+                    <a:bodyPr/>
+                    <a:lstStyle/>
+                    <a:p>
+                      <a:pPr>
+                        <a:defRPr sz="1050">
+                          <a:solidFill>
+                            <a:srgbClr val="334155"/>
+                          </a:solidFill>
+                          <a:latin typeface="Arial"/>
+                        </a:defRPr>
+                      </a:pPr>
+                      <a:r>
+                        <a:t>Văn bản thuần túy không chứa thẻ HTML đặc biệt.</a:t>
+                      </a:r>
+                    </a:p>
+                  </a:txBody>
+                  <a:tcPr>
+                    <a:solidFill>
+                      <a:srgbClr val="FFFFFF"/>
+                    </a:solidFill>
+                  </a:tcPr>
+                </a:tc>
+                <a:tc>
+                  <a:txBody>
+                    <a:bodyPr/>
+                    <a:lstStyle/>
+                    <a:p>
+                      <a:pPr>
+                        <a:defRPr sz="1050">
+                          <a:solidFill>
+                            <a:srgbClr val="334155"/>
+                          </a:solidFill>
+                          <a:latin typeface="Arial"/>
+                        </a:defRPr>
+                      </a:pPr>
+                      <a:r>
+                        <a:t>Hiển thị bình thường trên cả 2 nhánh (Lỗi &amp; Đã phòng thủ).</a:t>
+                      </a:r>
+                    </a:p>
+                  </a:txBody>
+                  <a:tcPr>
+                    <a:solidFill>
+                      <a:srgbClr val="FFFFFF"/>
+                    </a:solidFill>
+                  </a:tcPr>
+                </a:tc>
+              </a:tr>
+            </a:tbl>
+          </a:graphicData>
+        </a:graphic>
+      </p:graphicFrame>
     </p:spTree>
   </p:cSld>
   <p:clrMapOvr>

</xml_diff>

<commit_message>
feat: complete professional 19-slide presentation v3 following 43-point senior security designer review
</commit_message>
<xml_diff>
--- a/Slide_OWASP_Top3_Nhom_WNC_G01.pptx
+++ b/Slide_OWASP_Top3_Nhom_WNC_G01.pptx
@@ -3151,24 +3151,112 @@
       </p:sp>
       <p:sp>
         <p:nvSpPr>
-          <p:cNvPr id="3" name="Rounded Rectangle 2"/>
+          <p:cNvPr id="3" name="TextBox 2"/>
+          <p:cNvSpPr txBox="1"/>
+          <p:nvPr/>
+        </p:nvSpPr>
+        <p:spPr>
+          <a:xfrm>
+            <a:off x="914400" y="731520"/>
+            <a:ext cx="6217920" cy="3291840"/>
+          </a:xfrm>
+          <a:prstGeom prst="rect">
+            <a:avLst/>
+          </a:prstGeom>
+          <a:noFill/>
+        </p:spPr>
+        <p:txBody>
+          <a:bodyPr wrap="square">
+            <a:spAutoFit/>
+          </a:bodyPr>
+          <a:lstStyle/>
+          <a:p>
+            <a:pPr>
+              <a:defRPr sz="1300" b="1">
+                <a:solidFill>
+                  <a:srgbClr val="1D4ED8"/>
+                </a:solidFill>
+                <a:latin typeface="Arial"/>
+              </a:defRPr>
+            </a:pPr>
+            <a:r>
+              <a:t>OWASP TOP 10 • THỰC NGHIỆM AN TOÀN WEB</a:t>
+            </a:r>
+          </a:p>
+          <a:p>
+            <a:pPr>
+              <a:spcBef>
+                <a:spcPts val="800"/>
+              </a:spcBef>
+              <a:defRPr sz="2600" b="1">
+                <a:solidFill>
+                  <a:srgbClr val="0F172A"/>
+                </a:solidFill>
+                <a:latin typeface="Arial"/>
+              </a:defRPr>
+            </a:pPr>
+            <a:r>
+              <a:t>Nghiên Cứu Lỗ Hổng Web &amp; Cơ Chế Phòng Thủ Đa Tầng</a:t>
+            </a:r>
+          </a:p>
+          <a:p>
+            <a:pPr>
+              <a:spcBef>
+                <a:spcPts val="600"/>
+              </a:spcBef>
+              <a:defRPr sz="1600" b="1">
+                <a:solidFill>
+                  <a:srgbClr val="BE123C"/>
+                </a:solidFill>
+                <a:latin typeface="Arial"/>
+              </a:defRPr>
+            </a:pPr>
+            <a:r>
+              <a:t>SQL Injection • Stored XSS • CSRF Attack</a:t>
+            </a:r>
+          </a:p>
+          <a:p>
+            <a:pPr>
+              <a:spcBef>
+                <a:spcPts val="1000"/>
+              </a:spcBef>
+              <a:defRPr sz="1200" b="0">
+                <a:solidFill>
+                  <a:srgbClr val="334155"/>
+                </a:solidFill>
+                <a:latin typeface="Arial"/>
+              </a:defRPr>
+            </a:pPr>
+            <a:r>
+              <a:t>Học phần: Lập trình Web nâng cao  •  GVHD: ThS. Lê Hữu Dũng</a:t>
+            </a:r>
+            <a:br/>
+            <a:r>
+              <a:t>Khoa Công nghệ Thông tin — Trường Đại học Mở Hà Nội (HOU)</a:t>
+            </a:r>
+          </a:p>
+        </p:txBody>
+      </p:sp>
+      <p:sp>
+        <p:nvSpPr>
+          <p:cNvPr id="4" name="Rounded Rectangle 3"/>
           <p:cNvSpPr/>
           <p:nvPr/>
         </p:nvSpPr>
         <p:spPr>
           <a:xfrm>
-            <a:off x="914400" y="640080"/>
-            <a:ext cx="5303520" cy="384048"/>
+            <a:off x="7406640" y="731520"/>
+            <a:ext cx="3840480" cy="3291840"/>
           </a:xfrm>
           <a:prstGeom prst="roundRect">
             <a:avLst/>
           </a:prstGeom>
           <a:solidFill>
-            <a:srgbClr val="EFF6FF"/>
+            <a:srgbClr val="F8FAFC"/>
           </a:solidFill>
           <a:ln>
             <a:solidFill>
-              <a:srgbClr val="BFDBFE"/>
+              <a:srgbClr val="E2E8F0"/>
             </a:solidFill>
           </a:ln>
         </p:spPr>
@@ -3187,11 +3275,11 @@
           </a:fontRef>
         </p:style>
         <p:txBody>
-          <a:bodyPr rtlCol="0" anchor="ctr"/>
+          <a:bodyPr rtlCol="0" anchor="ctr" wrap="square"/>
           <a:lstStyle/>
           <a:p>
             <a:pPr algn="ctr">
-              <a:defRPr sz="1050" b="1">
+              <a:defRPr sz="1200" b="1">
                 <a:solidFill>
                   <a:srgbClr val="1D4ED8"/>
                 </a:solidFill>
@@ -3199,43 +3287,7 @@
               </a:defRPr>
             </a:pPr>
             <a:r>
-              <a:t>TRƯỜNG ĐẠI HỌC MỞ HÀ NỘI — KHOA CÔNG NGHỆ THÔNG TIN</a:t>
-            </a:r>
-          </a:p>
-        </p:txBody>
-      </p:sp>
-      <p:sp>
-        <p:nvSpPr>
-          <p:cNvPr id="4" name="TextBox 3"/>
-          <p:cNvSpPr txBox="1"/>
-          <p:nvPr/>
-        </p:nvSpPr>
-        <p:spPr>
-          <a:xfrm>
-            <a:off x="914400" y="1143000"/>
-            <a:ext cx="10362895" cy="2926080"/>
-          </a:xfrm>
-          <a:prstGeom prst="rect">
-            <a:avLst/>
-          </a:prstGeom>
-          <a:noFill/>
-        </p:spPr>
-        <p:txBody>
-          <a:bodyPr wrap="square">
-            <a:spAutoFit/>
-          </a:bodyPr>
-          <a:lstStyle/>
-          <a:p>
-            <a:pPr>
-              <a:defRPr sz="1500" b="1">
-                <a:solidFill>
-                  <a:srgbClr val="BE123C"/>
-                </a:solidFill>
-                <a:latin typeface="Arial"/>
-              </a:defRPr>
-            </a:pPr>
-            <a:r>
-              <a:t>BÁO CÁO THỰC NGHIỆM AN TOÀN WEB (OWASP TOP 10)</a:t>
+              <a:t>MÔ HÌNH 3 TẦNG &amp; 3 ĐIỂM NGUY CƠ</a:t>
             </a:r>
           </a:p>
           <a:p>
@@ -3243,7 +3295,7 @@
               <a:spcBef>
                 <a:spcPts val="800"/>
               </a:spcBef>
-              <a:defRPr sz="2700" b="1">
+              <a:defRPr sz="1100" b="1">
                 <a:solidFill>
                   <a:srgbClr val="0F172A"/>
                 </a:solidFill>
@@ -3251,11 +3303,23 @@
               </a:defRPr>
             </a:pPr>
             <a:r>
-              <a:t>SQL Injection • Stored XSS • CSRF Attack</a:t>
-            </a:r>
-            <a:br/>
-            <a:r>
-              <a:t>Nghiên Cứu Lỗ Hổng — Thực Nghiệm — Cơ Chế Phòng Thủ</a:t>
+              <a:t>1. Browser / Client DOM</a:t>
+            </a:r>
+          </a:p>
+          <a:p>
+            <a:pPr>
+              <a:spcBef>
+                <a:spcPts val="200"/>
+              </a:spcBef>
+              <a:defRPr sz="1050" b="0">
+                <a:solidFill>
+                  <a:srgbClr val="BE123C"/>
+                </a:solidFill>
+                <a:latin typeface="Arial"/>
+              </a:defRPr>
+            </a:pPr>
+            <a:r>
+              <a:t>   ➔ ⚠️ Nguy cơ: Stored XSS (Đánh cắp Cookie)</a:t>
             </a:r>
           </a:p>
           <a:p>
@@ -3263,15 +3327,63 @@
               <a:spcBef>
                 <a:spcPts val="800"/>
               </a:spcBef>
-              <a:defRPr sz="1350" b="0">
-                <a:solidFill>
-                  <a:srgbClr val="334155"/>
-                </a:solidFill>
-                <a:latin typeface="Arial"/>
-              </a:defRPr>
-            </a:pPr>
-            <a:r>
-              <a:t>Học phần: Lập trình Web nâng cao  •  Giảng viên hướng dẫn: ThS. Lê Hữu Dũng</a:t>
+              <a:defRPr sz="1100" b="1">
+                <a:solidFill>
+                  <a:srgbClr val="0F172A"/>
+                </a:solidFill>
+                <a:latin typeface="Arial"/>
+              </a:defRPr>
+            </a:pPr>
+            <a:r>
+              <a:t>2. Web Server (ASP.NET Core)</a:t>
+            </a:r>
+          </a:p>
+          <a:p>
+            <a:pPr>
+              <a:spcBef>
+                <a:spcPts val="200"/>
+              </a:spcBef>
+              <a:defRPr sz="1050" b="0">
+                <a:solidFill>
+                  <a:srgbClr val="BE123C"/>
+                </a:solidFill>
+                <a:latin typeface="Arial"/>
+              </a:defRPr>
+            </a:pPr>
+            <a:r>
+              <a:t>   ➔ ⚠️ Nguy cơ: CSRF (Mượn quyền giao dịch)</a:t>
+            </a:r>
+          </a:p>
+          <a:p>
+            <a:pPr>
+              <a:spcBef>
+                <a:spcPts val="800"/>
+              </a:spcBef>
+              <a:defRPr sz="1100" b="1">
+                <a:solidFill>
+                  <a:srgbClr val="0F172A"/>
+                </a:solidFill>
+                <a:latin typeface="Arial"/>
+              </a:defRPr>
+            </a:pPr>
+            <a:r>
+              <a:t>3. Database Server (SQL Server 2025)</a:t>
+            </a:r>
+          </a:p>
+          <a:p>
+            <a:pPr>
+              <a:spcBef>
+                <a:spcPts val="200"/>
+              </a:spcBef>
+              <a:defRPr sz="1050" b="0">
+                <a:solidFill>
+                  <a:srgbClr val="BE123C"/>
+                </a:solidFill>
+                <a:latin typeface="Arial"/>
+              </a:defRPr>
+            </a:pPr>
+            <a:r>
+              <a:t>   ➔ ⚠️ Nguy cơ: SQL Injection (Bẻ gãy cú pháp)</a:t>
             </a:r>
           </a:p>
         </p:txBody>
@@ -3660,7 +3772,7 @@
               </a:defRPr>
             </a:pPr>
             <a:r>
-              <a:t>2.3. Stored XSS: Minh Chứng Thực Nghiệm Trực Quan Trên Web UI</a:t>
+              <a:t>2.3. Stored XSS — Minh Chứng Thực Nghiệm Trực Quan Trên Web UI</a:t>
             </a:r>
           </a:p>
         </p:txBody>
@@ -3756,7 +3868,7 @@
               </a:defRPr>
             </a:pPr>
             <a:r>
-              <a:t>Minh chứng đối chứng chức năng Đánh giá: Nhánh dính lỗi kích hoạt popup Alert (Trái) vs Nhánh an toàn mã hóa HTML (Phải)</a:t>
+              <a:t>🔴 Vulnerable: Script lưu CSDL tự động bật popup Alert  vs  🟢 Secure: Razor tự động mã hóa HTML thành chữ an toàn</a:t>
             </a:r>
           </a:p>
         </p:txBody>
@@ -3908,7 +4020,7 @@
               </a:defRPr>
             </a:pPr>
             <a:r>
-              <a:t>2.4. Stored XSS: Minh Chứng Kiểm Thử Qua Chrome DevTools (Cookie &amp; Console)</a:t>
+              <a:t>2.4. Stored XSS — Minh Chứng Kiểm Thử Qua Chrome DevTools (Cookie &amp; Console)</a:t>
             </a:r>
           </a:p>
         </p:txBody>
@@ -4004,7 +4116,7 @@
               </a:defRPr>
             </a:pPr>
             <a:r>
-              <a:t>Mô phỏng Lab: Nhánh vulnerable cấu hình HttpOnly = false để chứng minh JavaScript đọc trộm được Session Cookie</a:t>
+              <a:t>Mô phỏng Lab: Nhánh vulnerable cấu hình HttpOnly = false để minh họa JavaScript đọc trộm Session Cookie</a:t>
             </a:r>
           </a:p>
         </p:txBody>
@@ -4156,7 +4268,7 @@
               </a:defRPr>
             </a:pPr>
             <a:r>
-              <a:t>2.5. Stored XSS: Cơ Chế Phòng Thủ Chuẩn Trong ASP.NET Core</a:t>
+              <a:t>2.5. Stored XSS — Cơ Chế Phòng Thủ Chuẩn Trong ASP.NET Core</a:t>
             </a:r>
           </a:p>
         </p:txBody>
@@ -4239,7 +4351,7 @@
           <a:lstStyle/>
           <a:p>
             <a:pPr algn="ctr">
-              <a:defRPr sz="1500" b="1">
+              <a:defRPr sz="1400" b="1">
                 <a:solidFill>
                   <a:srgbClr val="047857"/>
                 </a:solidFill>
@@ -4247,7 +4359,7 @@
               </a:defRPr>
             </a:pPr>
             <a:r>
-              <a:t>Phòng Thủ Tầng View: Context-Aware Encoding</a:t>
+              <a:t>🟢 SECURE: TỰ ĐỘNG HTML ENCODING</a:t>
             </a:r>
           </a:p>
           <a:p>
@@ -4296,19 +4408,19 @@
               </a:defRPr>
             </a:pPr>
             <a:r>
-              <a:t>Cơ chế chuyển đổi thực thể HTML:</a:t>
-            </a:r>
-            <a:br/>
-            <a:r>
-              <a:t>• Ký tự '&lt;' biến đổi thành &amp;lt;</a:t>
-            </a:r>
-            <a:br/>
-            <a:r>
-              <a:t>• Ký tự '&gt;' biến đổi thành &amp;gt;</a:t>
-            </a:r>
-            <a:br/>
-            <a:r>
-              <a:t>Trình duyệt hiển thị dưới dạng văn bản thuần túy, loại bỏ hoàn toàn khả năng thực thi mã kịch bản.</a:t>
+              <a:t>Cơ chế biến đổi ký tự nhạy cảm:</a:t>
+            </a:r>
+            <a:br/>
+            <a:r>
+              <a:t>• '&lt;' biến đổi thành &amp;lt;</a:t>
+            </a:r>
+            <a:br/>
+            <a:r>
+              <a:t>• '&gt;' biến đổi thành &amp;gt;</a:t>
+            </a:r>
+            <a:br/>
+            <a:r>
+              <a:t>Trình duyệt chỉ hiển thị dưới dạng văn bản thuần, không thực thi script.</a:t>
             </a:r>
           </a:p>
         </p:txBody>
@@ -4355,7 +4467,7 @@
           <a:lstStyle/>
           <a:p>
             <a:pPr algn="ctr">
-              <a:defRPr sz="1500" b="1">
+              <a:defRPr sz="1400" b="1">
                 <a:solidFill>
                   <a:srgbClr val="1D4ED8"/>
                 </a:solidFill>
@@ -4363,13 +4475,13 @@
               </a:defRPr>
             </a:pPr>
             <a:r>
-              <a:t>Phòng Thủ Tầng Cookie &amp; Header (Khuyến Nghị)</a:t>
+              <a:t>CẤU HÌNH COOKIE AN TOÀN (PRODUCTION)</a:t>
             </a:r>
           </a:p>
           <a:p>
             <a:pPr>
               <a:spcBef>
-                <a:spcPts val="600"/>
+                <a:spcPts val="800"/>
               </a:spcBef>
               <a:defRPr sz="1000" b="0">
                 <a:solidFill>
@@ -4379,7 +4491,7 @@
               </a:defRPr>
             </a:pPr>
             <a:r>
-              <a:t>// CẤU HÌNH COOKIE AN TOÀN TRONG SẢN PHẨM THẬT:</a:t>
+              <a:t>// BẢO VỆ COOKIE PHIÊN TRONG SẢN PHẨM THỰC TẾ:</a:t>
             </a:r>
             <a:br/>
             <a:r>
@@ -4409,7 +4521,7 @@
           <a:p>
             <a:pPr>
               <a:spcBef>
-                <a:spcPts val="1000"/>
+                <a:spcPts val="1200"/>
               </a:spcBef>
               <a:defRPr sz="1200" b="0">
                 <a:solidFill>
@@ -4419,11 +4531,11 @@
               </a:defRPr>
             </a:pPr>
             <a:r>
-              <a:t>Chính sách Content Security Policy (CSP Header):</a:t>
-            </a:r>
-            <a:br/>
-            <a:r>
-              <a:t>Thiết lập HTTP Header 'script-src self' ngăn cấm trình duyệt thực thi inline script, tạo thêm lớp bảo vệ vững chắc ngay cả khi có sơ hở ở tầng View.</a:t>
+              <a:t>Chính sách CSP (Content Security Policy):</a:t>
+            </a:r>
+            <a:br/>
+            <a:r>
+              <a:t>Cấu hình HTTP Header 'script-src self' ngăn chặn trình duyệt chạy inline script lạ, tạo thêm lớp bảo vệ kiên cố.</a:t>
             </a:r>
           </a:p>
         </p:txBody>
@@ -4575,7 +4687,7 @@
               </a:defRPr>
             </a:pPr>
             <a:r>
-              <a:t>3.1. CSRF Attack: Bản Chất Kỹ Thuật &amp; Phân Loại OWASP</a:t>
+              <a:t>3.1. CSRF Attack — Cơ Chế Mượn Quyền &amp; Phân Loại Chuẩn OWASP</a:t>
             </a:r>
           </a:p>
         </p:txBody>
@@ -4666,7 +4778,7 @@
               </a:defRPr>
             </a:pPr>
             <a:r>
-              <a:t>Bản Chất Kỹ Thuật Của Tấn Công CSRF</a:t>
+              <a:t>Sơ Đồ Luồng Tấn Công Mượn Quyền (CSRF)</a:t>
             </a:r>
           </a:p>
           <a:p>
@@ -4674,7 +4786,43 @@
               <a:spcBef>
                 <a:spcPts val="800"/>
               </a:spcBef>
-              <a:defRPr sz="1250" b="1">
+              <a:defRPr sz="1200" b="1">
+                <a:solidFill>
+                  <a:srgbClr val="0F172A"/>
+                </a:solidFill>
+                <a:latin typeface="Arial"/>
+              </a:defRPr>
+            </a:pPr>
+            <a:r>
+              <a:t>Victim logged in ➔ Đang có Cookie phiên làm việc hợp lệ</a:t>
+            </a:r>
+          </a:p>
+          <a:p>
+            <a:pPr>
+              <a:spcBef>
+                <a:spcPts val="200"/>
+              </a:spcBef>
+              <a:defRPr sz="1200" b="1">
+                <a:solidFill>
+                  <a:srgbClr val="64748B"/>
+                </a:solidFill>
+                <a:latin typeface="Arial"/>
+              </a:defRPr>
+            </a:pPr>
+            <a:r>
+              <a:t>            │</a:t>
+            </a:r>
+            <a:br/>
+            <a:r>
+              <a:t>            ▼</a:t>
+            </a:r>
+          </a:p>
+          <a:p>
+            <a:pPr>
+              <a:spcBef>
+                <a:spcPts val="200"/>
+              </a:spcBef>
+              <a:defRPr sz="1200" b="1">
                 <a:solidFill>
                   <a:srgbClr val="BE123C"/>
                 </a:solidFill>
@@ -4682,10 +4830,47 @@
               </a:defRPr>
             </a:pPr>
             <a:r>
-              <a:t>• Phân loại chuẩn OWASP: CSRF không phải một mục riêng lẻ trong OWASP Top 10 2021; nó liên quan trực tiếp đến A01:2021 – Broken Access Control và cơ chế xác thực phiên.</a:t>
-            </a:r>
-          </a:p>
-          <a:p>
+              <a:t>Mở Attacker Site ➔ Trang web độc hại kích hoạt POST ngầm</a:t>
+            </a:r>
+          </a:p>
+          <a:p>
+            <a:pPr>
+              <a:spcBef>
+                <a:spcPts val="200"/>
+              </a:spcBef>
+              <a:defRPr sz="1200" b="1">
+                <a:solidFill>
+                  <a:srgbClr val="64748B"/>
+                </a:solidFill>
+                <a:latin typeface="Arial"/>
+              </a:defRPr>
+            </a:pPr>
+            <a:r>
+              <a:t>            │</a:t>
+            </a:r>
+            <a:br/>
+            <a:r>
+              <a:t>            ▼</a:t>
+            </a:r>
+          </a:p>
+          <a:p>
+            <a:pPr>
+              <a:spcBef>
+                <a:spcPts val="200"/>
+              </a:spcBef>
+              <a:defRPr sz="1200" b="1">
+                <a:solidFill>
+                  <a:srgbClr val="BE123C"/>
+                </a:solidFill>
+                <a:latin typeface="Arial"/>
+              </a:defRPr>
+            </a:pPr>
+            <a:r>
+              <a:t>Target Server ➔ Tự động nhận Cookie, thực hiện trừ 20 triệu</a:t>
+            </a:r>
+          </a:p>
+          <a:p>
+            <a:br/>
             <a:pPr>
               <a:spcBef>
                 <a:spcPts val="800"/>
@@ -4698,23 +4883,11 @@
               </a:defRPr>
             </a:pPr>
             <a:r>
-              <a:t>• Cơ chế mượn quyền:</a:t>
-            </a:r>
-            <a:br/>
-            <a:r>
-              <a:t>  1. Nạn nhân có phiên làm việc hợp lệ (Cookie xác thực còn hiệu lực trên trình duyệt).</a:t>
-            </a:r>
-            <a:br/>
-            <a:r>
-              <a:t>  2. Trình duyệt tự động đính kèm Cookie xác thực theo mọi HTTP Request gửi tới ứng dụng mục tiêu.</a:t>
-            </a:r>
-            <a:br/>
-            <a:r>
-              <a:t>  3. Kẻ tấn công lừa nạn nhân truy cập một trang web nguồn gốc chéo (Cross-Origin Attacker Site).</a:t>
-            </a:r>
-            <a:br/>
-            <a:r>
-              <a:t>• Điểm mù: Máy chủ chỉ xác thực Cookie mà không kiểm tra nguồn gốc phát sinh Request.</a:t>
+              <a:t>📌 PHÂN LOẠI CHUẨN OWASP:</a:t>
+            </a:r>
+            <a:br/>
+            <a:r>
+              <a:t>CSRF không phải mục độc lập trong OWASP Top 10 2021; nó liên quan trực tiếp đến A01:2021 – Broken Access Control và cơ chế bảo toàn yêu cầu phiên.</a:t>
             </a:r>
           </a:p>
         </p:txBody>
@@ -4761,7 +4934,7 @@
           <a:lstStyle/>
           <a:p>
             <a:pPr algn="ctr">
-              <a:defRPr sz="1500" b="1">
+              <a:defRPr sz="1400" b="1">
                 <a:solidFill>
                   <a:srgbClr val="BE123C"/>
                 </a:solidFill>
@@ -4769,7 +4942,7 @@
               </a:defRPr>
             </a:pPr>
             <a:r>
-              <a:t>Action Xử Lý Giao Dịch Thiếu Kiểm Soát</a:t>
+              <a:t>🔴 VULNERABLE: ACTION THIẾU TOKEN</a:t>
             </a:r>
           </a:p>
           <a:p>
@@ -4845,7 +5018,11 @@
               </a:defRPr>
             </a:pPr>
             <a:r>
-              <a:t>Khi Action thiếu thuộc tính [ValidateAntiForgeryToken], yêu cầu POST bắt nguồn từ một website khác vẫn được thực thi do trình duyệt tự động kẹp theo Cookie của nạn nhân.</a:t>
+              <a:t>Điểm mù kiểm soát:</a:t>
+            </a:r>
+            <a:br/>
+            <a:r>
+              <a:t>Action thiếu [ValidateAntiForgeryToken], máy chủ chỉ kiểm tra Cookie hợp lệ rồi trừ tiền ngay mà không xác minh yêu cầu xuất phát từ đâu!</a:t>
             </a:r>
           </a:p>
         </p:txBody>
@@ -4997,7 +5174,7 @@
               </a:defRPr>
             </a:pPr>
             <a:r>
-              <a:t>3.2. CSRF Attack: Kịch Bản Khai Thác Qua Biểu Mẫu Ẩn</a:t>
+              <a:t>3.2. CSRF Attack — Kịch Bản Khai Thác Qua Biểu Mẫu Ẩn</a:t>
             </a:r>
           </a:p>
         </p:txBody>
@@ -5160,7 +5337,7 @@
               </a:defRPr>
             </a:pPr>
             <a:r>
-              <a:t>Hậu quả thực tế: Giao dịch chuyển tiền được thực thi hoàn toàn tự động mà không có sự đồng thuận chủ động của người dùng, làm thay đổi số dư ví tài khoản.</a:t>
+              <a:t>Hậu quả thực tế: Giao dịch chuyển tiền được thực thi hoàn toàn tự động mà không có sự đồng thuận chủ động của người dùng, dẫn đến thay đổi số dư ví tài khoản.</a:t>
             </a:r>
           </a:p>
         </p:txBody>
@@ -5312,7 +5489,7 @@
               </a:defRPr>
             </a:pPr>
             <a:r>
-              <a:t>3.3. CSRF Attack: Minh Chứng Thực Nghiệm Trực Quan Trên Web UI</a:t>
+              <a:t>3.3. CSRF Attack — Minh Chứng Thực Nghiệm Trực Quan Trên Web UI</a:t>
             </a:r>
           </a:p>
         </p:txBody>
@@ -5560,7 +5737,7 @@
               </a:defRPr>
             </a:pPr>
             <a:r>
-              <a:t>3.4. CSRF Attack: Minh Chứng Gói Tin Mạng (Chrome DevTools Headers)</a:t>
+              <a:t>3.4. CSRF Attack — Minh Chứng Gói Tin Mạng (Chrome DevTools Headers)</a:t>
             </a:r>
           </a:p>
         </p:txBody>
@@ -5808,7 +5985,7 @@
               </a:defRPr>
             </a:pPr>
             <a:r>
-              <a:t>3.5. CSRF Attack: Cơ Chế Phòng Thủ Bằng Anti-Forgery Token</a:t>
+              <a:t>3.5. CSRF Attack — Cơ Chế Phòng Thủ Bằng Anti-Forgery Token</a:t>
             </a:r>
           </a:p>
         </p:txBody>
@@ -5891,7 +6068,7 @@
           <a:lstStyle/>
           <a:p>
             <a:pPr algn="ctr">
-              <a:defRPr sz="1500" b="1">
+              <a:defRPr sz="1400" b="1">
                 <a:solidFill>
                   <a:srgbClr val="047857"/>
                 </a:solidFill>
@@ -5899,13 +6076,13 @@
               </a:defRPr>
             </a:pPr>
             <a:r>
-              <a:t>Mô Hình Synchronizer Token Pattern</a:t>
+              <a:t>🟢 SECURE: SYNCHRONIZER TOKEN PATTERN</a:t>
             </a:r>
           </a:p>
           <a:p>
             <a:pPr>
               <a:spcBef>
-                <a:spcPts val="800"/>
+                <a:spcPts val="600"/>
               </a:spcBef>
               <a:defRPr sz="950" b="0">
                 <a:solidFill>
@@ -5970,7 +6147,7 @@
           <a:p>
             <a:pPr>
               <a:spcBef>
-                <a:spcPts val="800"/>
+                <a:spcPts val="600"/>
               </a:spcBef>
               <a:defRPr sz="1150" b="0">
                 <a:solidFill>
@@ -5984,7 +6161,7 @@
             </a:r>
             <a:br/>
             <a:r>
-              <a:t>Máy chủ phát hành một cặp token: một lưu trong Cookie và một nhúng vào biểu mẫu. Trang web độc hại bị chặn đọc token bởi chính sách Same-Origin Policy (SOP).</a:t>
+              <a:t>Trang web của hacker ở tên miền khác bị chặn đọc token bí mật bởi chính sách Same-Origin Policy (SOP). Mọi request thiếu token đều bị chặn đứng.</a:t>
             </a:r>
           </a:p>
         </p:txBody>
@@ -6031,7 +6208,7 @@
           <a:lstStyle/>
           <a:p>
             <a:pPr algn="ctr">
-              <a:defRPr sz="1500" b="1">
+              <a:defRPr sz="1400" b="1">
                 <a:solidFill>
                   <a:srgbClr val="1D4ED8"/>
                 </a:solidFill>
@@ -6039,13 +6216,13 @@
               </a:defRPr>
             </a:pPr>
             <a:r>
-              <a:t>Tích Hợp Token Trong Fetch API (Slide Buổi 9)</a:t>
+              <a:t>TÍCH HỢP TOKEN TRONG AJAX FETCH API</a:t>
             </a:r>
           </a:p>
           <a:p>
             <a:pPr>
               <a:spcBef>
-                <a:spcPts val="800"/>
+                <a:spcPts val="600"/>
               </a:spcBef>
               <a:defRPr sz="950" b="0">
                 <a:solidFill>
@@ -6102,7 +6279,7 @@
           <a:p>
             <a:pPr>
               <a:spcBef>
-                <a:spcPts val="800"/>
+                <a:spcPts val="600"/>
               </a:spcBef>
               <a:defRPr sz="1150" b="0">
                 <a:solidFill>
@@ -6268,7 +6445,7 @@
               </a:defRPr>
             </a:pPr>
             <a:r>
-              <a:t>Tổng Kết: Bài Học Kỹ Thuật &amp; Bảng Đối Chiếu Phòng Thủ</a:t>
+              <a:t>Bài Học Rút Ra: Bảng Đối Chiếu 3 Lỗ Hổng &amp; Cơ Chế Phòng Thủ</a:t>
             </a:r>
           </a:p>
         </p:txBody>
@@ -6309,450 +6486,498 @@
           </a:p>
         </p:txBody>
       </p:sp>
-      <p:graphicFrame>
-        <p:nvGraphicFramePr>
-          <p:cNvPr id="6" name="Table 5"/>
-          <p:cNvGraphicFramePr>
-            <a:graphicFrameLocks noGrp="1"/>
-          </p:cNvGraphicFramePr>
-          <p:nvPr/>
-        </p:nvGraphicFramePr>
-        <p:xfrm>
-          <a:off x="731520" y="1371600"/>
-          <a:ext cx="10728655" cy="4754880"/>
-        </p:xfrm>
-        <a:graphic>
-          <a:graphicData uri="http://schemas.openxmlformats.org/drawingml/2006/table">
-            <a:tbl>
-              <a:tblPr firstRow="1" bandRow="1">
-                <a:tableStyleId>{5C22544A-7EE6-4342-B048-85BDC9FD1C3A}</a:tableStyleId>
-              </a:tblPr>
-              <a:tblGrid>
-                <a:gridCol w="2682163"/>
-                <a:gridCol w="2682163"/>
-                <a:gridCol w="2682163"/>
-                <a:gridCol w="2682166"/>
-              </a:tblGrid>
-              <a:tr h="1188720">
-                <a:tc>
-                  <a:txBody>
-                    <a:bodyPr/>
-                    <a:lstStyle/>
-                    <a:p>
-                      <a:pPr>
-                        <a:defRPr b="1" sz="1200">
-                          <a:solidFill>
-                            <a:srgbClr val="FFFFFF"/>
-                          </a:solidFill>
-                          <a:latin typeface="Arial"/>
-                        </a:defRPr>
-                      </a:pPr>
-                      <a:r>
-                        <a:t>Lỗ hổng an ninh</a:t>
-                      </a:r>
-                    </a:p>
-                  </a:txBody>
-                  <a:tcPr>
-                    <a:solidFill>
-                      <a:srgbClr val="1D4ED8"/>
-                    </a:solidFill>
-                  </a:tcPr>
-                </a:tc>
-                <a:tc>
-                  <a:txBody>
-                    <a:bodyPr/>
-                    <a:lstStyle/>
-                    <a:p>
-                      <a:pPr>
-                        <a:defRPr b="1" sz="1200">
-                          <a:solidFill>
-                            <a:srgbClr val="FFFFFF"/>
-                          </a:solidFill>
-                          <a:latin typeface="Arial"/>
-                        </a:defRPr>
-                      </a:pPr>
-                      <a:r>
-                        <a:t>Nguyên nhân cốt lõi</a:t>
-                      </a:r>
-                    </a:p>
-                  </a:txBody>
-                  <a:tcPr>
-                    <a:solidFill>
-                      <a:srgbClr val="1D4ED8"/>
-                    </a:solidFill>
-                  </a:tcPr>
-                </a:tc>
-                <a:tc>
-                  <a:txBody>
-                    <a:bodyPr/>
-                    <a:lstStyle/>
-                    <a:p>
-                      <a:pPr>
-                        <a:defRPr b="1" sz="1200">
-                          <a:solidFill>
-                            <a:srgbClr val="FFFFFF"/>
-                          </a:solidFill>
-                          <a:latin typeface="Arial"/>
-                        </a:defRPr>
-                      </a:pPr>
-                      <a:r>
-                        <a:t>Cơ chế phòng thủ chuẩn</a:t>
-                      </a:r>
-                    </a:p>
-                  </a:txBody>
-                  <a:tcPr>
-                    <a:solidFill>
-                      <a:srgbClr val="1D4ED8"/>
-                    </a:solidFill>
-                  </a:tcPr>
-                </a:tc>
-                <a:tc>
-                  <a:txBody>
-                    <a:bodyPr/>
-                    <a:lstStyle/>
-                    <a:p>
-                      <a:pPr>
-                        <a:defRPr b="1" sz="1200">
-                          <a:solidFill>
-                            <a:srgbClr val="FFFFFF"/>
-                          </a:solidFill>
-                          <a:latin typeface="Arial"/>
-                        </a:defRPr>
-                      </a:pPr>
-                      <a:r>
-                        <a:t>Thành viên phụ trách</a:t>
-                      </a:r>
-                    </a:p>
-                  </a:txBody>
-                  <a:tcPr>
-                    <a:solidFill>
-                      <a:srgbClr val="1D4ED8"/>
-                    </a:solidFill>
-                  </a:tcPr>
-                </a:tc>
-              </a:tr>
-              <a:tr h="1188720">
-                <a:tc>
-                  <a:txBody>
-                    <a:bodyPr/>
-                    <a:lstStyle/>
-                    <a:p>
-                      <a:pPr>
-                        <a:defRPr sz="1100" b="1">
-                          <a:solidFill>
-                            <a:srgbClr val="0F172A"/>
-                          </a:solidFill>
-                          <a:latin typeface="Arial"/>
-                        </a:defRPr>
-                      </a:pPr>
-                      <a:r>
-                        <a:t>SQL Injection</a:t>
-                      </a:r>
-                      <a:br/>
-                      <a:r>
-                        <a:t>(A03:2021)</a:t>
-                      </a:r>
-                    </a:p>
-                  </a:txBody>
-                  <a:tcPr>
-                    <a:solidFill>
-                      <a:srgbClr val="F8FAFC"/>
-                    </a:solidFill>
-                  </a:tcPr>
-                </a:tc>
-                <a:tc>
-                  <a:txBody>
-                    <a:bodyPr/>
-                    <a:lstStyle/>
-                    <a:p>
-                      <a:pPr>
-                        <a:defRPr sz="1100">
-                          <a:solidFill>
-                            <a:srgbClr val="334155"/>
-                          </a:solidFill>
-                          <a:latin typeface="Arial"/>
-                        </a:defRPr>
-                      </a:pPr>
-                      <a:r>
-                        <a:t>Ghép chuỗi đầu vào trực tiếp vào câu lệnh SQL.</a:t>
-                      </a:r>
-                    </a:p>
-                  </a:txBody>
-                  <a:tcPr>
-                    <a:solidFill>
-                      <a:srgbClr val="F8FAFC"/>
-                    </a:solidFill>
-                  </a:tcPr>
-                </a:tc>
-                <a:tc>
-                  <a:txBody>
-                    <a:bodyPr/>
-                    <a:lstStyle/>
-                    <a:p>
-                      <a:pPr>
-                        <a:defRPr sz="1100" b="1">
-                          <a:solidFill>
-                            <a:srgbClr val="047857"/>
-                          </a:solidFill>
-                          <a:latin typeface="Arial"/>
-                        </a:defRPr>
-                      </a:pPr>
-                      <a:r>
-                        <a:t>Parameterized Query (EF Core LINQ) + Nguyên tắc đặc quyền tối thiểu.</a:t>
-                      </a:r>
-                    </a:p>
-                  </a:txBody>
-                  <a:tcPr>
-                    <a:solidFill>
-                      <a:srgbClr val="F8FAFC"/>
-                    </a:solidFill>
-                  </a:tcPr>
-                </a:tc>
-                <a:tc>
-                  <a:txBody>
-                    <a:bodyPr/>
-                    <a:lstStyle/>
-                    <a:p>
-                      <a:pPr>
-                        <a:defRPr sz="1100">
-                          <a:solidFill>
-                            <a:srgbClr val="0F172A"/>
-                          </a:solidFill>
-                          <a:latin typeface="Arial"/>
-                        </a:defRPr>
-                      </a:pPr>
-                      <a:r>
-                        <a:t>Nguyễn Danh Học</a:t>
-                      </a:r>
-                      <a:br/>
-                      <a:r>
-                        <a:t>(23A1001D0158)</a:t>
-                      </a:r>
-                    </a:p>
-                  </a:txBody>
-                  <a:tcPr>
-                    <a:solidFill>
-                      <a:srgbClr val="F8FAFC"/>
-                    </a:solidFill>
-                  </a:tcPr>
-                </a:tc>
-              </a:tr>
-              <a:tr h="1188720">
-                <a:tc>
-                  <a:txBody>
-                    <a:bodyPr/>
-                    <a:lstStyle/>
-                    <a:p>
-                      <a:pPr>
-                        <a:defRPr sz="1100" b="1">
-                          <a:solidFill>
-                            <a:srgbClr val="0F172A"/>
-                          </a:solidFill>
-                          <a:latin typeface="Arial"/>
-                        </a:defRPr>
-                      </a:pPr>
-                      <a:r>
-                        <a:t>Stored XSS</a:t>
-                      </a:r>
-                      <a:br/>
-                      <a:r>
-                        <a:t>(A03:2021)</a:t>
-                      </a:r>
-                    </a:p>
-                  </a:txBody>
-                  <a:tcPr>
-                    <a:solidFill>
-                      <a:srgbClr val="FFFFFF"/>
-                    </a:solidFill>
-                  </a:tcPr>
-                </a:tc>
-                <a:tc>
-                  <a:txBody>
-                    <a:bodyPr/>
-                    <a:lstStyle/>
-                    <a:p>
-                      <a:pPr>
-                        <a:defRPr sz="1100">
-                          <a:solidFill>
-                            <a:srgbClr val="334155"/>
-                          </a:solidFill>
-                          <a:latin typeface="Arial"/>
-                        </a:defRPr>
-                      </a:pPr>
-                      <a:r>
-                        <a:t>Lưu trữ script độc hại vào CSDL &amp; render thô bằng @Html.Raw().</a:t>
-                      </a:r>
-                    </a:p>
-                  </a:txBody>
-                  <a:tcPr>
-                    <a:solidFill>
-                      <a:srgbClr val="FFFFFF"/>
-                    </a:solidFill>
-                  </a:tcPr>
-                </a:tc>
-                <a:tc>
-                  <a:txBody>
-                    <a:bodyPr/>
-                    <a:lstStyle/>
-                    <a:p>
-                      <a:pPr>
-                        <a:defRPr sz="1100" b="1">
-                          <a:solidFill>
-                            <a:srgbClr val="047857"/>
-                          </a:solidFill>
-                          <a:latin typeface="Arial"/>
-                        </a:defRPr>
-                      </a:pPr>
-                      <a:r>
-                        <a:t>Context-Aware HTML Encoding (@model.Property) + HttpOnly Cookie.</a:t>
-                      </a:r>
-                    </a:p>
-                  </a:txBody>
-                  <a:tcPr>
-                    <a:solidFill>
-                      <a:srgbClr val="FFFFFF"/>
-                    </a:solidFill>
-                  </a:tcPr>
-                </a:tc>
-                <a:tc>
-                  <a:txBody>
-                    <a:bodyPr/>
-                    <a:lstStyle/>
-                    <a:p>
-                      <a:pPr>
-                        <a:defRPr sz="1100">
-                          <a:solidFill>
-                            <a:srgbClr val="0F172A"/>
-                          </a:solidFill>
-                          <a:latin typeface="Arial"/>
-                        </a:defRPr>
-                      </a:pPr>
-                      <a:r>
-                        <a:t>Nguyễn Thanh Bình</a:t>
-                      </a:r>
-                      <a:br/>
-                      <a:r>
-                        <a:t>(23A1001D0041)</a:t>
-                      </a:r>
-                    </a:p>
-                  </a:txBody>
-                  <a:tcPr>
-                    <a:solidFill>
-                      <a:srgbClr val="FFFFFF"/>
-                    </a:solidFill>
-                  </a:tcPr>
-                </a:tc>
-              </a:tr>
-              <a:tr h="1188720">
-                <a:tc>
-                  <a:txBody>
-                    <a:bodyPr/>
-                    <a:lstStyle/>
-                    <a:p>
-                      <a:pPr>
-                        <a:defRPr sz="1100" b="1">
-                          <a:solidFill>
-                            <a:srgbClr val="0F172A"/>
-                          </a:solidFill>
-                          <a:latin typeface="Arial"/>
-                        </a:defRPr>
-                      </a:pPr>
-                      <a:r>
-                        <a:t>CSRF Attack</a:t>
-                      </a:r>
-                      <a:br/>
-                      <a:r>
-                        <a:t>(A01:2021 / Session)</a:t>
-                      </a:r>
-                    </a:p>
-                  </a:txBody>
-                  <a:tcPr>
-                    <a:solidFill>
-                      <a:srgbClr val="F8FAFC"/>
-                    </a:solidFill>
-                  </a:tcPr>
-                </a:tc>
-                <a:tc>
-                  <a:txBody>
-                    <a:bodyPr/>
-                    <a:lstStyle/>
-                    <a:p>
-                      <a:pPr>
-                        <a:defRPr sz="1100">
-                          <a:solidFill>
-                            <a:srgbClr val="334155"/>
-                          </a:solidFill>
-                          <a:latin typeface="Arial"/>
-                        </a:defRPr>
-                      </a:pPr>
-                      <a:r>
-                        <a:t>Máy chủ chỉ kiểm tra Cookie mà không xác thực nguồn gốc Request.</a:t>
-                      </a:r>
-                    </a:p>
-                  </a:txBody>
-                  <a:tcPr>
-                    <a:solidFill>
-                      <a:srgbClr val="F8FAFC"/>
-                    </a:solidFill>
-                  </a:tcPr>
-                </a:tc>
-                <a:tc>
-                  <a:txBody>
-                    <a:bodyPr/>
-                    <a:lstStyle/>
-                    <a:p>
-                      <a:pPr>
-                        <a:defRPr sz="1100" b="1">
-                          <a:solidFill>
-                            <a:srgbClr val="047857"/>
-                          </a:solidFill>
-                          <a:latin typeface="Arial"/>
-                        </a:defRPr>
-                      </a:pPr>
-                      <a:r>
-                        <a:t>Synchronizer Token Pattern (@Html.AntiForgeryToken() / Header).</a:t>
-                      </a:r>
-                    </a:p>
-                  </a:txBody>
-                  <a:tcPr>
-                    <a:solidFill>
-                      <a:srgbClr val="F8FAFC"/>
-                    </a:solidFill>
-                  </a:tcPr>
-                </a:tc>
-                <a:tc>
-                  <a:txBody>
-                    <a:bodyPr/>
-                    <a:lstStyle/>
-                    <a:p>
-                      <a:pPr>
-                        <a:defRPr sz="1100">
-                          <a:solidFill>
-                            <a:srgbClr val="0F172A"/>
-                          </a:solidFill>
-                          <a:latin typeface="Arial"/>
-                        </a:defRPr>
-                      </a:pPr>
-                      <a:r>
-                        <a:t>Nguyễn Minh Cường</a:t>
-                      </a:r>
-                      <a:br/>
-                      <a:r>
-                        <a:t>(23A1001D0058)</a:t>
-                      </a:r>
-                    </a:p>
-                  </a:txBody>
-                  <a:tcPr>
-                    <a:solidFill>
-                      <a:srgbClr val="F8FAFC"/>
-                    </a:solidFill>
-                  </a:tcPr>
-                </a:tc>
-              </a:tr>
-            </a:tbl>
-          </a:graphicData>
-        </a:graphic>
-      </p:graphicFrame>
+      <p:sp>
+        <p:nvSpPr>
+          <p:cNvPr id="6" name="Rounded Rectangle 5"/>
+          <p:cNvSpPr/>
+          <p:nvPr/>
+        </p:nvSpPr>
+        <p:spPr>
+          <a:xfrm>
+            <a:off x="731520" y="1280160"/>
+            <a:ext cx="3328416" cy="4846320"/>
+          </a:xfrm>
+          <a:prstGeom prst="roundRect">
+            <a:avLst/>
+          </a:prstGeom>
+          <a:solidFill>
+            <a:srgbClr val="EFF6FF"/>
+          </a:solidFill>
+          <a:ln>
+            <a:solidFill>
+              <a:srgbClr val="BFDBFE"/>
+            </a:solidFill>
+          </a:ln>
+        </p:spPr>
+        <p:style>
+          <a:lnRef idx="1">
+            <a:schemeClr val="accent1"/>
+          </a:lnRef>
+          <a:fillRef idx="3">
+            <a:schemeClr val="accent1"/>
+          </a:fillRef>
+          <a:effectRef idx="2">
+            <a:schemeClr val="accent1"/>
+          </a:effectRef>
+          <a:fontRef idx="minor">
+            <a:schemeClr val="lt1"/>
+          </a:fontRef>
+        </p:style>
+        <p:txBody>
+          <a:bodyPr rtlCol="0" anchor="ctr"/>
+          <a:lstStyle/>
+          <a:p>
+            <a:pPr algn="ctr">
+              <a:defRPr sz="1500" b="1">
+                <a:solidFill>
+                  <a:srgbClr val="1D4ED8"/>
+                </a:solidFill>
+                <a:latin typeface="Arial"/>
+              </a:defRPr>
+            </a:pPr>
+            <a:r>
+              <a:t>SQL INJECTION</a:t>
+            </a:r>
+          </a:p>
+          <a:p>
+            <a:pPr>
+              <a:spcBef>
+                <a:spcPts val="1000"/>
+              </a:spcBef>
+              <a:defRPr sz="1200" b="1">
+                <a:solidFill>
+                  <a:srgbClr val="0F172A"/>
+                </a:solidFill>
+                <a:latin typeface="Arial"/>
+              </a:defRPr>
+            </a:pPr>
+            <a:r>
+              <a:t>Nguyên nhân cốt lõi:</a:t>
+            </a:r>
+          </a:p>
+          <a:p>
+            <a:pPr>
+              <a:spcBef>
+                <a:spcPts val="200"/>
+              </a:spcBef>
+              <a:defRPr sz="1200" b="0">
+                <a:solidFill>
+                  <a:srgbClr val="BE123C"/>
+                </a:solidFill>
+                <a:latin typeface="Arial"/>
+              </a:defRPr>
+            </a:pPr>
+            <a:r>
+              <a:t>Ghép chuỗi SQL trực tiếp từ tham số người dùng.</a:t>
+            </a:r>
+          </a:p>
+          <a:p>
+            <a:pPr>
+              <a:spcBef>
+                <a:spcPts val="600"/>
+              </a:spcBef>
+              <a:defRPr sz="1400" b="1">
+                <a:solidFill>
+                  <a:srgbClr val="64748B"/>
+                </a:solidFill>
+                <a:latin typeface="Arial"/>
+              </a:defRPr>
+            </a:pPr>
+            <a:r>
+              <a:t>      │</a:t>
+            </a:r>
+            <a:br/>
+            <a:r>
+              <a:t>      ▼</a:t>
+            </a:r>
+          </a:p>
+          <a:p>
+            <a:pPr>
+              <a:spcBef>
+                <a:spcPts val="600"/>
+              </a:spcBef>
+              <a:defRPr sz="1200" b="1">
+                <a:solidFill>
+                  <a:srgbClr val="0F172A"/>
+                </a:solidFill>
+                <a:latin typeface="Arial"/>
+              </a:defRPr>
+            </a:pPr>
+            <a:r>
+              <a:t>Cơ chế phòng thủ:</a:t>
+            </a:r>
+          </a:p>
+          <a:p>
+            <a:pPr>
+              <a:spcBef>
+                <a:spcPts val="200"/>
+              </a:spcBef>
+              <a:defRPr sz="1200" b="1">
+                <a:solidFill>
+                  <a:srgbClr val="047857"/>
+                </a:solidFill>
+                <a:latin typeface="Arial"/>
+              </a:defRPr>
+            </a:pPr>
+            <a:r>
+              <a:t>Parameterized Query</a:t>
+            </a:r>
+            <a:br/>
+            <a:r>
+              <a:t>(Entity Framework Core LINQ)</a:t>
+            </a:r>
+          </a:p>
+          <a:p>
+            <a:br/>
+            <a:pPr>
+              <a:spcBef>
+                <a:spcPts val="1400"/>
+              </a:spcBef>
+              <a:defRPr sz="1100" b="0">
+                <a:solidFill>
+                  <a:srgbClr val="64748B"/>
+                </a:solidFill>
+                <a:latin typeface="Arial"/>
+              </a:defRPr>
+            </a:pPr>
+            <a:r>
+              <a:t>Phụ trách: Nguyễn Danh Học</a:t>
+            </a:r>
+            <a:br/>
+            <a:r>
+              <a:t>MSV: 23A1001D0158</a:t>
+            </a:r>
+          </a:p>
+        </p:txBody>
+      </p:sp>
+      <p:sp>
+        <p:nvSpPr>
+          <p:cNvPr id="7" name="Rounded Rectangle 6"/>
+          <p:cNvSpPr/>
+          <p:nvPr/>
+        </p:nvSpPr>
+        <p:spPr>
+          <a:xfrm>
+            <a:off x="4416552" y="1280160"/>
+            <a:ext cx="3328416" cy="4846320"/>
+          </a:xfrm>
+          <a:prstGeom prst="roundRect">
+            <a:avLst/>
+          </a:prstGeom>
+          <a:solidFill>
+            <a:srgbClr val="FFF1F2"/>
+          </a:solidFill>
+          <a:ln>
+            <a:solidFill>
+              <a:srgbClr val="FECDD3"/>
+            </a:solidFill>
+          </a:ln>
+        </p:spPr>
+        <p:style>
+          <a:lnRef idx="1">
+            <a:schemeClr val="accent1"/>
+          </a:lnRef>
+          <a:fillRef idx="3">
+            <a:schemeClr val="accent1"/>
+          </a:fillRef>
+          <a:effectRef idx="2">
+            <a:schemeClr val="accent1"/>
+          </a:effectRef>
+          <a:fontRef idx="minor">
+            <a:schemeClr val="lt1"/>
+          </a:fontRef>
+        </p:style>
+        <p:txBody>
+          <a:bodyPr rtlCol="0" anchor="ctr"/>
+          <a:lstStyle/>
+          <a:p>
+            <a:pPr algn="ctr">
+              <a:defRPr sz="1500" b="1">
+                <a:solidFill>
+                  <a:srgbClr val="BE123C"/>
+                </a:solidFill>
+                <a:latin typeface="Arial"/>
+              </a:defRPr>
+            </a:pPr>
+            <a:r>
+              <a:t>STORED XSS</a:t>
+            </a:r>
+          </a:p>
+          <a:p>
+            <a:pPr>
+              <a:spcBef>
+                <a:spcPts val="1000"/>
+              </a:spcBef>
+              <a:defRPr sz="1200" b="1">
+                <a:solidFill>
+                  <a:srgbClr val="0F172A"/>
+                </a:solidFill>
+                <a:latin typeface="Arial"/>
+              </a:defRPr>
+            </a:pPr>
+            <a:r>
+              <a:t>Nguyên nhân cốt lõi:</a:t>
+            </a:r>
+          </a:p>
+          <a:p>
+            <a:pPr>
+              <a:spcBef>
+                <a:spcPts val="200"/>
+              </a:spcBef>
+              <a:defRPr sz="1200" b="0">
+                <a:solidFill>
+                  <a:srgbClr val="BE123C"/>
+                </a:solidFill>
+                <a:latin typeface="Arial"/>
+              </a:defRPr>
+            </a:pPr>
+            <a:r>
+              <a:t>Lưu script thô vào CSDL &amp; render bằng @Html.Raw().</a:t>
+            </a:r>
+          </a:p>
+          <a:p>
+            <a:pPr>
+              <a:spcBef>
+                <a:spcPts val="600"/>
+              </a:spcBef>
+              <a:defRPr sz="1400" b="1">
+                <a:solidFill>
+                  <a:srgbClr val="64748B"/>
+                </a:solidFill>
+                <a:latin typeface="Arial"/>
+              </a:defRPr>
+            </a:pPr>
+            <a:r>
+              <a:t>      │</a:t>
+            </a:r>
+            <a:br/>
+            <a:r>
+              <a:t>      ▼</a:t>
+            </a:r>
+          </a:p>
+          <a:p>
+            <a:pPr>
+              <a:spcBef>
+                <a:spcPts val="600"/>
+              </a:spcBef>
+              <a:defRPr sz="1200" b="1">
+                <a:solidFill>
+                  <a:srgbClr val="0F172A"/>
+                </a:solidFill>
+                <a:latin typeface="Arial"/>
+              </a:defRPr>
+            </a:pPr>
+            <a:r>
+              <a:t>Cơ chế phòng thủ:</a:t>
+            </a:r>
+          </a:p>
+          <a:p>
+            <a:pPr>
+              <a:spcBef>
+                <a:spcPts val="200"/>
+              </a:spcBef>
+              <a:defRPr sz="1200" b="1">
+                <a:solidFill>
+                  <a:srgbClr val="047857"/>
+                </a:solidFill>
+                <a:latin typeface="Arial"/>
+              </a:defRPr>
+            </a:pPr>
+            <a:r>
+              <a:t>Context-Aware HTML Encoding</a:t>
+            </a:r>
+            <a:br/>
+            <a:r>
+              <a:t>(@comment.Content + HttpOnly)</a:t>
+            </a:r>
+          </a:p>
+          <a:p>
+            <a:br/>
+            <a:pPr>
+              <a:spcBef>
+                <a:spcPts val="1400"/>
+              </a:spcBef>
+              <a:defRPr sz="1100" b="0">
+                <a:solidFill>
+                  <a:srgbClr val="64748B"/>
+                </a:solidFill>
+                <a:latin typeface="Arial"/>
+              </a:defRPr>
+            </a:pPr>
+            <a:r>
+              <a:t>Phụ trách: Nguyễn Thanh Bình</a:t>
+            </a:r>
+            <a:br/>
+            <a:r>
+              <a:t>MSV: 23A1001D0041</a:t>
+            </a:r>
+          </a:p>
+        </p:txBody>
+      </p:sp>
+      <p:sp>
+        <p:nvSpPr>
+          <p:cNvPr id="8" name="Rounded Rectangle 7"/>
+          <p:cNvSpPr/>
+          <p:nvPr/>
+        </p:nvSpPr>
+        <p:spPr>
+          <a:xfrm>
+            <a:off x="8101584" y="1280160"/>
+            <a:ext cx="3328416" cy="4846320"/>
+          </a:xfrm>
+          <a:prstGeom prst="roundRect">
+            <a:avLst/>
+          </a:prstGeom>
+          <a:solidFill>
+            <a:srgbClr val="ECFDF5"/>
+          </a:solidFill>
+          <a:ln>
+            <a:solidFill>
+              <a:srgbClr val="A7F3D0"/>
+            </a:solidFill>
+          </a:ln>
+        </p:spPr>
+        <p:style>
+          <a:lnRef idx="1">
+            <a:schemeClr val="accent1"/>
+          </a:lnRef>
+          <a:fillRef idx="3">
+            <a:schemeClr val="accent1"/>
+          </a:fillRef>
+          <a:effectRef idx="2">
+            <a:schemeClr val="accent1"/>
+          </a:effectRef>
+          <a:fontRef idx="minor">
+            <a:schemeClr val="lt1"/>
+          </a:fontRef>
+        </p:style>
+        <p:txBody>
+          <a:bodyPr rtlCol="0" anchor="ctr"/>
+          <a:lstStyle/>
+          <a:p>
+            <a:pPr algn="ctr">
+              <a:defRPr sz="1500" b="1">
+                <a:solidFill>
+                  <a:srgbClr val="047857"/>
+                </a:solidFill>
+                <a:latin typeface="Arial"/>
+              </a:defRPr>
+            </a:pPr>
+            <a:r>
+              <a:t>CSRF ATTACK</a:t>
+            </a:r>
+          </a:p>
+          <a:p>
+            <a:pPr>
+              <a:spcBef>
+                <a:spcPts val="1000"/>
+              </a:spcBef>
+              <a:defRPr sz="1200" b="1">
+                <a:solidFill>
+                  <a:srgbClr val="0F172A"/>
+                </a:solidFill>
+                <a:latin typeface="Arial"/>
+              </a:defRPr>
+            </a:pPr>
+            <a:r>
+              <a:t>Nguyên nhân cốt lõi:</a:t>
+            </a:r>
+          </a:p>
+          <a:p>
+            <a:pPr>
+              <a:spcBef>
+                <a:spcPts val="200"/>
+              </a:spcBef>
+              <a:defRPr sz="1200" b="0">
+                <a:solidFill>
+                  <a:srgbClr val="BE123C"/>
+                </a:solidFill>
+                <a:latin typeface="Arial"/>
+              </a:defRPr>
+            </a:pPr>
+            <a:r>
+              <a:t>Chỉ kiểm tra Cookie mà thiếu xác thực nguồn gốc Request.</a:t>
+            </a:r>
+          </a:p>
+          <a:p>
+            <a:pPr>
+              <a:spcBef>
+                <a:spcPts val="600"/>
+              </a:spcBef>
+              <a:defRPr sz="1400" b="1">
+                <a:solidFill>
+                  <a:srgbClr val="64748B"/>
+                </a:solidFill>
+                <a:latin typeface="Arial"/>
+              </a:defRPr>
+            </a:pPr>
+            <a:r>
+              <a:t>      │</a:t>
+            </a:r>
+            <a:br/>
+            <a:r>
+              <a:t>      ▼</a:t>
+            </a:r>
+          </a:p>
+          <a:p>
+            <a:pPr>
+              <a:spcBef>
+                <a:spcPts val="600"/>
+              </a:spcBef>
+              <a:defRPr sz="1200" b="1">
+                <a:solidFill>
+                  <a:srgbClr val="0F172A"/>
+                </a:solidFill>
+                <a:latin typeface="Arial"/>
+              </a:defRPr>
+            </a:pPr>
+            <a:r>
+              <a:t>Cơ chế phòng thủ:</a:t>
+            </a:r>
+          </a:p>
+          <a:p>
+            <a:pPr>
+              <a:spcBef>
+                <a:spcPts val="200"/>
+              </a:spcBef>
+              <a:defRPr sz="1200" b="1">
+                <a:solidFill>
+                  <a:srgbClr val="047857"/>
+                </a:solidFill>
+                <a:latin typeface="Arial"/>
+              </a:defRPr>
+            </a:pPr>
+            <a:r>
+              <a:t>Synchronizer Token Pattern</a:t>
+            </a:r>
+            <a:br/>
+            <a:r>
+              <a:t>(@Html.AntiForgeryToken)</a:t>
+            </a:r>
+          </a:p>
+          <a:p>
+            <a:br/>
+            <a:pPr>
+              <a:spcBef>
+                <a:spcPts val="1400"/>
+              </a:spcBef>
+              <a:defRPr sz="1100" b="0">
+                <a:solidFill>
+                  <a:srgbClr val="64748B"/>
+                </a:solidFill>
+                <a:latin typeface="Arial"/>
+              </a:defRPr>
+            </a:pPr>
+            <a:r>
+              <a:t>Phụ trách: Nguyễn Minh Cường</a:t>
+            </a:r>
+            <a:br/>
+            <a:r>
+              <a:t>MSV: 23A1001D0058</a:t>
+            </a:r>
+          </a:p>
+        </p:txBody>
+      </p:sp>
     </p:spTree>
   </p:cSld>
   <p:clrMapOvr>
@@ -6900,7 +7125,7 @@
               </a:defRPr>
             </a:pPr>
             <a:r>
-              <a:t>Kết Luận Báo Cáo Thực Nghiệm OWASP Top 10</a:t>
+              <a:t>Kết Luận Thực Nghiệm &amp; Q&amp;A</a:t>
             </a:r>
           </a:p>
         </p:txBody>
@@ -6991,7 +7216,7 @@
               </a:defRPr>
             </a:pPr>
             <a:r>
-              <a:t>KẾT LUẬN &amp; CAM KẾT CHUẨN BẢO MẬT (NHÓM WNC.G01)</a:t>
+              <a:t>TỔNG KẾT: TỪ KHAI THÁC THỰC NGHIỆM ĐẾN PHÒNG THỦ ĐA TẦNG</a:t>
             </a:r>
           </a:p>
           <a:p>
@@ -6999,7 +7224,23 @@
               <a:spcBef>
                 <a:spcPts val="1400"/>
               </a:spcBef>
-              <a:defRPr sz="1300" b="0">
+              <a:defRPr sz="1300" b="1">
+                <a:solidFill>
+                  <a:srgbClr val="BE123C"/>
+                </a:solidFill>
+                <a:latin typeface="Arial"/>
+              </a:defRPr>
+            </a:pPr>
+            <a:r>
+              <a:t>01 — Tái lập thành công lỗ hổng:</a:t>
+            </a:r>
+          </a:p>
+          <a:p>
+            <a:pPr>
+              <a:spcBef>
+                <a:spcPts val="200"/>
+              </a:spcBef>
+              <a:defRPr sz="1250" b="0">
                 <a:solidFill>
                   <a:srgbClr val="334155"/>
                 </a:solidFill>
@@ -7007,7 +7248,7 @@
               </a:defRPr>
             </a:pPr>
             <a:r>
-              <a:t>1. Thực nghiệm trực quan: Nhóm đã chứng minh rõ cơ chế khai thác và mức độ rủi ro của từng lỗ hổng trên cả 3 tầng: Giao diện Web, Gói tin mạng (Chrome DevTools) và Cơ sở dữ liệu (SQL Server 2025).</a:t>
+              <a:t>Nhóm đã biểu diễn thành công kịch bản tấn công trên 3 bề mặt: Giao diện Web, Gói tin mạng (Chrome DevTools) và CSDL SQL Server 2025.</a:t>
             </a:r>
           </a:p>
           <a:p>
@@ -7015,7 +7256,23 @@
               <a:spcBef>
                 <a:spcPts val="1200"/>
               </a:spcBef>
-              <a:defRPr sz="1300" b="0">
+              <a:defRPr sz="1300" b="1">
+                <a:solidFill>
+                  <a:srgbClr val="047857"/>
+                </a:solidFill>
+                <a:latin typeface="Arial"/>
+              </a:defRPr>
+            </a:pPr>
+            <a:r>
+              <a:t>02 — Kiểm chứng giải pháp phòng thủ triệt để:</a:t>
+            </a:r>
+          </a:p>
+          <a:p>
+            <a:pPr>
+              <a:spcBef>
+                <a:spcPts val="200"/>
+              </a:spcBef>
+              <a:defRPr sz="1250" b="0">
                 <a:solidFill>
                   <a:srgbClr val="334155"/>
                 </a:solidFill>
@@ -7023,7 +7280,7 @@
               </a:defRPr>
             </a:pPr>
             <a:r>
-              <a:t>2. Phòng thủ đa tầng (Security View): Các cơ chế phòng thủ (EF Core Parameterized, Razor HTML Encoding, Anti-Forgery Token) được tích hợp trực tiếp vào kiến trúc nền tảng của Đồ án BTL Website Tư Vấn Trực Tuyến.</a:t>
+              <a:t>Áp dụng Parameterized Query, HTML Encoding và Anti-Forgery Token chặn đứng 100% các vector tấn công.</a:t>
             </a:r>
           </a:p>
           <a:p>
@@ -7031,24 +7288,44 @@
               <a:spcBef>
                 <a:spcPts val="1200"/>
               </a:spcBef>
-              <a:defRPr sz="1300" b="0">
-                <a:solidFill>
-                  <a:srgbClr val="334155"/>
-                </a:solidFill>
-                <a:latin typeface="Arial"/>
-              </a:defRPr>
-            </a:pPr>
-            <a:r>
-              <a:t>3. Đóng góp đồng đều: Cả 3 thành viên đều trực tiếp xây dựng mã nguồn, kiểm thử đối chứng và phân tích chuyên môn độc lập.</a:t>
-            </a:r>
-          </a:p>
-          <a:p>
-            <a:br/>
+              <a:defRPr sz="1300" b="1">
+                <a:solidFill>
+                  <a:srgbClr val="1D4ED8"/>
+                </a:solidFill>
+                <a:latin typeface="Arial"/>
+              </a:defRPr>
+            </a:pPr>
+            <a:r>
+              <a:t>03 — Triết lý an ninh cốt lõi (Security Principle):</a:t>
+            </a:r>
+          </a:p>
+          <a:p>
             <a:pPr>
               <a:spcBef>
-                <a:spcPts val="2400"/>
+                <a:spcPts val="400"/>
               </a:spcBef>
-              <a:defRPr sz="1500" b="1">
+              <a:defRPr sz="1250" b="1">
+                <a:solidFill>
+                  <a:srgbClr val="0F172A"/>
+                </a:solidFill>
+                <a:latin typeface="Arial"/>
+              </a:defRPr>
+            </a:pPr>
+            <a:r>
+              <a:t>• Never trust user-controlled input (Không bao giờ tin tưởng dữ liệu đầu vào).</a:t>
+            </a:r>
+            <a:br/>
+            <a:r>
+              <a:t>• Separate data from executable instructions (Luôn phân tách dữ liệu khỏi cú pháp lệnh).</a:t>
+            </a:r>
+          </a:p>
+          <a:p>
+            <a:br/>
+            <a:pPr>
+              <a:spcBef>
+                <a:spcPts val="2000"/>
+              </a:spcBef>
+              <a:defRPr sz="1600" b="1">
                 <a:solidFill>
                   <a:srgbClr val="BE123C"/>
                 </a:solidFill>
@@ -7056,7 +7333,7 @@
               </a:defRPr>
             </a:pPr>
             <a:r>
-              <a:t>Kính chúc thầy sức khỏe và công tác tốt. Nhóm WNC.G01 xin trân trọng cảm ơn!</a:t>
+              <a:t>XIN TRÂN TRỌNG CẢM ƠN THẦY VÀ CÁC BẠN! — Q&amp;A</a:t>
             </a:r>
           </a:p>
         </p:txBody>
@@ -7291,7 +7568,7 @@
           <a:lstStyle/>
           <a:p>
             <a:pPr algn="ctr">
-              <a:defRPr sz="1500" b="1">
+              <a:defRPr sz="1400" b="1">
                 <a:solidFill>
                   <a:srgbClr val="1D4ED8"/>
                 </a:solidFill>
@@ -7299,7 +7576,7 @@
               </a:defRPr>
             </a:pPr>
             <a:r>
-              <a:t>Thông Số Cấu Hình Hệ Thống Thực Nghiệm</a:t>
+              <a:t>TECH STACK (MÔI TRƯỜNG KỸ THUẬT)</a:t>
             </a:r>
           </a:p>
           <a:p>
@@ -7315,7 +7592,11 @@
               </a:defRPr>
             </a:pPr>
             <a:r>
-              <a:t>• Hệ điều hành: Linux (Ubuntu 24.04 LTS / Zorin OS)</a:t>
+              <a:t>• Operating System:</a:t>
+            </a:r>
+            <a:br/>
+            <a:r>
+              <a:t>  Ubuntu 24.04 LTS / Linux Kernel 6.8</a:t>
             </a:r>
           </a:p>
           <a:p>
@@ -7331,7 +7612,11 @@
               </a:defRPr>
             </a:pPr>
             <a:r>
-              <a:t>• Nền tảng Backend: ASP.NET Core MVC (.NET 10.0)</a:t>
+              <a:t>• Backend Platform:</a:t>
+            </a:r>
+            <a:br/>
+            <a:r>
+              <a:t>  ASP.NET Core MVC / .NET 10.0</a:t>
             </a:r>
           </a:p>
           <a:p>
@@ -7347,7 +7632,11 @@
               </a:defRPr>
             </a:pPr>
             <a:r>
-              <a:t>• Cơ sở dữ liệu: Microsoft SQL Server 2025 Developer (Port 1433)</a:t>
+              <a:t>• Database Engine:</a:t>
+            </a:r>
+            <a:br/>
+            <a:r>
+              <a:t>  Microsoft SQL Server 2025 Developer (Port 1433)</a:t>
             </a:r>
           </a:p>
           <a:p>
@@ -7363,7 +7652,11 @@
               </a:defRPr>
             </a:pPr>
             <a:r>
-              <a:t>• Tầng giao diện: Razor View Engine, HTML5, CSS3, JavaScript</a:t>
+              <a:t>• Frontend Engine:</a:t>
+            </a:r>
+            <a:br/>
+            <a:r>
+              <a:t>  Razor View, HTML5, CSS3, JavaScript</a:t>
             </a:r>
           </a:p>
           <a:p>
@@ -7379,23 +7672,11 @@
               </a:defRPr>
             </a:pPr>
             <a:r>
-              <a:t>• Môi trường phát triển: Visual Studio Code, C# DevKit</a:t>
-            </a:r>
-          </a:p>
-          <a:p>
-            <a:pPr>
-              <a:spcBef>
-                <a:spcPts val="600"/>
-              </a:spcBef>
-              <a:defRPr sz="1200" b="0">
-                <a:solidFill>
-                  <a:srgbClr val="334155"/>
-                </a:solidFill>
-                <a:latin typeface="Arial"/>
-              </a:defRPr>
-            </a:pPr>
-            <a:r>
-              <a:t>• Công cụ kiểm thử: Chrome DevTools, cURL CLI, MSSQL Extension</a:t>
+              <a:t>• Development &amp; Testing Tools:</a:t>
+            </a:r>
+            <a:br/>
+            <a:r>
+              <a:t>  VS Code, Chrome DevTools, cURL CLI, MSSQL Extension</a:t>
             </a:r>
           </a:p>
         </p:txBody>
@@ -7442,7 +7723,7 @@
           <a:lstStyle/>
           <a:p>
             <a:pPr algn="ctr">
-              <a:defRPr sz="1500" b="1">
+              <a:defRPr sz="1400" b="1">
                 <a:solidFill>
                   <a:srgbClr val="047857"/>
                 </a:solidFill>
@@ -7450,7 +7731,7 @@
               </a:defRPr>
             </a:pPr>
             <a:r>
-              <a:t>Phạm Vi &amp; Nguyên Tắc Đạo Đức An Ninh</a:t>
+              <a:t>LAB SCOPE (PHẠM VI &amp; NGUYÊN TẮC ĐẠO ĐỨC)</a:t>
             </a:r>
           </a:p>
           <a:p>
@@ -7458,9 +7739,9 @@
               <a:spcBef>
                 <a:spcPts val="800"/>
               </a:spcBef>
-              <a:defRPr sz="1250" b="1">
-                <a:solidFill>
-                  <a:srgbClr val="0F172A"/>
+              <a:defRPr sz="1200" b="0">
+                <a:solidFill>
+                  <a:srgbClr val="334155"/>
                 </a:solidFill>
                 <a:latin typeface="Arial"/>
               </a:defRPr>
@@ -7468,11 +7749,15 @@
             <a:r>
               <a:t>✓ Môi trường cô lập (Localhost):</a:t>
             </a:r>
+            <a:br/>
+            <a:r>
+              <a:t>Thực nghiệm hoàn toàn trên ứng dụng do nhóm tự xây dựng (http://localhost:5076), tuyệt đối không quét hay tấn công hệ thống bên ngoài.</a:t>
+            </a:r>
           </a:p>
           <a:p>
             <a:pPr>
               <a:spcBef>
-                <a:spcPts val="400"/>
+                <a:spcPts val="1000"/>
               </a:spcBef>
               <a:defRPr sz="1200" b="0">
                 <a:solidFill>
@@ -7482,29 +7767,17 @@
               </a:defRPr>
             </a:pPr>
             <a:r>
-              <a:t>Toàn bộ thực nghiệm được tiến hành trên ứng dụng mẫu do nhóm tự xây dựng (chạy trên localhost:5076), tuyệt đối không thực hiện trên các hệ thống bên ngoài.</a:t>
+              <a:t>✓ Thiết kế đối chứng song song:</a:t>
+            </a:r>
+            <a:br/>
+            <a:r>
+              <a:t>Mỗi lỗ hổng đều xây dựng 2 nhánh: Vulnerable (minh họa lỗi) vs Secure (chứng minh phòng thủ).</a:t>
             </a:r>
           </a:p>
           <a:p>
             <a:pPr>
               <a:spcBef>
-                <a:spcPts val="1200"/>
-              </a:spcBef>
-              <a:defRPr sz="1250" b="1">
-                <a:solidFill>
-                  <a:srgbClr val="0F172A"/>
-                </a:solidFill>
-                <a:latin typeface="Arial"/>
-              </a:defRPr>
-            </a:pPr>
-            <a:r>
-              <a:t>✓ Thiết kế đối chứng song song (Vulnerable vs Secure):</a:t>
-            </a:r>
-          </a:p>
-          <a:p>
-            <a:pPr>
-              <a:spcBef>
-                <a:spcPts val="400"/>
+                <a:spcPts val="1000"/>
               </a:spcBef>
               <a:defRPr sz="1200" b="0">
                 <a:solidFill>
@@ -7514,39 +7787,11 @@
               </a:defRPr>
             </a:pPr>
             <a:r>
-              <a:t>Mỗi lỗ hổng đều xây dựng 2 nhánh xử lý: Nhánh dính lỗi (để chứng minh sự nguy hiểm) và Nhánh an toàn (để kiểm chứng hiệu quả phòng thủ).</a:t>
-            </a:r>
-          </a:p>
-          <a:p>
-            <a:pPr>
-              <a:spcBef>
-                <a:spcPts val="1200"/>
-              </a:spcBef>
-              <a:defRPr sz="1250" b="1">
-                <a:solidFill>
-                  <a:srgbClr val="0F172A"/>
-                </a:solidFill>
-                <a:latin typeface="Arial"/>
-              </a:defRPr>
-            </a:pPr>
-            <a:r>
               <a:t>✓ Dữ liệu mô phỏng an toàn:</a:t>
             </a:r>
-          </a:p>
-          <a:p>
-            <a:pPr>
-              <a:spcBef>
-                <a:spcPts val="400"/>
-              </a:spcBef>
-              <a:defRPr sz="1200" b="0">
-                <a:solidFill>
-                  <a:srgbClr val="334155"/>
-                </a:solidFill>
-                <a:latin typeface="Arial"/>
-              </a:defRPr>
-            </a:pPr>
-            <a:r>
-              <a:t>Toàn bộ tài khoản, mật khẩu và số dư ví trong CSDL là dữ liệu mẫu giả định phục vụ mục đích học tập và nghiên cứu.</a:t>
+            <a:br/>
+            <a:r>
+              <a:t>Toàn bộ tài khoản, số dư và mật khẩu là dữ liệu giả định phục vụ học tập.</a:t>
             </a:r>
           </a:p>
         </p:txBody>
@@ -7698,7 +7943,7 @@
               </a:defRPr>
             </a:pPr>
             <a:r>
-              <a:t>1.1. SQL Injection: Sơ Đồ Luồng &amp; Nguyên Nhân Cốt Lõi</a:t>
+              <a:t>1.1. SQL Injection — Lỗi Xảy Ra Ở Đâu &amp; Nguyên Nhân Cốt Lõi</a:t>
             </a:r>
           </a:p>
         </p:txBody>
@@ -7789,13 +8034,13 @@
               </a:defRPr>
             </a:pPr>
             <a:r>
-              <a:t>Sơ Đồ Luồng Xử Lý Dữ Liệu</a:t>
+              <a:t>Sơ Đồ Luồng Xử Lý &amp; Root Cause</a:t>
             </a:r>
           </a:p>
           <a:p>
             <a:pPr>
               <a:spcBef>
-                <a:spcPts val="800"/>
+                <a:spcPts val="1000"/>
               </a:spcBef>
               <a:defRPr sz="1200" b="1">
                 <a:solidFill>
@@ -7877,14 +8122,14 @@
               </a:defRPr>
             </a:pPr>
             <a:r>
-              <a:t>SQL Server 2025 ➔ Thông dịch cấu trúc lệnh bị tiêm nhiễm</a:t>
+              <a:t>SQL Server 2025 ➔ Thực thi câu lệnh bị bẻ gãy cú pháp</a:t>
             </a:r>
           </a:p>
           <a:p>
             <a:br/>
             <a:pPr>
               <a:spcBef>
-                <a:spcPts val="800"/>
+                <a:spcPts val="1000"/>
               </a:spcBef>
               <a:defRPr sz="1200" b="0">
                 <a:solidFill>
@@ -7894,11 +8139,11 @@
               </a:defRPr>
             </a:pPr>
             <a:r>
-              <a:t>Root Cause (Nguyên nhân cốt lõi):</a:t>
-            </a:r>
-            <a:br/>
-            <a:r>
-              <a:t>Dữ liệu người dùng được ghép trực tiếp vào câu truy vấn. Hệ CSDL không phân định được đâu là Dữ liệu (Data) và đâu là Cú pháp lệnh (Code).</a:t>
+              <a:t>📌 ROOT CAUSE (Nguyên nhân cốt lõi):</a:t>
+            </a:r>
+            <a:br/>
+            <a:r>
+              <a:t>Dữ liệu người dùng được ghép trực tiếp vào câu lệnh SQL. Hệ CSDL không phân định được ranh giới giữa Dữ liệu (Data) và Lệnh thực thi (Code).</a:t>
             </a:r>
           </a:p>
         </p:txBody>
@@ -7945,7 +8190,7 @@
           <a:lstStyle/>
           <a:p>
             <a:pPr algn="ctr">
-              <a:defRPr sz="1500" b="1">
+              <a:defRPr sz="1400" b="1">
                 <a:solidFill>
                   <a:srgbClr val="BE123C"/>
                 </a:solidFill>
@@ -7953,15 +8198,15 @@
               </a:defRPr>
             </a:pPr>
             <a:r>
-              <a:t>Đoạn Mã Gây Lỗi (C# Controller)</a:t>
+              <a:t>🔴 VULNERABLE CODE (Ghép Chuỗi SQL)</a:t>
             </a:r>
           </a:p>
           <a:p>
             <a:pPr>
               <a:spcBef>
-                <a:spcPts val="800"/>
+                <a:spcPts val="1000"/>
               </a:spcBef>
-              <a:defRPr sz="1050" b="0">
+              <a:defRPr sz="1100" b="0">
                 <a:solidFill>
                   <a:srgbClr val="9F1239"/>
                 </a:solidFill>
@@ -7969,7 +8214,7 @@
               </a:defRPr>
             </a:pPr>
             <a:r>
-              <a:t>// NỐI CHUỖI TRỰC TIẾP TỪ THAM SỐ:</a:t>
+              <a:t>// Nối chuỗi trực tiếp từ tham số đầu vào:</a:t>
             </a:r>
             <a:br/>
             <a:r>
@@ -8010,11 +8255,11 @@
               </a:defRPr>
             </a:pPr>
             <a:r>
-              <a:t>Cơ chế phá vỡ cú pháp:</a:t>
-            </a:r>
-            <a:br/>
-            <a:r>
-              <a:t>Dấu nháy đơn (') của kẻ tấn công đóng sớm chuỗi giá trị Username. Phần còn lại được máy chủ thông dịch thành lệnh điều khiển thay vì dữ liệu.</a:t>
+              <a:t>Cơ chế phá vỡ:</a:t>
+            </a:r>
+            <a:br/>
+            <a:r>
+              <a:t>Dấu nháy đơn (') đóng chuỗi sớm, biến mệnh đề kiểm tra mật khẩu thành chú thích (--), mở toang quyền truy cập CSDL.</a:t>
             </a:r>
           </a:p>
         </p:txBody>
@@ -8166,7 +8411,7 @@
               </a:defRPr>
             </a:pPr>
             <a:r>
-              <a:t>1.2. SQL Injection: 3 Kịch Bản Khai Thác Thực Nghiệm</a:t>
+              <a:t>1.2. SQL Injection — 3 Kịch Bản Khai Thác Thực Nghiệm</a:t>
             </a:r>
           </a:p>
         </p:txBody>
@@ -8207,426 +8452,231 @@
           </a:p>
         </p:txBody>
       </p:sp>
-      <p:graphicFrame>
-        <p:nvGraphicFramePr>
-          <p:cNvPr id="6" name="Table 5"/>
-          <p:cNvGraphicFramePr>
-            <a:graphicFrameLocks noGrp="1"/>
-          </p:cNvGraphicFramePr>
-          <p:nvPr/>
-        </p:nvGraphicFramePr>
-        <p:xfrm>
-          <a:off x="731520" y="1280160"/>
-          <a:ext cx="10728655" cy="4846320"/>
-        </p:xfrm>
-        <a:graphic>
-          <a:graphicData uri="http://schemas.openxmlformats.org/drawingml/2006/table">
-            <a:tbl>
-              <a:tblPr firstRow="1" bandRow="1">
-                <a:tableStyleId>{5C22544A-7EE6-4342-B048-85BDC9FD1C3A}</a:tableStyleId>
-              </a:tblPr>
-              <a:tblGrid>
-                <a:gridCol w="2682163"/>
-                <a:gridCol w="2682163"/>
-                <a:gridCol w="2682163"/>
-                <a:gridCol w="2682166"/>
-              </a:tblGrid>
-              <a:tr h="1211580">
-                <a:tc>
-                  <a:txBody>
-                    <a:bodyPr/>
-                    <a:lstStyle/>
-                    <a:p>
-                      <a:pPr>
-                        <a:defRPr b="1" sz="1100">
-                          <a:solidFill>
-                            <a:srgbClr val="FFFFFF"/>
-                          </a:solidFill>
-                          <a:latin typeface="Arial"/>
-                        </a:defRPr>
-                      </a:pPr>
-                      <a:r>
-                        <a:t>Kịch bản kiểm thử</a:t>
-                      </a:r>
-                    </a:p>
-                  </a:txBody>
-                  <a:tcPr>
-                    <a:solidFill>
-                      <a:srgbClr val="1D4ED8"/>
-                    </a:solidFill>
-                  </a:tcPr>
-                </a:tc>
-                <a:tc>
-                  <a:txBody>
-                    <a:bodyPr/>
-                    <a:lstStyle/>
-                    <a:p>
-                      <a:pPr>
-                        <a:defRPr b="1" sz="1100">
-                          <a:solidFill>
-                            <a:srgbClr val="FFFFFF"/>
-                          </a:solidFill>
-                          <a:latin typeface="Arial"/>
-                        </a:defRPr>
-                      </a:pPr>
-                      <a:r>
-                        <a:t>Payload đưa vào ô Username</a:t>
-                      </a:r>
-                    </a:p>
-                  </a:txBody>
-                  <a:tcPr>
-                    <a:solidFill>
-                      <a:srgbClr val="1D4ED8"/>
-                    </a:solidFill>
-                  </a:tcPr>
-                </a:tc>
-                <a:tc>
-                  <a:txBody>
-                    <a:bodyPr/>
-                    <a:lstStyle/>
-                    <a:p>
-                      <a:pPr>
-                        <a:defRPr b="1" sz="1100">
-                          <a:solidFill>
-                            <a:srgbClr val="FFFFFF"/>
-                          </a:solidFill>
-                          <a:latin typeface="Arial"/>
-                        </a:defRPr>
-                      </a:pPr>
-                      <a:r>
-                        <a:t>Cơ chế bẻ gãy cú pháp</a:t>
-                      </a:r>
-                    </a:p>
-                  </a:txBody>
-                  <a:tcPr>
-                    <a:solidFill>
-                      <a:srgbClr val="1D4ED8"/>
-                    </a:solidFill>
-                  </a:tcPr>
-                </a:tc>
-                <a:tc>
-                  <a:txBody>
-                    <a:bodyPr/>
-                    <a:lstStyle/>
-                    <a:p>
-                      <a:pPr>
-                        <a:defRPr b="1" sz="1100">
-                          <a:solidFill>
-                            <a:srgbClr val="FFFFFF"/>
-                          </a:solidFill>
-                          <a:latin typeface="Arial"/>
-                        </a:defRPr>
-                      </a:pPr>
-                      <a:r>
-                        <a:t>Kết quả thực tế</a:t>
-                      </a:r>
-                    </a:p>
-                  </a:txBody>
-                  <a:tcPr>
-                    <a:solidFill>
-                      <a:srgbClr val="1D4ED8"/>
-                    </a:solidFill>
-                  </a:tcPr>
-                </a:tc>
-              </a:tr>
-              <a:tr h="1211580">
-                <a:tc>
-                  <a:txBody>
-                    <a:bodyPr/>
-                    <a:lstStyle/>
-                    <a:p>
-                      <a:pPr>
-                        <a:defRPr sz="1100">
-                          <a:solidFill>
-                            <a:srgbClr val="0F172A"/>
-                          </a:solidFill>
-                          <a:latin typeface="Arial"/>
-                        </a:defRPr>
-                      </a:pPr>
-                      <a:r>
-                        <a:t>Kịch bản 1: Bypass tổng quát</a:t>
-                      </a:r>
-                    </a:p>
-                  </a:txBody>
-                  <a:tcPr>
-                    <a:solidFill>
-                      <a:srgbClr val="F8FAFC"/>
-                    </a:solidFill>
-                  </a:tcPr>
-                </a:tc>
-                <a:tc>
-                  <a:txBody>
-                    <a:bodyPr/>
-                    <a:lstStyle/>
-                    <a:p>
-                      <a:pPr>
-                        <a:defRPr sz="1100" b="1">
-                          <a:solidFill>
-                            <a:srgbClr val="BE123C"/>
-                          </a:solidFill>
-                          <a:latin typeface="Courier New"/>
-                        </a:defRPr>
-                      </a:pPr>
-                      <a:r>
-                        <a:t>' OR '1'='1' --</a:t>
-                      </a:r>
-                    </a:p>
-                  </a:txBody>
-                  <a:tcPr>
-                    <a:solidFill>
-                      <a:srgbClr val="F8FAFC"/>
-                    </a:solidFill>
-                  </a:tcPr>
-                </a:tc>
-                <a:tc>
-                  <a:txBody>
-                    <a:bodyPr/>
-                    <a:lstStyle/>
-                    <a:p>
-                      <a:pPr>
-                        <a:defRPr sz="1100">
-                          <a:solidFill>
-                            <a:srgbClr val="334155"/>
-                          </a:solidFill>
-                          <a:latin typeface="Arial"/>
-                        </a:defRPr>
-                      </a:pPr>
-                      <a:r>
-                        <a:t>Nháy đơn (') đóng chuỗi; OR '1'='1' luôn đúng; '--' hủy vế kiểm tra mật khẩu.</a:t>
-                      </a:r>
-                    </a:p>
-                  </a:txBody>
-                  <a:tcPr>
-                    <a:solidFill>
-                      <a:srgbClr val="F8FAFC"/>
-                    </a:solidFill>
-                  </a:tcPr>
-                </a:tc>
-                <a:tc>
-                  <a:txBody>
-                    <a:bodyPr/>
-                    <a:lstStyle/>
-                    <a:p>
-                      <a:pPr>
-                        <a:defRPr sz="1100">
-                          <a:solidFill>
-                            <a:srgbClr val="334155"/>
-                          </a:solidFill>
-                          <a:latin typeface="Arial"/>
-                        </a:defRPr>
-                      </a:pPr>
-                      <a:r>
-                        <a:t>Bypass thành công, lấy tài khoản đầu tiên trong bảng (Admin).</a:t>
-                      </a:r>
-                    </a:p>
-                  </a:txBody>
-                  <a:tcPr>
-                    <a:solidFill>
-                      <a:srgbClr val="F8FAFC"/>
-                    </a:solidFill>
-                  </a:tcPr>
-                </a:tc>
-              </a:tr>
-              <a:tr h="1211580">
-                <a:tc>
-                  <a:txBody>
-                    <a:bodyPr/>
-                    <a:lstStyle/>
-                    <a:p>
-                      <a:pPr>
-                        <a:defRPr sz="1100">
-                          <a:solidFill>
-                            <a:srgbClr val="0F172A"/>
-                          </a:solidFill>
-                          <a:latin typeface="Arial"/>
-                        </a:defRPr>
-                      </a:pPr>
-                      <a:r>
-                        <a:t>Kịch bản 2: Nhắm đích danh Admin</a:t>
-                      </a:r>
-                    </a:p>
-                  </a:txBody>
-                  <a:tcPr>
-                    <a:solidFill>
-                      <a:srgbClr val="FFFFFF"/>
-                    </a:solidFill>
-                  </a:tcPr>
-                </a:tc>
-                <a:tc>
-                  <a:txBody>
-                    <a:bodyPr/>
-                    <a:lstStyle/>
-                    <a:p>
-                      <a:pPr>
-                        <a:defRPr sz="1100" b="1">
-                          <a:solidFill>
-                            <a:srgbClr val="BE123C"/>
-                          </a:solidFill>
-                          <a:latin typeface="Courier New"/>
-                        </a:defRPr>
-                      </a:pPr>
-                      <a:r>
-                        <a:t>admin' --</a:t>
-                      </a:r>
-                    </a:p>
-                  </a:txBody>
-                  <a:tcPr>
-                    <a:solidFill>
-                      <a:srgbClr val="FFFFFF"/>
-                    </a:solidFill>
-                  </a:tcPr>
-                </a:tc>
-                <a:tc>
-                  <a:txBody>
-                    <a:bodyPr/>
-                    <a:lstStyle/>
-                    <a:p>
-                      <a:pPr>
-                        <a:defRPr sz="1100">
-                          <a:solidFill>
-                            <a:srgbClr val="334155"/>
-                          </a:solidFill>
-                          <a:latin typeface="Arial"/>
-                        </a:defRPr>
-                      </a:pPr>
-                      <a:r>
-                        <a:t>Cố định Username = 'admin'; '--' hủy toàn bộ vế AND Password = ...</a:t>
-                      </a:r>
-                    </a:p>
-                  </a:txBody>
-                  <a:tcPr>
-                    <a:solidFill>
-                      <a:srgbClr val="FFFFFF"/>
-                    </a:solidFill>
-                  </a:tcPr>
-                </a:tc>
-                <a:tc>
-                  <a:txBody>
-                    <a:bodyPr/>
-                    <a:lstStyle/>
-                    <a:p>
-                      <a:pPr>
-                        <a:defRPr sz="1100">
-                          <a:solidFill>
-                            <a:srgbClr val="334155"/>
-                          </a:solidFill>
-                          <a:latin typeface="Arial"/>
-                        </a:defRPr>
-                      </a:pPr>
-                      <a:r>
-                        <a:t>Chiếm đoạt chính xác quyền Admin mà không cần biết mật khẩu.</a:t>
-                      </a:r>
-                    </a:p>
-                  </a:txBody>
-                  <a:tcPr>
-                    <a:solidFill>
-                      <a:srgbClr val="FFFFFF"/>
-                    </a:solidFill>
-                  </a:tcPr>
-                </a:tc>
-              </a:tr>
-              <a:tr h="1211580">
-                <a:tc>
-                  <a:txBody>
-                    <a:bodyPr/>
-                    <a:lstStyle/>
-                    <a:p>
-                      <a:pPr>
-                        <a:defRPr sz="1100">
-                          <a:solidFill>
-                            <a:srgbClr val="0F172A"/>
-                          </a:solidFill>
-                          <a:latin typeface="Arial"/>
-                        </a:defRPr>
-                      </a:pPr>
-                      <a:r>
-                        <a:t>Kịch bản chuẩn: Đăng nhập đúng</a:t>
-                      </a:r>
-                    </a:p>
-                  </a:txBody>
-                  <a:tcPr>
-                    <a:solidFill>
-                      <a:srgbClr val="F8FAFC"/>
-                    </a:solidFill>
-                  </a:tcPr>
-                </a:tc>
-                <a:tc>
-                  <a:txBody>
-                    <a:bodyPr/>
-                    <a:lstStyle/>
-                    <a:p>
-                      <a:pPr>
-                        <a:defRPr sz="1100" b="1">
-                          <a:solidFill>
-                            <a:srgbClr val="047857"/>
-                          </a:solidFill>
-                          <a:latin typeface="Courier New"/>
-                        </a:defRPr>
-                      </a:pPr>
-                      <a:r>
-                        <a:t>admin / AdminPassword@2026</a:t>
-                      </a:r>
-                    </a:p>
-                  </a:txBody>
-                  <a:tcPr>
-                    <a:solidFill>
-                      <a:srgbClr val="F8FAFC"/>
-                    </a:solidFill>
-                  </a:tcPr>
-                </a:tc>
-                <a:tc>
-                  <a:txBody>
-                    <a:bodyPr/>
-                    <a:lstStyle/>
-                    <a:p>
-                      <a:pPr>
-                        <a:defRPr sz="1100">
-                          <a:solidFill>
-                            <a:srgbClr val="334155"/>
-                          </a:solidFill>
-                          <a:latin typeface="Arial"/>
-                        </a:defRPr>
-                      </a:pPr>
-                      <a:r>
-                        <a:t>Dữ liệu hợp lệ, không chứa ký tự điều khiển hay can thiệp cú pháp.</a:t>
-                      </a:r>
-                    </a:p>
-                  </a:txBody>
-                  <a:tcPr>
-                    <a:solidFill>
-                      <a:srgbClr val="F8FAFC"/>
-                    </a:solidFill>
-                  </a:tcPr>
-                </a:tc>
-                <a:tc>
-                  <a:txBody>
-                    <a:bodyPr/>
-                    <a:lstStyle/>
-                    <a:p>
-                      <a:pPr>
-                        <a:defRPr sz="1100">
-                          <a:solidFill>
-                            <a:srgbClr val="334155"/>
-                          </a:solidFill>
-                          <a:latin typeface="Arial"/>
-                        </a:defRPr>
-                      </a:pPr>
-                      <a:r>
-                        <a:t>Đăng nhập thành công trên cả 2 nhánh (Lỗi &amp; Đã phòng thủ).</a:t>
-                      </a:r>
-                    </a:p>
-                  </a:txBody>
-                  <a:tcPr>
-                    <a:solidFill>
-                      <a:srgbClr val="F8FAFC"/>
-                    </a:solidFill>
-                  </a:tcPr>
-                </a:tc>
-              </a:tr>
-            </a:tbl>
-          </a:graphicData>
-        </a:graphic>
-      </p:graphicFrame>
+      <p:sp>
+        <p:nvSpPr>
+          <p:cNvPr id="6" name="Rounded Rectangle 5"/>
+          <p:cNvSpPr/>
+          <p:nvPr/>
+        </p:nvSpPr>
+        <p:spPr>
+          <a:xfrm>
+            <a:off x="731520" y="1280160"/>
+            <a:ext cx="10728655" cy="1463040"/>
+          </a:xfrm>
+          <a:prstGeom prst="roundRect">
+            <a:avLst/>
+          </a:prstGeom>
+          <a:solidFill>
+            <a:srgbClr val="FFF1F2"/>
+          </a:solidFill>
+          <a:ln>
+            <a:solidFill>
+              <a:srgbClr val="FECDD3"/>
+            </a:solidFill>
+          </a:ln>
+        </p:spPr>
+        <p:style>
+          <a:lnRef idx="1">
+            <a:schemeClr val="accent1"/>
+          </a:lnRef>
+          <a:fillRef idx="3">
+            <a:schemeClr val="accent1"/>
+          </a:fillRef>
+          <a:effectRef idx="2">
+            <a:schemeClr val="accent1"/>
+          </a:effectRef>
+          <a:fontRef idx="minor">
+            <a:schemeClr val="lt1"/>
+          </a:fontRef>
+        </p:style>
+        <p:txBody>
+          <a:bodyPr rtlCol="0" anchor="ctr"/>
+          <a:lstStyle/>
+          <a:p>
+            <a:pPr algn="ctr">
+              <a:defRPr sz="1300" b="1">
+                <a:solidFill>
+                  <a:srgbClr val="BE123C"/>
+                </a:solidFill>
+                <a:latin typeface="Arial"/>
+              </a:defRPr>
+            </a:pPr>
+            <a:r>
+              <a:t>01 — BYPASS ĐĂNG NHẬP TỔNG QUÁT: ' OR '1'='1' --</a:t>
+            </a:r>
+          </a:p>
+          <a:p>
+            <a:pPr>
+              <a:spcBef>
+                <a:spcPts val="400"/>
+              </a:spcBef>
+              <a:defRPr sz="1150" b="0">
+                <a:solidFill>
+                  <a:srgbClr val="334155"/>
+                </a:solidFill>
+                <a:latin typeface="Arial"/>
+              </a:defRPr>
+            </a:pPr>
+            <a:r>
+              <a:t>• Cơ chế: Dấu nháy đơn (') đóng chuỗi; mệnh đề OR '1'='1' luôn đúng cho mọi dòng; ký tự '--' vô hiệu hóa bước kiểm tra mật khẩu.</a:t>
+            </a:r>
+            <a:br/>
+            <a:r>
+              <a:t>• Kết quả thực tế: Vượt qua xác thực thành công, đăng nhập ngay vào tài khoản đầu tiên trong bảng (Admin).</a:t>
+            </a:r>
+          </a:p>
+        </p:txBody>
+      </p:sp>
+      <p:sp>
+        <p:nvSpPr>
+          <p:cNvPr id="7" name="Rounded Rectangle 6"/>
+          <p:cNvSpPr/>
+          <p:nvPr/>
+        </p:nvSpPr>
+        <p:spPr>
+          <a:xfrm>
+            <a:off x="731520" y="2926080"/>
+            <a:ext cx="10728655" cy="1463040"/>
+          </a:xfrm>
+          <a:prstGeom prst="roundRect">
+            <a:avLst/>
+          </a:prstGeom>
+          <a:solidFill>
+            <a:srgbClr val="FFFBEB"/>
+          </a:solidFill>
+          <a:ln>
+            <a:solidFill>
+              <a:srgbClr val="FEF08A"/>
+            </a:solidFill>
+          </a:ln>
+        </p:spPr>
+        <p:style>
+          <a:lnRef idx="1">
+            <a:schemeClr val="accent1"/>
+          </a:lnRef>
+          <a:fillRef idx="3">
+            <a:schemeClr val="accent1"/>
+          </a:fillRef>
+          <a:effectRef idx="2">
+            <a:schemeClr val="accent1"/>
+          </a:effectRef>
+          <a:fontRef idx="minor">
+            <a:schemeClr val="lt1"/>
+          </a:fontRef>
+        </p:style>
+        <p:txBody>
+          <a:bodyPr rtlCol="0" anchor="ctr"/>
+          <a:lstStyle/>
+          <a:p>
+            <a:pPr algn="ctr">
+              <a:defRPr sz="1300" b="1">
+                <a:solidFill>
+                  <a:srgbClr val="B45309"/>
+                </a:solidFill>
+                <a:latin typeface="Arial"/>
+              </a:defRPr>
+            </a:pPr>
+            <a:r>
+              <a:t>02 — TẤN CÔNG ĐÍCH DANH QUẢN TRỊ VIÊN: admin' --</a:t>
+            </a:r>
+          </a:p>
+          <a:p>
+            <a:pPr>
+              <a:spcBef>
+                <a:spcPts val="400"/>
+              </a:spcBef>
+              <a:defRPr sz="1150" b="0">
+                <a:solidFill>
+                  <a:srgbClr val="334155"/>
+                </a:solidFill>
+                <a:latin typeface="Arial"/>
+              </a:defRPr>
+            </a:pPr>
+            <a:r>
+              <a:t>• Cơ chế: Cố định Username = 'admin'; ký tự '--' cắt bỏ hoàn toàn mệnh đề 'AND Password = ...' phía sau.</a:t>
+            </a:r>
+            <a:br/>
+            <a:r>
+              <a:t>• Kết quả thực tế: Chiếm đoạt chính xác tài khoản Admin cấp cao nhất mà không cần nhập mật khẩu.</a:t>
+            </a:r>
+          </a:p>
+        </p:txBody>
+      </p:sp>
+      <p:sp>
+        <p:nvSpPr>
+          <p:cNvPr id="8" name="Rounded Rectangle 7"/>
+          <p:cNvSpPr/>
+          <p:nvPr/>
+        </p:nvSpPr>
+        <p:spPr>
+          <a:xfrm>
+            <a:off x="731520" y="4572000"/>
+            <a:ext cx="10728655" cy="1463040"/>
+          </a:xfrm>
+          <a:prstGeom prst="roundRect">
+            <a:avLst/>
+          </a:prstGeom>
+          <a:solidFill>
+            <a:srgbClr val="F8FAFC"/>
+          </a:solidFill>
+          <a:ln>
+            <a:solidFill>
+              <a:srgbClr val="E2E8F0"/>
+            </a:solidFill>
+          </a:ln>
+        </p:spPr>
+        <p:style>
+          <a:lnRef idx="1">
+            <a:schemeClr val="accent1"/>
+          </a:lnRef>
+          <a:fillRef idx="3">
+            <a:schemeClr val="accent1"/>
+          </a:fillRef>
+          <a:effectRef idx="2">
+            <a:schemeClr val="accent1"/>
+          </a:effectRef>
+          <a:fontRef idx="minor">
+            <a:schemeClr val="lt1"/>
+          </a:fontRef>
+        </p:style>
+        <p:txBody>
+          <a:bodyPr rtlCol="0" anchor="ctr"/>
+          <a:lstStyle/>
+          <a:p>
+            <a:pPr algn="ctr">
+              <a:defRPr sz="1300" b="1">
+                <a:solidFill>
+                  <a:srgbClr val="1D4ED8"/>
+                </a:solidFill>
+                <a:latin typeface="Arial"/>
+              </a:defRPr>
+            </a:pPr>
+            <a:r>
+              <a:t>03 — ĐĂNG NHẬP CHUẨN HỢP LỆ: admin / AdminPassword@2026</a:t>
+            </a:r>
+          </a:p>
+          <a:p>
+            <a:pPr>
+              <a:spcBef>
+                <a:spcPts val="400"/>
+              </a:spcBef>
+              <a:defRPr sz="1150" b="0">
+                <a:solidFill>
+                  <a:srgbClr val="334155"/>
+                </a:solidFill>
+                <a:latin typeface="Arial"/>
+              </a:defRPr>
+            </a:pPr>
+            <a:r>
+              <a:t>• Cơ chế: Dữ liệu người dùng bình thường, không chứa ký tự điều khiển hay can thiệp cú pháp.</a:t>
+            </a:r>
+            <a:br/>
+            <a:r>
+              <a:t>• Kết quả đối chứng: Đăng nhập thành công trên cả 2 nhánh (Lỗi &amp; An toàn), chứng minh hệ thống hoạt động đúng nghiệp vụ.</a:t>
+            </a:r>
+          </a:p>
+        </p:txBody>
+      </p:sp>
     </p:spTree>
   </p:cSld>
   <p:clrMapOvr>
@@ -8774,7 +8824,7 @@
               </a:defRPr>
             </a:pPr>
             <a:r>
-              <a:t>1.3. SQL Injection: Minh Chứng Thực Nghiệm Trực Quan Trên Web UI</a:t>
+              <a:t>1.3. SQL Injection — Minh Chứng Thực Nghiệm Trực Quan Trên Web UI</a:t>
             </a:r>
           </a:p>
         </p:txBody>
@@ -8870,7 +8920,7 @@
               </a:defRPr>
             </a:pPr>
             <a:r>
-              <a:t>Minh chứng đối chứng: Trích xuất 4 tài khoản CSDL khi inject ' OR '1'='1' -- (Trái) vs Chặn đứng an toàn với EF Core (Phải)</a:t>
+              <a:t>🔴 Vulnerable: Trích xuất 4 tài khoản CSDL khi inject ' OR '1'='1' --  vs  🟢 Secure: Chặn đứng an toàn với EF Core (0 kết quả)</a:t>
             </a:r>
           </a:p>
         </p:txBody>
@@ -9022,7 +9072,7 @@
               </a:defRPr>
             </a:pPr>
             <a:r>
-              <a:t>1.4. SQL Injection: Minh Chứng Gói Tin Mạng (Chrome DevTools Network)</a:t>
+              <a:t>1.4. SQL Injection — Minh Chứng Gói Tin Mạng (Chrome DevTools Network)</a:t>
             </a:r>
           </a:p>
         </p:txBody>
@@ -9270,7 +9320,7 @@
               </a:defRPr>
             </a:pPr>
             <a:r>
-              <a:t>1.5. SQL Injection: Cơ Chế Phòng Thủ Chuẩn Hóa</a:t>
+              <a:t>1.5. SQL Injection — Cơ Chế Phòng Thủ Chuẩn Hóa</a:t>
             </a:r>
           </a:p>
         </p:txBody>
@@ -9353,7 +9403,7 @@
           <a:lstStyle/>
           <a:p>
             <a:pPr algn="ctr">
-              <a:defRPr sz="1500" b="1">
+              <a:defRPr sz="1400" b="1">
                 <a:solidFill>
                   <a:srgbClr val="047857"/>
                 </a:solidFill>
@@ -9361,7 +9411,7 @@
               </a:defRPr>
             </a:pPr>
             <a:r>
-              <a:t>Phòng Thủ SQL Injection: Parameterized Query</a:t>
+              <a:t>🟢 SECURE CODE: PARAMETERIZED QUERY</a:t>
             </a:r>
           </a:p>
           <a:p>
@@ -9395,7 +9445,23 @@
           <a:p>
             <a:pPr>
               <a:spcBef>
-                <a:spcPts val="1200"/>
+                <a:spcPts val="1400"/>
+              </a:spcBef>
+              <a:defRPr sz="1250" b="1">
+                <a:solidFill>
+                  <a:srgbClr val="0F172A"/>
+                </a:solidFill>
+                <a:latin typeface="Arial"/>
+              </a:defRPr>
+            </a:pPr>
+            <a:r>
+              <a:t>Nguyên tắc cốt lõi: Data ≠ SQL Syntax</a:t>
+            </a:r>
+          </a:p>
+          <a:p>
+            <a:pPr>
+              <a:spcBef>
+                <a:spcPts val="600"/>
               </a:spcBef>
               <a:defRPr sz="1200" b="0">
                 <a:solidFill>
@@ -9405,19 +9471,11 @@
               </a:defRPr>
             </a:pPr>
             <a:r>
-              <a:t>Nguyên lý kỹ thuật:</a:t>
-            </a:r>
-            <a:br/>
-            <a:r>
-              <a:t>• Data ≠ SQL Syntax: Đầu vào người dùng được truyền qua tham số riêng biệt (@p0, @p1).</a:t>
-            </a:r>
-            <a:br/>
-            <a:r>
-              <a:t>• Máy chủ SQL Server biên dịch cấu trúc cây truy vấn (Execution Plan) TRƯỚC khi gán dữ liệu.</a:t>
-            </a:r>
-            <a:br/>
-            <a:r>
-              <a:t>• Toàn bộ chuỗi payload bị cô lập thành giá trị văn bản (literal), không thể can thiệp vào logic thực thi.</a:t>
+              <a:t>• Máy chủ SQL Server biên dịch cấu trúc cây truy vấn (Execution Plan) TRƯỚC khi nhận tham số.</a:t>
+            </a:r>
+            <a:br/>
+            <a:r>
+              <a:t>• Biến @p0, @p1 nhận toàn bộ payload như một giá trị văn bản (literal), vô hiệu hóa hoàn toàn ý đồ chèn lệnh.</a:t>
             </a:r>
           </a:p>
         </p:txBody>
@@ -9464,7 +9522,7 @@
           <a:lstStyle/>
           <a:p>
             <a:pPr algn="ctr">
-              <a:defRPr sz="1500" b="1">
+              <a:defRPr sz="1400" b="1">
                 <a:solidFill>
                   <a:srgbClr val="1D4ED8"/>
                 </a:solidFill>
@@ -9472,7 +9530,55 @@
               </a:defRPr>
             </a:pPr>
             <a:r>
-              <a:t>Bảo Vệ Mật Khẩu: Tách Biệt Với SQL Injection</a:t>
+              <a:t>BẢO VỆ MẬT KHẨU (TÁCH BIỆT LOGIC)</a:t>
+            </a:r>
+          </a:p>
+          <a:p>
+            <a:pPr>
+              <a:spcBef>
+                <a:spcPts val="800"/>
+              </a:spcBef>
+              <a:defRPr sz="1200" b="1">
+                <a:solidFill>
+                  <a:srgbClr val="0F172A"/>
+                </a:solidFill>
+                <a:latin typeface="Arial"/>
+              </a:defRPr>
+            </a:pPr>
+            <a:r>
+              <a:t>Phân định rõ ràng trong báo cáo bảo mật:</a:t>
+            </a:r>
+          </a:p>
+          <a:p>
+            <a:pPr>
+              <a:spcBef>
+                <a:spcPts val="600"/>
+              </a:spcBef>
+              <a:defRPr sz="1200" b="1">
+                <a:solidFill>
+                  <a:srgbClr val="047857"/>
+                </a:solidFill>
+                <a:latin typeface="Arial"/>
+              </a:defRPr>
+            </a:pPr>
+            <a:r>
+              <a:t>1. Phòng thủ SQL Injection: Dùng Parameterized Query / EF Core LINQ.</a:t>
+            </a:r>
+          </a:p>
+          <a:p>
+            <a:pPr>
+              <a:spcBef>
+                <a:spcPts val="800"/>
+              </a:spcBef>
+              <a:defRPr sz="1200" b="1">
+                <a:solidFill>
+                  <a:srgbClr val="1D4ED8"/>
+                </a:solidFill>
+                <a:latin typeface="Arial"/>
+              </a:defRPr>
+            </a:pPr>
+            <a:r>
+              <a:t>2. Bảo vệ mật khẩu (Defense-in-Depth): Dùng Password Hashing (ASP.NET Core Identity PBKDF2) kèm Salt ngẫu nhiên.</a:t>
             </a:r>
           </a:p>
           <a:p>
@@ -9488,44 +9594,7 @@
               </a:defRPr>
             </a:pPr>
             <a:r>
-              <a:t>Lưu ý logic bảo mật quan trọng:</a:t>
-            </a:r>
-            <a:br/>
-            <a:r>
-              <a:t>• Parameterized Query giải quyết triệt để lỗi SQL Injection.</a:t>
-            </a:r>
-            <a:br/>
-            <a:r>
-              <a:t>• Tuy nhiên, để bảo vệ mật khẩu người dùng phòng trường hợp CSDL bị rò rỉ, cần lớp phòng thủ bổ sung (Defense-in-Depth):</a:t>
-            </a:r>
-          </a:p>
-          <a:p>
-            <a:pPr>
-              <a:spcBef>
-                <a:spcPts val="800"/>
-              </a:spcBef>
-              <a:defRPr sz="1200" b="0">
-                <a:solidFill>
-                  <a:srgbClr val="334155"/>
-                </a:solidFill>
-                <a:latin typeface="Arial"/>
-              </a:defRPr>
-            </a:pPr>
-            <a:r>
-              <a:t>1. Password Hashing (ASP.NET Core Identity):</a:t>
-            </a:r>
-            <a:br/>
-            <a:r>
-              <a:t>   Băm mật khẩu 1 chiều bằng thuật toán an toàn (PBKDF2/BCrypt) kèm Salt, tuyệt đối không lưu mật khẩu dạng plain-text.</a:t>
-            </a:r>
-            <a:br/>
-            <a:br/>
-            <a:r>
-              <a:t>2. Phân quyền tối thiểu (Least Privilege):</a:t>
-            </a:r>
-            <a:br/>
-            <a:r>
-              <a:t>   Tài khoản kết nối CSDL của ứng dụng chỉ có quyền SELECT/INSERT/UPDATE trên các bảng nghiệp vụ, không dùng quyền sa/DDL.</a:t>
+              <a:t>3. Đặc quyền tối thiểu (Least Privilege): Ứng dụng chỉ được cấp quyền SELECT/INSERT/UPDATE trên bảng cần thiết, cấm quyền sa/DDL.</a:t>
             </a:r>
           </a:p>
         </p:txBody>
@@ -9677,7 +9746,7 @@
               </a:defRPr>
             </a:pPr>
             <a:r>
-              <a:t>2.1. Stored XSS: Bản Chất Kỹ Thuật &amp; Sơ Đồ Luồng</a:t>
+              <a:t>2.1. Stored XSS — Lỗi Phát Tán Như Thế Nào &amp; Nguyên Nhân Gốc</a:t>
             </a:r>
           </a:p>
         </p:txBody>
@@ -9784,7 +9853,7 @@
               </a:defRPr>
             </a:pPr>
             <a:r>
-              <a:t>Kẻ tấn công ➔ Nhập mã độc JavaScript vào form đánh giá</a:t>
+              <a:t>Attacker ➔ Nhập mã JavaScript vào Form đánh giá</a:t>
             </a:r>
           </a:p>
           <a:p>
@@ -9820,7 +9889,7 @@
               </a:defRPr>
             </a:pPr>
             <a:r>
-              <a:t>Web Server ➔ Lưu nguyên văn mã độc vào Database (dbo.Comments)</a:t>
+              <a:t>Web Server ➔ Lưu nguyên văn mã độc vào CSDL (dbo.Comments)</a:t>
             </a:r>
           </a:p>
           <a:p>
@@ -9856,7 +9925,7 @@
               </a:defRPr>
             </a:pPr>
             <a:r>
-              <a:t>Nạn nhân truy cập trang ➔ Trình duyệt tự động thực thi script độc hại</a:t>
+              <a:t>Victim Browser ➔ Tải trang, tự động biên dịch &amp; thực thi script</a:t>
             </a:r>
           </a:p>
           <a:p>
@@ -9873,11 +9942,11 @@
               </a:defRPr>
             </a:pPr>
             <a:r>
-              <a:t>Đặc điểm kỹ thuật:</a:t>
-            </a:r>
-            <a:br/>
-            <a:r>
-              <a:t>Stored XSS là dạng XSS lưu trữ: mã độc được lưu trên máy chủ CSDL và có thể được kích hoạt tự động mỗi khi người dùng khác truy cập trang nội dung bị nhiễm.</a:t>
+              <a:t>📌 ROOT CAUSE (Nguyên nhân cốt lõi):</a:t>
+            </a:r>
+            <a:br/>
+            <a:r>
+              <a:t>Dữ liệu người dùng không tin cậy được render trực tiếp ra trình duyệt mà không qua cơ chế mã hóa đầu ra (Output Encoding).</a:t>
             </a:r>
           </a:p>
         </p:txBody>
@@ -9924,7 +9993,7 @@
           <a:lstStyle/>
           <a:p>
             <a:pPr algn="ctr">
-              <a:defRPr sz="1500" b="1">
+              <a:defRPr sz="1400" b="1">
                 <a:solidFill>
                   <a:srgbClr val="BE123C"/>
                 </a:solidFill>
@@ -9932,7 +10001,7 @@
               </a:defRPr>
             </a:pPr>
             <a:r>
-              <a:t>Nguyên Nhân: Sự Lạm Dụng @@Html.Raw()</a:t>
+              <a:t>🔴 VULNERABLE: SỰ LẠM DỤNG @Html.Raw()</a:t>
             </a:r>
           </a:p>
           <a:p>
@@ -9948,7 +10017,7 @@
               </a:defRPr>
             </a:pPr>
             <a:r>
-              <a:t>// 1. CONTROLLER LƯU NGUYÊN VĂN NỘI DUNG VÀO CSDL:</a:t>
+              <a:t>// CONTROLLER LƯU NGUYÊN VĂN NỘI DUNG VÀO CSDL:</a:t>
             </a:r>
             <a:br/>
             <a:r>
@@ -9973,7 +10042,7 @@
             <a:br/>
             <a:br/>
             <a:r>
-              <a:t>// 2. RAZOR VIEW HIỂN THỊ DỮ LIỆU THÔ BẰNG HTML.RAW:</a:t>
+              <a:t>// RAZOR VIEW HIỂN THỊ DỮ LIỆU THÔ BẰNG HTML.RAW:</a:t>
             </a:r>
             <a:br/>
             <a:r>
@@ -10005,7 +10074,7 @@
             </a:r>
             <a:br/>
             <a:r>
-              <a:t>@Html.Raw() vô hiệu hóa hoàn toàn cơ chế mã hóa HTML tự động của Razor Engine, ép trình duyệt phải biên dịch và thực thi chuỗi dữ liệu như mã lệnh.</a:t>
+              <a:t>@Html.Raw() vô hiệu hóa tính năng tự động mã hóa HTML của Razor View, mở toang cửa cho script độc hại chạy trên máy người dùng.</a:t>
             </a:r>
           </a:p>
         </p:txBody>
@@ -10157,7 +10226,7 @@
               </a:defRPr>
             </a:pPr>
             <a:r>
-              <a:t>2.2. Stored XSS: 3 Kịch Bản Tiêm Mã Độc Thực Nghiệm</a:t>
+              <a:t>2.2. Stored XSS — 3 Kịch Bản Tiêm Mã Độc Thực Nghiệm</a:t>
             </a:r>
           </a:p>
         </p:txBody>
@@ -10198,426 +10267,231 @@
           </a:p>
         </p:txBody>
       </p:sp>
-      <p:graphicFrame>
-        <p:nvGraphicFramePr>
-          <p:cNvPr id="6" name="Table 5"/>
-          <p:cNvGraphicFramePr>
-            <a:graphicFrameLocks noGrp="1"/>
-          </p:cNvGraphicFramePr>
-          <p:nvPr/>
-        </p:nvGraphicFramePr>
-        <p:xfrm>
-          <a:off x="731520" y="1280160"/>
-          <a:ext cx="10728655" cy="4846320"/>
-        </p:xfrm>
-        <a:graphic>
-          <a:graphicData uri="http://schemas.openxmlformats.org/drawingml/2006/table">
-            <a:tbl>
-              <a:tblPr firstRow="1" bandRow="1">
-                <a:tableStyleId>{5C22544A-7EE6-4342-B048-85BDC9FD1C3A}</a:tableStyleId>
-              </a:tblPr>
-              <a:tblGrid>
-                <a:gridCol w="2682163"/>
-                <a:gridCol w="2682163"/>
-                <a:gridCol w="2682163"/>
-                <a:gridCol w="2682166"/>
-              </a:tblGrid>
-              <a:tr h="1211580">
-                <a:tc>
-                  <a:txBody>
-                    <a:bodyPr/>
-                    <a:lstStyle/>
-                    <a:p>
-                      <a:pPr>
-                        <a:defRPr b="1" sz="1100">
-                          <a:solidFill>
-                            <a:srgbClr val="FFFFFF"/>
-                          </a:solidFill>
-                          <a:latin typeface="Arial"/>
-                        </a:defRPr>
-                      </a:pPr>
-                      <a:r>
-                        <a:t>Kịch bản kiểm thử</a:t>
-                      </a:r>
-                    </a:p>
-                  </a:txBody>
-                  <a:tcPr>
-                    <a:solidFill>
-                      <a:srgbClr val="BE123C"/>
-                    </a:solidFill>
-                  </a:tcPr>
-                </a:tc>
-                <a:tc>
-                  <a:txBody>
-                    <a:bodyPr/>
-                    <a:lstStyle/>
-                    <a:p>
-                      <a:pPr>
-                        <a:defRPr b="1" sz="1100">
-                          <a:solidFill>
-                            <a:srgbClr val="FFFFFF"/>
-                          </a:solidFill>
-                          <a:latin typeface="Arial"/>
-                        </a:defRPr>
-                      </a:pPr>
-                      <a:r>
-                        <a:t>Mã độc Payload đưa vào</a:t>
-                      </a:r>
-                    </a:p>
-                  </a:txBody>
-                  <a:tcPr>
-                    <a:solidFill>
-                      <a:srgbClr val="BE123C"/>
-                    </a:solidFill>
-                  </a:tcPr>
-                </a:tc>
-                <a:tc>
-                  <a:txBody>
-                    <a:bodyPr/>
-                    <a:lstStyle/>
-                    <a:p>
-                      <a:pPr>
-                        <a:defRPr b="1" sz="1100">
-                          <a:solidFill>
-                            <a:srgbClr val="FFFFFF"/>
-                          </a:solidFill>
-                          <a:latin typeface="Arial"/>
-                        </a:defRPr>
-                      </a:pPr>
-                      <a:r>
-                        <a:t>Cơ chế kích hoạt trên Trình duyệt</a:t>
-                      </a:r>
-                    </a:p>
-                  </a:txBody>
-                  <a:tcPr>
-                    <a:solidFill>
-                      <a:srgbClr val="BE123C"/>
-                    </a:solidFill>
-                  </a:tcPr>
-                </a:tc>
-                <a:tc>
-                  <a:txBody>
-                    <a:bodyPr/>
-                    <a:lstStyle/>
-                    <a:p>
-                      <a:pPr>
-                        <a:defRPr b="1" sz="1100">
-                          <a:solidFill>
-                            <a:srgbClr val="FFFFFF"/>
-                          </a:solidFill>
-                          <a:latin typeface="Arial"/>
-                        </a:defRPr>
-                      </a:pPr>
-                      <a:r>
-                        <a:t>Mục tiêu khai thác</a:t>
-                      </a:r>
-                    </a:p>
-                  </a:txBody>
-                  <a:tcPr>
-                    <a:solidFill>
-                      <a:srgbClr val="BE123C"/>
-                    </a:solidFill>
-                  </a:tcPr>
-                </a:tc>
-              </a:tr>
-              <a:tr h="1211580">
-                <a:tc>
-                  <a:txBody>
-                    <a:bodyPr/>
-                    <a:lstStyle/>
-                    <a:p>
-                      <a:pPr>
-                        <a:defRPr sz="1100">
-                          <a:solidFill>
-                            <a:srgbClr val="0F172A"/>
-                          </a:solidFill>
-                          <a:latin typeface="Arial"/>
-                        </a:defRPr>
-                      </a:pPr>
-                      <a:r>
-                        <a:t>Kịch bản 1: Đánh cắp Cookie</a:t>
-                      </a:r>
-                    </a:p>
-                  </a:txBody>
-                  <a:tcPr>
-                    <a:solidFill>
-                      <a:srgbClr val="F8FAFC"/>
-                    </a:solidFill>
-                  </a:tcPr>
-                </a:tc>
-                <a:tc>
-                  <a:txBody>
-                    <a:bodyPr/>
-                    <a:lstStyle/>
-                    <a:p>
-                      <a:pPr>
-                        <a:defRPr sz="1100" b="1">
-                          <a:solidFill>
-                            <a:srgbClr val="BE123C"/>
-                          </a:solidFill>
-                          <a:latin typeface="Courier New"/>
-                        </a:defRPr>
-                      </a:pPr>
-                      <a:r>
-                        <a:t>&lt;script&gt;alert(document.cookie);&lt;/script&gt;</a:t>
-                      </a:r>
-                    </a:p>
-                  </a:txBody>
-                  <a:tcPr>
-                    <a:solidFill>
-                      <a:srgbClr val="F8FAFC"/>
-                    </a:solidFill>
-                  </a:tcPr>
-                </a:tc>
-                <a:tc>
-                  <a:txBody>
-                    <a:bodyPr/>
-                    <a:lstStyle/>
-                    <a:p>
-                      <a:pPr>
-                        <a:defRPr sz="1100">
-                          <a:solidFill>
-                            <a:srgbClr val="334155"/>
-                          </a:solidFill>
-                          <a:latin typeface="Arial"/>
-                        </a:defRPr>
-                      </a:pPr>
-                      <a:r>
-                        <a:t>Trình duyệt thực thi thẻ &lt;script&gt; và đọc toàn bộ giá trị lưu trong document.cookie.</a:t>
-                      </a:r>
-                    </a:p>
-                  </a:txBody>
-                  <a:tcPr>
-                    <a:solidFill>
-                      <a:srgbClr val="F8FAFC"/>
-                    </a:solidFill>
-                  </a:tcPr>
-                </a:tc>
-                <a:tc>
-                  <a:txBody>
-                    <a:bodyPr/>
-                    <a:lstStyle/>
-                    <a:p>
-                      <a:pPr>
-                        <a:defRPr sz="1100">
-                          <a:solidFill>
-                            <a:srgbClr val="334155"/>
-                          </a:solidFill>
-                          <a:latin typeface="Arial"/>
-                        </a:defRPr>
-                      </a:pPr>
-                      <a:r>
-                        <a:t>Chiếm đoạt Session Token (Cookie Stealing) để mạo danh phiên làm việc.</a:t>
-                      </a:r>
-                    </a:p>
-                  </a:txBody>
-                  <a:tcPr>
-                    <a:solidFill>
-                      <a:srgbClr val="F8FAFC"/>
-                    </a:solidFill>
-                  </a:tcPr>
-                </a:tc>
-              </a:tr>
-              <a:tr h="1211580">
-                <a:tc>
-                  <a:txBody>
-                    <a:bodyPr/>
-                    <a:lstStyle/>
-                    <a:p>
-                      <a:pPr>
-                        <a:defRPr sz="1100">
-                          <a:solidFill>
-                            <a:srgbClr val="0F172A"/>
-                          </a:solidFill>
-                          <a:latin typeface="Arial"/>
-                        </a:defRPr>
-                      </a:pPr>
-                      <a:r>
-                        <a:t>Kịch bản 2: Bypass qua thẻ &lt;img&gt;</a:t>
-                      </a:r>
-                    </a:p>
-                  </a:txBody>
-                  <a:tcPr>
-                    <a:solidFill>
-                      <a:srgbClr val="FFFFFF"/>
-                    </a:solidFill>
-                  </a:tcPr>
-                </a:tc>
-                <a:tc>
-                  <a:txBody>
-                    <a:bodyPr/>
-                    <a:lstStyle/>
-                    <a:p>
-                      <a:pPr>
-                        <a:defRPr sz="1100" b="1">
-                          <a:solidFill>
-                            <a:srgbClr val="BE123C"/>
-                          </a:solidFill>
-                          <a:latin typeface="Courier New"/>
-                        </a:defRPr>
-                      </a:pPr>
-                      <a:r>
-                        <a:t>&lt;img src=x onerror=alert('XSS!')&gt;</a:t>
-                      </a:r>
-                    </a:p>
-                  </a:txBody>
-                  <a:tcPr>
-                    <a:solidFill>
-                      <a:srgbClr val="FFFFFF"/>
-                    </a:solidFill>
-                  </a:tcPr>
-                </a:tc>
-                <a:tc>
-                  <a:txBody>
-                    <a:bodyPr/>
-                    <a:lstStyle/>
-                    <a:p>
-                      <a:pPr>
-                        <a:defRPr sz="1100">
-                          <a:solidFill>
-                            <a:srgbClr val="334155"/>
-                          </a:solidFill>
-                          <a:latin typeface="Arial"/>
-                        </a:defRPr>
-                      </a:pPr>
-                      <a:r>
-                        <a:t>Khi đường dẫn ảnh bị lỗi (src=x), trình duyệt lập tức kích hoạt sự kiện onerror.</a:t>
-                      </a:r>
-                    </a:p>
-                  </a:txBody>
-                  <a:tcPr>
-                    <a:solidFill>
-                      <a:srgbClr val="FFFFFF"/>
-                    </a:solidFill>
-                  </a:tcPr>
-                </a:tc>
-                <a:tc>
-                  <a:txBody>
-                    <a:bodyPr/>
-                    <a:lstStyle/>
-                    <a:p>
-                      <a:pPr>
-                        <a:defRPr sz="1100">
-                          <a:solidFill>
-                            <a:srgbClr val="334155"/>
-                          </a:solidFill>
-                          <a:latin typeface="Arial"/>
-                        </a:defRPr>
-                      </a:pPr>
-                      <a:r>
-                        <a:t>Vượt qua các bộ lọc từ khóa đơn giản chỉ chặn chuỗi '&lt;script&gt;'.</a:t>
-                      </a:r>
-                    </a:p>
-                  </a:txBody>
-                  <a:tcPr>
-                    <a:solidFill>
-                      <a:srgbClr val="FFFFFF"/>
-                    </a:solidFill>
-                  </a:tcPr>
-                </a:tc>
-              </a:tr>
-              <a:tr h="1211580">
-                <a:tc>
-                  <a:txBody>
-                    <a:bodyPr/>
-                    <a:lstStyle/>
-                    <a:p>
-                      <a:pPr>
-                        <a:defRPr sz="1100">
-                          <a:solidFill>
-                            <a:srgbClr val="0F172A"/>
-                          </a:solidFill>
-                          <a:latin typeface="Arial"/>
-                        </a:defRPr>
-                      </a:pPr>
-                      <a:r>
-                        <a:t>Kịch bản chuẩn: Đánh giá hợp lệ</a:t>
-                      </a:r>
-                    </a:p>
-                  </a:txBody>
-                  <a:tcPr>
-                    <a:solidFill>
-                      <a:srgbClr val="F8FAFC"/>
-                    </a:solidFill>
-                  </a:tcPr>
-                </a:tc>
-                <a:tc>
-                  <a:txBody>
-                    <a:bodyPr/>
-                    <a:lstStyle/>
-                    <a:p>
-                      <a:pPr>
-                        <a:defRPr sz="1100" b="1">
-                          <a:solidFill>
-                            <a:srgbClr val="047857"/>
-                          </a:solidFill>
-                          <a:latin typeface="Courier New"/>
-                        </a:defRPr>
-                      </a:pPr>
-                      <a:r>
-                        <a:t>Dịch vụ tư vấn rất chuyên nghiệp, 5 sao!</a:t>
-                      </a:r>
-                    </a:p>
-                  </a:txBody>
-                  <a:tcPr>
-                    <a:solidFill>
-                      <a:srgbClr val="F8FAFC"/>
-                    </a:solidFill>
-                  </a:tcPr>
-                </a:tc>
-                <a:tc>
-                  <a:txBody>
-                    <a:bodyPr/>
-                    <a:lstStyle/>
-                    <a:p>
-                      <a:pPr>
-                        <a:defRPr sz="1100">
-                          <a:solidFill>
-                            <a:srgbClr val="334155"/>
-                          </a:solidFill>
-                          <a:latin typeface="Arial"/>
-                        </a:defRPr>
-                      </a:pPr>
-                      <a:r>
-                        <a:t>Văn bản thuần túy không chứa thẻ HTML hay kịch bản đặc biệt.</a:t>
-                      </a:r>
-                    </a:p>
-                  </a:txBody>
-                  <a:tcPr>
-                    <a:solidFill>
-                      <a:srgbClr val="F8FAFC"/>
-                    </a:solidFill>
-                  </a:tcPr>
-                </a:tc>
-                <a:tc>
-                  <a:txBody>
-                    <a:bodyPr/>
-                    <a:lstStyle/>
-                    <a:p>
-                      <a:pPr>
-                        <a:defRPr sz="1100">
-                          <a:solidFill>
-                            <a:srgbClr val="334155"/>
-                          </a:solidFill>
-                          <a:latin typeface="Arial"/>
-                        </a:defRPr>
-                      </a:pPr>
-                      <a:r>
-                        <a:t>Hiển thị bình thường trên cả 2 nhánh (Lỗi &amp; Đã phòng thủ).</a:t>
-                      </a:r>
-                    </a:p>
-                  </a:txBody>
-                  <a:tcPr>
-                    <a:solidFill>
-                      <a:srgbClr val="F8FAFC"/>
-                    </a:solidFill>
-                  </a:tcPr>
-                </a:tc>
-              </a:tr>
-            </a:tbl>
-          </a:graphicData>
-        </a:graphic>
-      </p:graphicFrame>
+      <p:sp>
+        <p:nvSpPr>
+          <p:cNvPr id="6" name="Rounded Rectangle 5"/>
+          <p:cNvSpPr/>
+          <p:nvPr/>
+        </p:nvSpPr>
+        <p:spPr>
+          <a:xfrm>
+            <a:off x="731520" y="1280160"/>
+            <a:ext cx="10728655" cy="1463040"/>
+          </a:xfrm>
+          <a:prstGeom prst="roundRect">
+            <a:avLst/>
+          </a:prstGeom>
+          <a:solidFill>
+            <a:srgbClr val="FFF1F2"/>
+          </a:solidFill>
+          <a:ln>
+            <a:solidFill>
+              <a:srgbClr val="FECDD3"/>
+            </a:solidFill>
+          </a:ln>
+        </p:spPr>
+        <p:style>
+          <a:lnRef idx="1">
+            <a:schemeClr val="accent1"/>
+          </a:lnRef>
+          <a:fillRef idx="3">
+            <a:schemeClr val="accent1"/>
+          </a:fillRef>
+          <a:effectRef idx="2">
+            <a:schemeClr val="accent1"/>
+          </a:effectRef>
+          <a:fontRef idx="minor">
+            <a:schemeClr val="lt1"/>
+          </a:fontRef>
+        </p:style>
+        <p:txBody>
+          <a:bodyPr rtlCol="0" anchor="ctr"/>
+          <a:lstStyle/>
+          <a:p>
+            <a:pPr algn="ctr">
+              <a:defRPr sz="1300" b="1">
+                <a:solidFill>
+                  <a:srgbClr val="BE123C"/>
+                </a:solidFill>
+                <a:latin typeface="Arial"/>
+              </a:defRPr>
+            </a:pPr>
+            <a:r>
+              <a:t>01 — ĐÁNH CẮP COOKIE / SESSION: &lt;script&gt;alert(document.cookie);&lt;/script&gt;</a:t>
+            </a:r>
+          </a:p>
+          <a:p>
+            <a:pPr>
+              <a:spcBef>
+                <a:spcPts val="400"/>
+              </a:spcBef>
+              <a:defRPr sz="1150" b="0">
+                <a:solidFill>
+                  <a:srgbClr val="334155"/>
+                </a:solidFill>
+                <a:latin typeface="Arial"/>
+              </a:defRPr>
+            </a:pPr>
+            <a:r>
+              <a:t>• Cơ chế: Trình duyệt thực thi thẻ &lt;script&gt; và đọc toàn bộ giá trị lưu trong thuộc tính document.cookie.</a:t>
+            </a:r>
+            <a:br/>
+            <a:r>
+              <a:t>• Hậu quả: Hacker chiếm đoạt Session Token (Cookie Stealing) để đăng nhập mạo danh người dùng hợp lệ.</a:t>
+            </a:r>
+          </a:p>
+        </p:txBody>
+      </p:sp>
+      <p:sp>
+        <p:nvSpPr>
+          <p:cNvPr id="7" name="Rounded Rectangle 6"/>
+          <p:cNvSpPr/>
+          <p:nvPr/>
+        </p:nvSpPr>
+        <p:spPr>
+          <a:xfrm>
+            <a:off x="731520" y="2926080"/>
+            <a:ext cx="10728655" cy="1463040"/>
+          </a:xfrm>
+          <a:prstGeom prst="roundRect">
+            <a:avLst/>
+          </a:prstGeom>
+          <a:solidFill>
+            <a:srgbClr val="FFFBEB"/>
+          </a:solidFill>
+          <a:ln>
+            <a:solidFill>
+              <a:srgbClr val="FEF08A"/>
+            </a:solidFill>
+          </a:ln>
+        </p:spPr>
+        <p:style>
+          <a:lnRef idx="1">
+            <a:schemeClr val="accent1"/>
+          </a:lnRef>
+          <a:fillRef idx="3">
+            <a:schemeClr val="accent1"/>
+          </a:fillRef>
+          <a:effectRef idx="2">
+            <a:schemeClr val="accent1"/>
+          </a:effectRef>
+          <a:fontRef idx="minor">
+            <a:schemeClr val="lt1"/>
+          </a:fontRef>
+        </p:style>
+        <p:txBody>
+          <a:bodyPr rtlCol="0" anchor="ctr"/>
+          <a:lstStyle/>
+          <a:p>
+            <a:pPr algn="ctr">
+              <a:defRPr sz="1300" b="1">
+                <a:solidFill>
+                  <a:srgbClr val="B45309"/>
+                </a:solidFill>
+                <a:latin typeface="Arial"/>
+              </a:defRPr>
+            </a:pPr>
+            <a:r>
+              <a:t>02 — BYPASS BỘ LỌC QUA EVENT HANDLER: &lt;img src=x onerror=alert('XSS!')&gt;</a:t>
+            </a:r>
+          </a:p>
+          <a:p>
+            <a:pPr>
+              <a:spcBef>
+                <a:spcPts val="400"/>
+              </a:spcBef>
+              <a:defRPr sz="1150" b="0">
+                <a:solidFill>
+                  <a:srgbClr val="334155"/>
+                </a:solidFill>
+                <a:latin typeface="Arial"/>
+              </a:defRPr>
+            </a:pPr>
+            <a:r>
+              <a:t>• Cơ chế: Khi đường dẫn ảnh bị lỗi (src=x), trình duyệt lập tức kích hoạt sự kiện onerror để chạy mã JavaScript.</a:t>
+            </a:r>
+            <a:br/>
+            <a:r>
+              <a:t>• Mục tiêu: Vượt qua các bộ lọc từ khóa đơn giản chỉ chặn chuỗi '&lt;script&gt;'.</a:t>
+            </a:r>
+          </a:p>
+        </p:txBody>
+      </p:sp>
+      <p:sp>
+        <p:nvSpPr>
+          <p:cNvPr id="8" name="Rounded Rectangle 7"/>
+          <p:cNvSpPr/>
+          <p:nvPr/>
+        </p:nvSpPr>
+        <p:spPr>
+          <a:xfrm>
+            <a:off x="731520" y="4572000"/>
+            <a:ext cx="10728655" cy="1463040"/>
+          </a:xfrm>
+          <a:prstGeom prst="roundRect">
+            <a:avLst/>
+          </a:prstGeom>
+          <a:solidFill>
+            <a:srgbClr val="F8FAFC"/>
+          </a:solidFill>
+          <a:ln>
+            <a:solidFill>
+              <a:srgbClr val="E2E8F0"/>
+            </a:solidFill>
+          </a:ln>
+        </p:spPr>
+        <p:style>
+          <a:lnRef idx="1">
+            <a:schemeClr val="accent1"/>
+          </a:lnRef>
+          <a:fillRef idx="3">
+            <a:schemeClr val="accent1"/>
+          </a:fillRef>
+          <a:effectRef idx="2">
+            <a:schemeClr val="accent1"/>
+          </a:effectRef>
+          <a:fontRef idx="minor">
+            <a:schemeClr val="lt1"/>
+          </a:fontRef>
+        </p:style>
+        <p:txBody>
+          <a:bodyPr rtlCol="0" anchor="ctr"/>
+          <a:lstStyle/>
+          <a:p>
+            <a:pPr algn="ctr">
+              <a:defRPr sz="1300" b="1">
+                <a:solidFill>
+                  <a:srgbClr val="1D4ED8"/>
+                </a:solidFill>
+                <a:latin typeface="Arial"/>
+              </a:defRPr>
+            </a:pPr>
+            <a:r>
+              <a:t>03 — ĐÁNH GIÁ CHUẨN HỢP LỆ: Dịch vụ tư vấn rất chuyên nghiệp, 5 sao!</a:t>
+            </a:r>
+          </a:p>
+          <a:p>
+            <a:pPr>
+              <a:spcBef>
+                <a:spcPts val="400"/>
+              </a:spcBef>
+              <a:defRPr sz="1150" b="0">
+                <a:solidFill>
+                  <a:srgbClr val="334155"/>
+                </a:solidFill>
+                <a:latin typeface="Arial"/>
+              </a:defRPr>
+            </a:pPr>
+            <a:r>
+              <a:t>• Cơ chế: Văn bản thuần túy không chứa thẻ HTML hay kịch bản đặc biệt.</a:t>
+            </a:r>
+            <a:br/>
+            <a:r>
+              <a:t>• Kết quả đối chứng: Hiển thị an toàn trên cả 2 nhánh (Lỗi &amp; Đã phòng thủ).</a:t>
+            </a:r>
+          </a:p>
+        </p:txBody>
+      </p:sp>
     </p:spTree>
   </p:cSld>
   <p:clrMapOvr>

</xml_diff>